<commit_message>
Created new images for index page
</commit_message>
<xml_diff>
--- a/src/main/webapp/images/images.pptx
+++ b/src/main/webapp/images/images.pptx
@@ -4,8 +4,12 @@
   <p:sldMasterIdLst>
     <p:sldMasterId id="2147483648" r:id="rId1"/>
   </p:sldMasterIdLst>
+  <p:notesMasterIdLst>
+    <p:notesMasterId r:id="rId4"/>
+  </p:notesMasterIdLst>
   <p:sldIdLst>
-    <p:sldId id="256" r:id="rId2"/>
+    <p:sldId id="257" r:id="rId2"/>
+    <p:sldId id="258" r:id="rId3"/>
   </p:sldIdLst>
   <p:sldSz cx="12192000" cy="6858000"/>
   <p:notesSz cx="6858000" cy="9144000"/>
@@ -104,6 +108,11 @@
       </a:defRPr>
     </a:lvl9pPr>
   </p:defaultTextStyle>
+  <p:extLst>
+    <p:ext uri="{EFAFB233-063F-42B5-8137-9DF3F51BA10A}">
+      <p15:sldGuideLst xmlns:p15="http://schemas.microsoft.com/office/powerpoint/2012/main"/>
+    </p:ext>
+  </p:extLst>
 </p:presentation>
 </file>
 
@@ -236,6 +245,439 @@
     </pc:docChg>
   </pc:docChgLst>
 </pc:chgInfo>
+</file>
+
+<file path=ppt/notesMasters/notesMaster1.xml><?xml version="1.0" encoding="utf-8"?>
+<p:notesMaster xmlns:a="http://schemas.openxmlformats.org/drawingml/2006/main" xmlns:r="http://schemas.openxmlformats.org/officeDocument/2006/relationships" xmlns:p="http://schemas.openxmlformats.org/presentationml/2006/main">
+  <p:cSld>
+    <p:bg>
+      <p:bgRef idx="1001">
+        <a:schemeClr val="bg1"/>
+      </p:bgRef>
+    </p:bg>
+    <p:spTree>
+      <p:nvGrpSpPr>
+        <p:cNvPr id="1" name=""/>
+        <p:cNvGrpSpPr/>
+        <p:nvPr/>
+      </p:nvGrpSpPr>
+      <p:grpSpPr>
+        <a:xfrm>
+          <a:off x="0" y="0"/>
+          <a:ext cx="0" cy="0"/>
+          <a:chOff x="0" y="0"/>
+          <a:chExt cx="0" cy="0"/>
+        </a:xfrm>
+      </p:grpSpPr>
+      <p:sp>
+        <p:nvSpPr>
+          <p:cNvPr id="2" name="Header Placeholder 1"/>
+          <p:cNvSpPr>
+            <a:spLocks noGrp="1"/>
+          </p:cNvSpPr>
+          <p:nvPr>
+            <p:ph type="hdr" sz="quarter"/>
+          </p:nvPr>
+        </p:nvSpPr>
+        <p:spPr>
+          <a:xfrm>
+            <a:off x="0" y="0"/>
+            <a:ext cx="2971800" cy="458788"/>
+          </a:xfrm>
+          <a:prstGeom prst="rect">
+            <a:avLst/>
+          </a:prstGeom>
+        </p:spPr>
+        <p:txBody>
+          <a:bodyPr vert="horz" lIns="91440" tIns="45720" rIns="91440" bIns="45720" rtlCol="0"/>
+          <a:lstStyle>
+            <a:lvl1pPr algn="l">
+              <a:defRPr sz="1200"/>
+            </a:lvl1pPr>
+          </a:lstStyle>
+          <a:p>
+            <a:endParaRPr lang="en-US"/>
+          </a:p>
+        </p:txBody>
+      </p:sp>
+      <p:sp>
+        <p:nvSpPr>
+          <p:cNvPr id="3" name="Date Placeholder 2"/>
+          <p:cNvSpPr>
+            <a:spLocks noGrp="1"/>
+          </p:cNvSpPr>
+          <p:nvPr>
+            <p:ph type="dt" idx="1"/>
+          </p:nvPr>
+        </p:nvSpPr>
+        <p:spPr>
+          <a:xfrm>
+            <a:off x="3884613" y="0"/>
+            <a:ext cx="2971800" cy="458788"/>
+          </a:xfrm>
+          <a:prstGeom prst="rect">
+            <a:avLst/>
+          </a:prstGeom>
+        </p:spPr>
+        <p:txBody>
+          <a:bodyPr vert="horz" lIns="91440" tIns="45720" rIns="91440" bIns="45720" rtlCol="0"/>
+          <a:lstStyle>
+            <a:lvl1pPr algn="r">
+              <a:defRPr sz="1200"/>
+            </a:lvl1pPr>
+          </a:lstStyle>
+          <a:p>
+            <a:fld id="{2C805E82-58EB-422E-864A-536C3BC092C4}" type="datetimeFigureOut">
+              <a:rPr lang="en-US" smtClean="0"/>
+              <a:t>8/28/2025</a:t>
+            </a:fld>
+            <a:endParaRPr lang="en-US"/>
+          </a:p>
+        </p:txBody>
+      </p:sp>
+      <p:sp>
+        <p:nvSpPr>
+          <p:cNvPr id="4" name="Slide Image Placeholder 3"/>
+          <p:cNvSpPr>
+            <a:spLocks noGrp="1" noRot="1" noChangeAspect="1"/>
+          </p:cNvSpPr>
+          <p:nvPr>
+            <p:ph type="sldImg" idx="2"/>
+          </p:nvPr>
+        </p:nvSpPr>
+        <p:spPr>
+          <a:xfrm>
+            <a:off x="685800" y="1143000"/>
+            <a:ext cx="5486400" cy="3086100"/>
+          </a:xfrm>
+          <a:prstGeom prst="rect">
+            <a:avLst/>
+          </a:prstGeom>
+          <a:noFill/>
+          <a:ln w="12700">
+            <a:solidFill>
+              <a:prstClr val="black"/>
+            </a:solidFill>
+          </a:ln>
+        </p:spPr>
+        <p:txBody>
+          <a:bodyPr vert="horz" lIns="91440" tIns="45720" rIns="91440" bIns="45720" rtlCol="0" anchor="ctr"/>
+          <a:lstStyle/>
+          <a:p>
+            <a:endParaRPr lang="en-US"/>
+          </a:p>
+        </p:txBody>
+      </p:sp>
+      <p:sp>
+        <p:nvSpPr>
+          <p:cNvPr id="5" name="Notes Placeholder 4"/>
+          <p:cNvSpPr>
+            <a:spLocks noGrp="1"/>
+          </p:cNvSpPr>
+          <p:nvPr>
+            <p:ph type="body" sz="quarter" idx="3"/>
+          </p:nvPr>
+        </p:nvSpPr>
+        <p:spPr>
+          <a:xfrm>
+            <a:off x="685800" y="4400550"/>
+            <a:ext cx="5486400" cy="3600450"/>
+          </a:xfrm>
+          <a:prstGeom prst="rect">
+            <a:avLst/>
+          </a:prstGeom>
+        </p:spPr>
+        <p:txBody>
+          <a:bodyPr vert="horz" lIns="91440" tIns="45720" rIns="91440" bIns="45720" rtlCol="0"/>
+          <a:lstStyle/>
+          <a:p>
+            <a:pPr lvl="0"/>
+            <a:r>
+              <a:rPr lang="en-US"/>
+              <a:t>Click to edit Master text styles</a:t>
+            </a:r>
+          </a:p>
+          <a:p>
+            <a:pPr lvl="1"/>
+            <a:r>
+              <a:rPr lang="en-US"/>
+              <a:t>Second level</a:t>
+            </a:r>
+          </a:p>
+          <a:p>
+            <a:pPr lvl="2"/>
+            <a:r>
+              <a:rPr lang="en-US"/>
+              <a:t>Third level</a:t>
+            </a:r>
+          </a:p>
+          <a:p>
+            <a:pPr lvl="3"/>
+            <a:r>
+              <a:rPr lang="en-US"/>
+              <a:t>Fourth level</a:t>
+            </a:r>
+          </a:p>
+          <a:p>
+            <a:pPr lvl="4"/>
+            <a:r>
+              <a:rPr lang="en-US"/>
+              <a:t>Fifth level</a:t>
+            </a:r>
+          </a:p>
+        </p:txBody>
+      </p:sp>
+      <p:sp>
+        <p:nvSpPr>
+          <p:cNvPr id="6" name="Footer Placeholder 5"/>
+          <p:cNvSpPr>
+            <a:spLocks noGrp="1"/>
+          </p:cNvSpPr>
+          <p:nvPr>
+            <p:ph type="ftr" sz="quarter" idx="4"/>
+          </p:nvPr>
+        </p:nvSpPr>
+        <p:spPr>
+          <a:xfrm>
+            <a:off x="0" y="8685213"/>
+            <a:ext cx="2971800" cy="458787"/>
+          </a:xfrm>
+          <a:prstGeom prst="rect">
+            <a:avLst/>
+          </a:prstGeom>
+        </p:spPr>
+        <p:txBody>
+          <a:bodyPr vert="horz" lIns="91440" tIns="45720" rIns="91440" bIns="45720" rtlCol="0" anchor="b"/>
+          <a:lstStyle>
+            <a:lvl1pPr algn="l">
+              <a:defRPr sz="1200"/>
+            </a:lvl1pPr>
+          </a:lstStyle>
+          <a:p>
+            <a:endParaRPr lang="en-US"/>
+          </a:p>
+        </p:txBody>
+      </p:sp>
+      <p:sp>
+        <p:nvSpPr>
+          <p:cNvPr id="7" name="Slide Number Placeholder 6"/>
+          <p:cNvSpPr>
+            <a:spLocks noGrp="1"/>
+          </p:cNvSpPr>
+          <p:nvPr>
+            <p:ph type="sldNum" sz="quarter" idx="5"/>
+          </p:nvPr>
+        </p:nvSpPr>
+        <p:spPr>
+          <a:xfrm>
+            <a:off x="3884613" y="8685213"/>
+            <a:ext cx="2971800" cy="458787"/>
+          </a:xfrm>
+          <a:prstGeom prst="rect">
+            <a:avLst/>
+          </a:prstGeom>
+        </p:spPr>
+        <p:txBody>
+          <a:bodyPr vert="horz" lIns="91440" tIns="45720" rIns="91440" bIns="45720" rtlCol="0" anchor="b"/>
+          <a:lstStyle>
+            <a:lvl1pPr algn="r">
+              <a:defRPr sz="1200"/>
+            </a:lvl1pPr>
+          </a:lstStyle>
+          <a:p>
+            <a:fld id="{22634106-49D0-487D-BD46-6EF9FCEBB6A7}" type="slidenum">
+              <a:rPr lang="en-US" smtClean="0"/>
+              <a:t>‹#›</a:t>
+            </a:fld>
+            <a:endParaRPr lang="en-US"/>
+          </a:p>
+        </p:txBody>
+      </p:sp>
+    </p:spTree>
+    <p:extLst>
+      <p:ext uri="{BB962C8B-B14F-4D97-AF65-F5344CB8AC3E}">
+        <p14:creationId xmlns:p14="http://schemas.microsoft.com/office/powerpoint/2010/main" val="191393082"/>
+      </p:ext>
+    </p:extLst>
+  </p:cSld>
+  <p:clrMap bg1="lt1" tx1="dk1" bg2="lt2" tx2="dk2" accent1="accent1" accent2="accent2" accent3="accent3" accent4="accent4" accent5="accent5" accent6="accent6" hlink="hlink" folHlink="folHlink"/>
+  <p:notesStyle>
+    <a:lvl1pPr marL="0" algn="l" defTabSz="914400" rtl="0" eaLnBrk="1" latinLnBrk="0" hangingPunct="1">
+      <a:defRPr sz="1200" kern="1200">
+        <a:solidFill>
+          <a:schemeClr val="tx1"/>
+        </a:solidFill>
+        <a:latin typeface="+mn-lt"/>
+        <a:ea typeface="+mn-ea"/>
+        <a:cs typeface="+mn-cs"/>
+      </a:defRPr>
+    </a:lvl1pPr>
+    <a:lvl2pPr marL="457200" algn="l" defTabSz="914400" rtl="0" eaLnBrk="1" latinLnBrk="0" hangingPunct="1">
+      <a:defRPr sz="1200" kern="1200">
+        <a:solidFill>
+          <a:schemeClr val="tx1"/>
+        </a:solidFill>
+        <a:latin typeface="+mn-lt"/>
+        <a:ea typeface="+mn-ea"/>
+        <a:cs typeface="+mn-cs"/>
+      </a:defRPr>
+    </a:lvl2pPr>
+    <a:lvl3pPr marL="914400" algn="l" defTabSz="914400" rtl="0" eaLnBrk="1" latinLnBrk="0" hangingPunct="1">
+      <a:defRPr sz="1200" kern="1200">
+        <a:solidFill>
+          <a:schemeClr val="tx1"/>
+        </a:solidFill>
+        <a:latin typeface="+mn-lt"/>
+        <a:ea typeface="+mn-ea"/>
+        <a:cs typeface="+mn-cs"/>
+      </a:defRPr>
+    </a:lvl3pPr>
+    <a:lvl4pPr marL="1371600" algn="l" defTabSz="914400" rtl="0" eaLnBrk="1" latinLnBrk="0" hangingPunct="1">
+      <a:defRPr sz="1200" kern="1200">
+        <a:solidFill>
+          <a:schemeClr val="tx1"/>
+        </a:solidFill>
+        <a:latin typeface="+mn-lt"/>
+        <a:ea typeface="+mn-ea"/>
+        <a:cs typeface="+mn-cs"/>
+      </a:defRPr>
+    </a:lvl4pPr>
+    <a:lvl5pPr marL="1828800" algn="l" defTabSz="914400" rtl="0" eaLnBrk="1" latinLnBrk="0" hangingPunct="1">
+      <a:defRPr sz="1200" kern="1200">
+        <a:solidFill>
+          <a:schemeClr val="tx1"/>
+        </a:solidFill>
+        <a:latin typeface="+mn-lt"/>
+        <a:ea typeface="+mn-ea"/>
+        <a:cs typeface="+mn-cs"/>
+      </a:defRPr>
+    </a:lvl5pPr>
+    <a:lvl6pPr marL="2286000" algn="l" defTabSz="914400" rtl="0" eaLnBrk="1" latinLnBrk="0" hangingPunct="1">
+      <a:defRPr sz="1200" kern="1200">
+        <a:solidFill>
+          <a:schemeClr val="tx1"/>
+        </a:solidFill>
+        <a:latin typeface="+mn-lt"/>
+        <a:ea typeface="+mn-ea"/>
+        <a:cs typeface="+mn-cs"/>
+      </a:defRPr>
+    </a:lvl6pPr>
+    <a:lvl7pPr marL="2743200" algn="l" defTabSz="914400" rtl="0" eaLnBrk="1" latinLnBrk="0" hangingPunct="1">
+      <a:defRPr sz="1200" kern="1200">
+        <a:solidFill>
+          <a:schemeClr val="tx1"/>
+        </a:solidFill>
+        <a:latin typeface="+mn-lt"/>
+        <a:ea typeface="+mn-ea"/>
+        <a:cs typeface="+mn-cs"/>
+      </a:defRPr>
+    </a:lvl7pPr>
+    <a:lvl8pPr marL="3200400" algn="l" defTabSz="914400" rtl="0" eaLnBrk="1" latinLnBrk="0" hangingPunct="1">
+      <a:defRPr sz="1200" kern="1200">
+        <a:solidFill>
+          <a:schemeClr val="tx1"/>
+        </a:solidFill>
+        <a:latin typeface="+mn-lt"/>
+        <a:ea typeface="+mn-ea"/>
+        <a:cs typeface="+mn-cs"/>
+      </a:defRPr>
+    </a:lvl8pPr>
+    <a:lvl9pPr marL="3657600" algn="l" defTabSz="914400" rtl="0" eaLnBrk="1" latinLnBrk="0" hangingPunct="1">
+      <a:defRPr sz="1200" kern="1200">
+        <a:solidFill>
+          <a:schemeClr val="tx1"/>
+        </a:solidFill>
+        <a:latin typeface="+mn-lt"/>
+        <a:ea typeface="+mn-ea"/>
+        <a:cs typeface="+mn-cs"/>
+      </a:defRPr>
+    </a:lvl9pPr>
+  </p:notesStyle>
+</p:notesMaster>
+</file>
+
+<file path=ppt/notesSlides/notesSlide1.xml><?xml version="1.0" encoding="utf-8"?>
+<p:notes xmlns:a="http://schemas.openxmlformats.org/drawingml/2006/main" xmlns:r="http://schemas.openxmlformats.org/officeDocument/2006/relationships" xmlns:p="http://schemas.openxmlformats.org/presentationml/2006/main">
+  <p:cSld>
+    <p:spTree>
+      <p:nvGrpSpPr>
+        <p:cNvPr id="1" name=""/>
+        <p:cNvGrpSpPr/>
+        <p:nvPr/>
+      </p:nvGrpSpPr>
+      <p:grpSpPr>
+        <a:xfrm>
+          <a:off x="0" y="0"/>
+          <a:ext cx="0" cy="0"/>
+          <a:chOff x="0" y="0"/>
+          <a:chExt cx="0" cy="0"/>
+        </a:xfrm>
+      </p:grpSpPr>
+      <p:sp>
+        <p:nvSpPr>
+          <p:cNvPr id="2" name="Slide Image Placeholder 1"/>
+          <p:cNvSpPr>
+            <a:spLocks noGrp="1" noRot="1" noChangeAspect="1"/>
+          </p:cNvSpPr>
+          <p:nvPr>
+            <p:ph type="sldImg"/>
+          </p:nvPr>
+        </p:nvSpPr>
+        <p:spPr/>
+      </p:sp>
+      <p:sp>
+        <p:nvSpPr>
+          <p:cNvPr id="3" name="Notes Placeholder 2"/>
+          <p:cNvSpPr>
+            <a:spLocks noGrp="1"/>
+          </p:cNvSpPr>
+          <p:nvPr>
+            <p:ph type="body" idx="1"/>
+          </p:nvPr>
+        </p:nvSpPr>
+        <p:spPr/>
+        <p:txBody>
+          <a:bodyPr/>
+          <a:lstStyle/>
+          <a:p>
+            <a:endParaRPr lang="en-US" dirty="0"/>
+          </a:p>
+        </p:txBody>
+      </p:sp>
+      <p:sp>
+        <p:nvSpPr>
+          <p:cNvPr id="4" name="Slide Number Placeholder 3"/>
+          <p:cNvSpPr>
+            <a:spLocks noGrp="1"/>
+          </p:cNvSpPr>
+          <p:nvPr>
+            <p:ph type="sldNum" sz="quarter" idx="5"/>
+          </p:nvPr>
+        </p:nvSpPr>
+        <p:spPr/>
+        <p:txBody>
+          <a:bodyPr/>
+          <a:lstStyle/>
+          <a:p>
+            <a:fld id="{22634106-49D0-487D-BD46-6EF9FCEBB6A7}" type="slidenum">
+              <a:rPr lang="en-US" smtClean="0"/>
+              <a:t>2</a:t>
+            </a:fld>
+            <a:endParaRPr lang="en-US"/>
+          </a:p>
+        </p:txBody>
+      </p:sp>
+    </p:spTree>
+    <p:extLst>
+      <p:ext uri="{BB962C8B-B14F-4D97-AF65-F5344CB8AC3E}">
+        <p14:creationId xmlns:p14="http://schemas.microsoft.com/office/powerpoint/2010/main" val="3779784053"/>
+      </p:ext>
+    </p:extLst>
+  </p:cSld>
+  <p:clrMapOvr>
+    <a:masterClrMapping/>
+  </p:clrMapOvr>
+</p:notes>
 </file>
 
 <file path=ppt/slideLayouts/slideLayout1.xml><?xml version="1.0" encoding="utf-8"?>
@@ -716,7 +1158,596 @@
       </p:grpSpPr>
       <p:sp>
         <p:nvSpPr>
-          <p:cNvPr id="4" name="Arrow: Pentagon 3">
+          <p:cNvPr id="16" name="Rectangle: Rounded Corners 15">
+            <a:extLst>
+              <a:ext uri="{FF2B5EF4-FFF2-40B4-BE49-F238E27FC236}">
+                <a16:creationId xmlns:a16="http://schemas.microsoft.com/office/drawing/2014/main" id="{FC98986E-8655-2801-6114-FF784133FB2D}"/>
+              </a:ext>
+            </a:extLst>
+          </p:cNvPr>
+          <p:cNvSpPr/>
+          <p:nvPr/>
+        </p:nvSpPr>
+        <p:spPr>
+          <a:xfrm>
+            <a:off x="4865511" y="866684"/>
+            <a:ext cx="1631245" cy="2034001"/>
+          </a:xfrm>
+          <a:prstGeom prst="roundRect">
+            <a:avLst/>
+          </a:prstGeom>
+          <a:solidFill>
+            <a:schemeClr val="tx2">
+              <a:lumMod val="10000"/>
+              <a:lumOff val="90000"/>
+            </a:schemeClr>
+          </a:solidFill>
+          <a:ln>
+            <a:noFill/>
+          </a:ln>
+        </p:spPr>
+        <p:style>
+          <a:lnRef idx="2">
+            <a:schemeClr val="accent1">
+              <a:shade val="15000"/>
+            </a:schemeClr>
+          </a:lnRef>
+          <a:fillRef idx="1">
+            <a:schemeClr val="accent1"/>
+          </a:fillRef>
+          <a:effectRef idx="0">
+            <a:schemeClr val="accent1"/>
+          </a:effectRef>
+          <a:fontRef idx="minor">
+            <a:schemeClr val="lt1"/>
+          </a:fontRef>
+        </p:style>
+        <p:txBody>
+          <a:bodyPr rtlCol="0" anchor="ctr"/>
+          <a:lstStyle/>
+          <a:p>
+            <a:pPr algn="ctr"/>
+            <a:endParaRPr lang="en-US"/>
+          </a:p>
+        </p:txBody>
+      </p:sp>
+      <p:pic>
+        <p:nvPicPr>
+          <p:cNvPr id="5" name="Picture 4">
+            <a:extLst>
+              <a:ext uri="{FF2B5EF4-FFF2-40B4-BE49-F238E27FC236}">
+                <a16:creationId xmlns:a16="http://schemas.microsoft.com/office/drawing/2014/main" id="{017FF472-B03A-83B2-A0BC-85A9F397CAB1}"/>
+              </a:ext>
+            </a:extLst>
+          </p:cNvPr>
+          <p:cNvPicPr>
+            <a:picLocks noChangeAspect="1"/>
+          </p:cNvPicPr>
+          <p:nvPr/>
+        </p:nvPicPr>
+        <p:blipFill>
+          <a:blip r:embed="rId2"/>
+          <a:stretch>
+            <a:fillRect/>
+          </a:stretch>
+        </p:blipFill>
+        <p:spPr>
+          <a:xfrm>
+            <a:off x="948559" y="956734"/>
+            <a:ext cx="428685" cy="533474"/>
+          </a:xfrm>
+          <a:prstGeom prst="rect">
+            <a:avLst/>
+          </a:prstGeom>
+        </p:spPr>
+      </p:pic>
+      <p:pic>
+        <p:nvPicPr>
+          <p:cNvPr id="7" name="Picture 6">
+            <a:extLst>
+              <a:ext uri="{FF2B5EF4-FFF2-40B4-BE49-F238E27FC236}">
+                <a16:creationId xmlns:a16="http://schemas.microsoft.com/office/drawing/2014/main" id="{DFCCBDD2-96F3-D035-BBD4-8D5228A48585}"/>
+              </a:ext>
+            </a:extLst>
+          </p:cNvPr>
+          <p:cNvPicPr>
+            <a:picLocks noChangeAspect="1"/>
+          </p:cNvPicPr>
+          <p:nvPr/>
+        </p:nvPicPr>
+        <p:blipFill>
+          <a:blip r:embed="rId3"/>
+          <a:stretch>
+            <a:fillRect/>
+          </a:stretch>
+        </p:blipFill>
+        <p:spPr>
+          <a:xfrm>
+            <a:off x="874845" y="1992413"/>
+            <a:ext cx="502399" cy="533475"/>
+          </a:xfrm>
+          <a:prstGeom prst="rect">
+            <a:avLst/>
+          </a:prstGeom>
+        </p:spPr>
+      </p:pic>
+      <p:pic>
+        <p:nvPicPr>
+          <p:cNvPr id="9" name="Picture 8">
+            <a:extLst>
+              <a:ext uri="{FF2B5EF4-FFF2-40B4-BE49-F238E27FC236}">
+                <a16:creationId xmlns:a16="http://schemas.microsoft.com/office/drawing/2014/main" id="{32ACDBE5-1CB5-759D-B2E0-1B8D86C3585C}"/>
+              </a:ext>
+            </a:extLst>
+          </p:cNvPr>
+          <p:cNvPicPr>
+            <a:picLocks noChangeAspect="1"/>
+          </p:cNvPicPr>
+          <p:nvPr/>
+        </p:nvPicPr>
+        <p:blipFill>
+          <a:blip r:embed="rId4"/>
+          <a:stretch>
+            <a:fillRect/>
+          </a:stretch>
+        </p:blipFill>
+        <p:spPr>
+          <a:xfrm>
+            <a:off x="1051755" y="3086052"/>
+            <a:ext cx="376290" cy="685895"/>
+          </a:xfrm>
+          <a:prstGeom prst="rect">
+            <a:avLst/>
+          </a:prstGeom>
+        </p:spPr>
+      </p:pic>
+      <p:pic>
+        <p:nvPicPr>
+          <p:cNvPr id="11" name="Picture 10">
+            <a:extLst>
+              <a:ext uri="{FF2B5EF4-FFF2-40B4-BE49-F238E27FC236}">
+                <a16:creationId xmlns:a16="http://schemas.microsoft.com/office/drawing/2014/main" id="{82E57A25-30AB-1A62-21FE-EA9F72049869}"/>
+              </a:ext>
+            </a:extLst>
+          </p:cNvPr>
+          <p:cNvPicPr>
+            <a:picLocks noChangeAspect="1"/>
+          </p:cNvPicPr>
+          <p:nvPr/>
+        </p:nvPicPr>
+        <p:blipFill>
+          <a:blip r:embed="rId5"/>
+          <a:stretch>
+            <a:fillRect/>
+          </a:stretch>
+        </p:blipFill>
+        <p:spPr>
+          <a:xfrm>
+            <a:off x="757571" y="4019605"/>
+            <a:ext cx="810659" cy="625012"/>
+          </a:xfrm>
+          <a:prstGeom prst="rect">
+            <a:avLst/>
+          </a:prstGeom>
+        </p:spPr>
+      </p:pic>
+      <p:pic>
+        <p:nvPicPr>
+          <p:cNvPr id="13" name="Picture 12">
+            <a:extLst>
+              <a:ext uri="{FF2B5EF4-FFF2-40B4-BE49-F238E27FC236}">
+                <a16:creationId xmlns:a16="http://schemas.microsoft.com/office/drawing/2014/main" id="{E129074E-E449-AE9C-AF98-EE7DCEB46182}"/>
+              </a:ext>
+            </a:extLst>
+          </p:cNvPr>
+          <p:cNvPicPr>
+            <a:picLocks noChangeAspect="1"/>
+          </p:cNvPicPr>
+          <p:nvPr/>
+        </p:nvPicPr>
+        <p:blipFill>
+          <a:blip r:embed="rId6"/>
+          <a:stretch>
+            <a:fillRect/>
+          </a:stretch>
+        </p:blipFill>
+        <p:spPr>
+          <a:xfrm>
+            <a:off x="730750" y="4892275"/>
+            <a:ext cx="790588" cy="752023"/>
+          </a:xfrm>
+          <a:prstGeom prst="rect">
+            <a:avLst/>
+          </a:prstGeom>
+        </p:spPr>
+      </p:pic>
+      <p:pic>
+        <p:nvPicPr>
+          <p:cNvPr id="15" name="Picture 14">
+            <a:extLst>
+              <a:ext uri="{FF2B5EF4-FFF2-40B4-BE49-F238E27FC236}">
+                <a16:creationId xmlns:a16="http://schemas.microsoft.com/office/drawing/2014/main" id="{B51A125E-49F4-16CB-197D-AC95272472CB}"/>
+              </a:ext>
+            </a:extLst>
+          </p:cNvPr>
+          <p:cNvPicPr>
+            <a:picLocks noChangeAspect="1"/>
+          </p:cNvPicPr>
+          <p:nvPr/>
+        </p:nvPicPr>
+        <p:blipFill>
+          <a:blip r:embed="rId7"/>
+          <a:stretch>
+            <a:fillRect/>
+          </a:stretch>
+        </p:blipFill>
+        <p:spPr>
+          <a:xfrm>
+            <a:off x="2364770" y="5061639"/>
+            <a:ext cx="471804" cy="578473"/>
+          </a:xfrm>
+          <a:prstGeom prst="rect">
+            <a:avLst/>
+          </a:prstGeom>
+        </p:spPr>
+      </p:pic>
+      <p:pic>
+        <p:nvPicPr>
+          <p:cNvPr id="17" name="Picture 16">
+            <a:extLst>
+              <a:ext uri="{FF2B5EF4-FFF2-40B4-BE49-F238E27FC236}">
+                <a16:creationId xmlns:a16="http://schemas.microsoft.com/office/drawing/2014/main" id="{338187AE-9B8F-1BAC-1A16-A2873ED5A6C4}"/>
+              </a:ext>
+            </a:extLst>
+          </p:cNvPr>
+          <p:cNvPicPr>
+            <a:picLocks noChangeAspect="1"/>
+          </p:cNvPicPr>
+          <p:nvPr/>
+        </p:nvPicPr>
+        <p:blipFill>
+          <a:blip r:embed="rId8"/>
+          <a:stretch>
+            <a:fillRect/>
+          </a:stretch>
+        </p:blipFill>
+        <p:spPr>
+          <a:xfrm>
+            <a:off x="2364770" y="4092400"/>
+            <a:ext cx="671898" cy="685896"/>
+          </a:xfrm>
+          <a:prstGeom prst="rect">
+            <a:avLst/>
+          </a:prstGeom>
+        </p:spPr>
+      </p:pic>
+      <p:pic>
+        <p:nvPicPr>
+          <p:cNvPr id="19" name="Picture 18">
+            <a:extLst>
+              <a:ext uri="{FF2B5EF4-FFF2-40B4-BE49-F238E27FC236}">
+                <a16:creationId xmlns:a16="http://schemas.microsoft.com/office/drawing/2014/main" id="{65B38BEB-95ED-2636-4AF0-A96FDC5FA13C}"/>
+              </a:ext>
+            </a:extLst>
+          </p:cNvPr>
+          <p:cNvPicPr>
+            <a:picLocks noChangeAspect="1"/>
+          </p:cNvPicPr>
+          <p:nvPr/>
+        </p:nvPicPr>
+        <p:blipFill>
+          <a:blip r:embed="rId9"/>
+          <a:stretch>
+            <a:fillRect/>
+          </a:stretch>
+        </p:blipFill>
+        <p:spPr>
+          <a:xfrm>
+            <a:off x="3036668" y="5061639"/>
+            <a:ext cx="513562" cy="520847"/>
+          </a:xfrm>
+          <a:prstGeom prst="rect">
+            <a:avLst/>
+          </a:prstGeom>
+        </p:spPr>
+      </p:pic>
+      <p:pic>
+        <p:nvPicPr>
+          <p:cNvPr id="21" name="Picture 20">
+            <a:extLst>
+              <a:ext uri="{FF2B5EF4-FFF2-40B4-BE49-F238E27FC236}">
+                <a16:creationId xmlns:a16="http://schemas.microsoft.com/office/drawing/2014/main" id="{E815195D-B8E8-9985-D0D2-3CDF156E2C43}"/>
+              </a:ext>
+            </a:extLst>
+          </p:cNvPr>
+          <p:cNvPicPr>
+            <a:picLocks noChangeAspect="1"/>
+          </p:cNvPicPr>
+          <p:nvPr/>
+        </p:nvPicPr>
+        <p:blipFill>
+          <a:blip r:embed="rId10"/>
+          <a:stretch>
+            <a:fillRect/>
+          </a:stretch>
+        </p:blipFill>
+        <p:spPr>
+          <a:xfrm>
+            <a:off x="2449437" y="3042356"/>
+            <a:ext cx="544824" cy="729591"/>
+          </a:xfrm>
+          <a:prstGeom prst="rect">
+            <a:avLst/>
+          </a:prstGeom>
+        </p:spPr>
+      </p:pic>
+      <p:pic>
+        <p:nvPicPr>
+          <p:cNvPr id="23" name="Picture 22">
+            <a:extLst>
+              <a:ext uri="{FF2B5EF4-FFF2-40B4-BE49-F238E27FC236}">
+                <a16:creationId xmlns:a16="http://schemas.microsoft.com/office/drawing/2014/main" id="{D9E4E0BC-B756-59E6-FB31-3E56F34EA356}"/>
+              </a:ext>
+            </a:extLst>
+          </p:cNvPr>
+          <p:cNvPicPr>
+            <a:picLocks noChangeAspect="1"/>
+          </p:cNvPicPr>
+          <p:nvPr/>
+        </p:nvPicPr>
+        <p:blipFill>
+          <a:blip r:embed="rId11"/>
+          <a:stretch>
+            <a:fillRect/>
+          </a:stretch>
+        </p:blipFill>
+        <p:spPr>
+          <a:xfrm>
+            <a:off x="2292051" y="1943321"/>
+            <a:ext cx="744617" cy="957364"/>
+          </a:xfrm>
+          <a:prstGeom prst="rect">
+            <a:avLst/>
+          </a:prstGeom>
+        </p:spPr>
+      </p:pic>
+      <p:pic>
+        <p:nvPicPr>
+          <p:cNvPr id="25" name="Picture 24">
+            <a:extLst>
+              <a:ext uri="{FF2B5EF4-FFF2-40B4-BE49-F238E27FC236}">
+                <a16:creationId xmlns:a16="http://schemas.microsoft.com/office/drawing/2014/main" id="{6EE62576-57DC-189F-D098-5D3941EB67B9}"/>
+              </a:ext>
+            </a:extLst>
+          </p:cNvPr>
+          <p:cNvPicPr>
+            <a:picLocks noChangeAspect="1"/>
+          </p:cNvPicPr>
+          <p:nvPr/>
+        </p:nvPicPr>
+        <p:blipFill>
+          <a:blip r:embed="rId12"/>
+          <a:stretch>
+            <a:fillRect/>
+          </a:stretch>
+        </p:blipFill>
+        <p:spPr>
+          <a:xfrm>
+            <a:off x="2366598" y="982668"/>
+            <a:ext cx="627663" cy="729591"/>
+          </a:xfrm>
+          <a:prstGeom prst="rect">
+            <a:avLst/>
+          </a:prstGeom>
+        </p:spPr>
+      </p:pic>
+      <p:pic>
+        <p:nvPicPr>
+          <p:cNvPr id="27" name="Picture 26">
+            <a:extLst>
+              <a:ext uri="{FF2B5EF4-FFF2-40B4-BE49-F238E27FC236}">
+                <a16:creationId xmlns:a16="http://schemas.microsoft.com/office/drawing/2014/main" id="{E5244A8E-ED4E-3E33-18AB-CE6DEDC061AE}"/>
+              </a:ext>
+            </a:extLst>
+          </p:cNvPr>
+          <p:cNvPicPr>
+            <a:picLocks noChangeAspect="1"/>
+          </p:cNvPicPr>
+          <p:nvPr/>
+        </p:nvPicPr>
+        <p:blipFill>
+          <a:blip r:embed="rId13"/>
+          <a:stretch>
+            <a:fillRect/>
+          </a:stretch>
+        </p:blipFill>
+        <p:spPr>
+          <a:xfrm>
+            <a:off x="3550230" y="2079144"/>
+            <a:ext cx="670646" cy="821541"/>
+          </a:xfrm>
+          <a:prstGeom prst="rect">
+            <a:avLst/>
+          </a:prstGeom>
+        </p:spPr>
+      </p:pic>
+      <p:pic>
+        <p:nvPicPr>
+          <p:cNvPr id="29" name="Picture 28">
+            <a:extLst>
+              <a:ext uri="{FF2B5EF4-FFF2-40B4-BE49-F238E27FC236}">
+                <a16:creationId xmlns:a16="http://schemas.microsoft.com/office/drawing/2014/main" id="{2327AFE1-0712-5B76-55F6-81C980432F0F}"/>
+              </a:ext>
+            </a:extLst>
+          </p:cNvPr>
+          <p:cNvPicPr>
+            <a:picLocks noChangeAspect="1"/>
+          </p:cNvPicPr>
+          <p:nvPr/>
+        </p:nvPicPr>
+        <p:blipFill>
+          <a:blip r:embed="rId14"/>
+          <a:stretch>
+            <a:fillRect/>
+          </a:stretch>
+        </p:blipFill>
+        <p:spPr>
+          <a:xfrm flipH="1">
+            <a:off x="3293653" y="866684"/>
+            <a:ext cx="627662" cy="1000122"/>
+          </a:xfrm>
+          <a:prstGeom prst="rect">
+            <a:avLst/>
+          </a:prstGeom>
+        </p:spPr>
+      </p:pic>
+      <p:pic>
+        <p:nvPicPr>
+          <p:cNvPr id="3" name="Picture 2" descr="A person with a computer&#10;&#10;AI-generated content may be incorrect.">
+            <a:extLst>
+              <a:ext uri="{FF2B5EF4-FFF2-40B4-BE49-F238E27FC236}">
+                <a16:creationId xmlns:a16="http://schemas.microsoft.com/office/drawing/2014/main" id="{9208BBAC-B031-6213-6F52-E7DEAF95B582}"/>
+              </a:ext>
+            </a:extLst>
+          </p:cNvPr>
+          <p:cNvPicPr>
+            <a:picLocks noChangeAspect="1"/>
+          </p:cNvPicPr>
+          <p:nvPr/>
+        </p:nvPicPr>
+        <p:blipFill>
+          <a:blip r:embed="rId15">
+            <a:extLst>
+              <a:ext uri="{28A0092B-C50C-407E-A947-70E740481C1C}">
+                <a14:useLocalDpi xmlns:a14="http://schemas.microsoft.com/office/drawing/2010/main" val="0"/>
+              </a:ext>
+            </a:extLst>
+          </a:blip>
+          <a:stretch>
+            <a:fillRect/>
+          </a:stretch>
+        </p:blipFill>
+        <p:spPr>
+          <a:xfrm>
+            <a:off x="5775904" y="1992413"/>
+            <a:ext cx="628904" cy="733722"/>
+          </a:xfrm>
+          <a:prstGeom prst="rect">
+            <a:avLst/>
+          </a:prstGeom>
+        </p:spPr>
+      </p:pic>
+      <p:pic>
+        <p:nvPicPr>
+          <p:cNvPr id="6" name="Picture 5" descr="A person in a suit holding a tablet&#10;&#10;AI-generated content may be incorrect.">
+            <a:extLst>
+              <a:ext uri="{FF2B5EF4-FFF2-40B4-BE49-F238E27FC236}">
+                <a16:creationId xmlns:a16="http://schemas.microsoft.com/office/drawing/2014/main" id="{CA875515-277E-5DBA-D761-B729FB55E072}"/>
+              </a:ext>
+            </a:extLst>
+          </p:cNvPr>
+          <p:cNvPicPr>
+            <a:picLocks noChangeAspect="1"/>
+          </p:cNvPicPr>
+          <p:nvPr/>
+        </p:nvPicPr>
+        <p:blipFill>
+          <a:blip r:embed="rId16">
+            <a:extLst>
+              <a:ext uri="{28A0092B-C50C-407E-A947-70E740481C1C}">
+                <a14:useLocalDpi xmlns:a14="http://schemas.microsoft.com/office/drawing/2010/main" val="0"/>
+              </a:ext>
+            </a:extLst>
+          </a:blip>
+          <a:stretch>
+            <a:fillRect/>
+          </a:stretch>
+        </p:blipFill>
+        <p:spPr>
+          <a:xfrm>
+            <a:off x="4968747" y="1758885"/>
+            <a:ext cx="628904" cy="1000529"/>
+          </a:xfrm>
+          <a:prstGeom prst="rect">
+            <a:avLst/>
+          </a:prstGeom>
+        </p:spPr>
+      </p:pic>
+      <p:pic>
+        <p:nvPicPr>
+          <p:cNvPr id="10" name="Picture 9" descr="A person sitting in a chair with a computer&#10;&#10;AI-generated content may be incorrect.">
+            <a:extLst>
+              <a:ext uri="{FF2B5EF4-FFF2-40B4-BE49-F238E27FC236}">
+                <a16:creationId xmlns:a16="http://schemas.microsoft.com/office/drawing/2014/main" id="{7D28356E-09AF-D4E3-C9D1-F9D7F4F4BE36}"/>
+              </a:ext>
+            </a:extLst>
+          </p:cNvPr>
+          <p:cNvPicPr>
+            <a:picLocks noChangeAspect="1"/>
+          </p:cNvPicPr>
+          <p:nvPr/>
+        </p:nvPicPr>
+        <p:blipFill>
+          <a:blip r:embed="rId17">
+            <a:extLst>
+              <a:ext uri="{28A0092B-C50C-407E-A947-70E740481C1C}">
+                <a14:useLocalDpi xmlns:a14="http://schemas.microsoft.com/office/drawing/2010/main" val="0"/>
+              </a:ext>
+            </a:extLst>
+          </a:blip>
+          <a:stretch>
+            <a:fillRect/>
+          </a:stretch>
+        </p:blipFill>
+        <p:spPr>
+          <a:xfrm>
+            <a:off x="5667005" y="913669"/>
+            <a:ext cx="743447" cy="953137"/>
+          </a:xfrm>
+          <a:prstGeom prst="rect">
+            <a:avLst/>
+          </a:prstGeom>
+        </p:spPr>
+      </p:pic>
+      <p:pic>
+        <p:nvPicPr>
+          <p:cNvPr id="14" name="Picture 13" descr="A person sitting at a desk with a computer&#10;&#10;AI-generated content may be incorrect.">
+            <a:extLst>
+              <a:ext uri="{FF2B5EF4-FFF2-40B4-BE49-F238E27FC236}">
+                <a16:creationId xmlns:a16="http://schemas.microsoft.com/office/drawing/2014/main" id="{DC432507-9D6A-B8F7-1148-D55CF7EF9625}"/>
+              </a:ext>
+            </a:extLst>
+          </p:cNvPr>
+          <p:cNvPicPr>
+            <a:picLocks noChangeAspect="1"/>
+          </p:cNvPicPr>
+          <p:nvPr/>
+        </p:nvPicPr>
+        <p:blipFill>
+          <a:blip r:embed="rId18">
+            <a:extLst>
+              <a:ext uri="{28A0092B-C50C-407E-A947-70E740481C1C}">
+                <a14:useLocalDpi xmlns:a14="http://schemas.microsoft.com/office/drawing/2010/main" val="0"/>
+              </a:ext>
+            </a:extLst>
+          </a:blip>
+          <a:stretch>
+            <a:fillRect/>
+          </a:stretch>
+        </p:blipFill>
+        <p:spPr>
+          <a:xfrm>
+            <a:off x="5011627" y="931334"/>
+            <a:ext cx="543145" cy="733722"/>
+          </a:xfrm>
+          <a:prstGeom prst="rect">
+            <a:avLst/>
+          </a:prstGeom>
+        </p:spPr>
+      </p:pic>
+      <p:sp>
+        <p:nvSpPr>
+          <p:cNvPr id="18" name="Arrow: Pentagon 17">
             <a:extLst>
               <a:ext uri="{FF2B5EF4-FFF2-40B4-BE49-F238E27FC236}">
                 <a16:creationId xmlns:a16="http://schemas.microsoft.com/office/drawing/2014/main" id="{52132A69-4E90-6CE8-9B66-780F4DA40058}"/>
@@ -728,7 +1759,7 @@
         </p:nvSpPr>
         <p:spPr>
           <a:xfrm>
-            <a:off x="2996498" y="1865671"/>
+            <a:off x="7269343" y="1109850"/>
             <a:ext cx="1235473" cy="372604"/>
           </a:xfrm>
           <a:prstGeom prst="homePlate">
@@ -762,7 +1793,7 @@
       </p:sp>
       <p:sp>
         <p:nvSpPr>
-          <p:cNvPr id="5" name="Oval 4">
+          <p:cNvPr id="20" name="Oval 19">
             <a:extLst>
               <a:ext uri="{FF2B5EF4-FFF2-40B4-BE49-F238E27FC236}">
                 <a16:creationId xmlns:a16="http://schemas.microsoft.com/office/drawing/2014/main" id="{51AE15FC-CDEC-B166-C98D-95F450AF75E2}"/>
@@ -774,7 +1805,7 @@
         </p:nvSpPr>
         <p:spPr>
           <a:xfrm>
-            <a:off x="2805293" y="1811741"/>
+            <a:off x="7078138" y="1055920"/>
             <a:ext cx="480463" cy="480463"/>
           </a:xfrm>
           <a:prstGeom prst="ellipse">
@@ -814,7 +1845,7 @@
       </p:sp>
       <p:sp>
         <p:nvSpPr>
-          <p:cNvPr id="6" name="Oval 5">
+          <p:cNvPr id="22" name="Oval 21">
             <a:extLst>
               <a:ext uri="{FF2B5EF4-FFF2-40B4-BE49-F238E27FC236}">
                 <a16:creationId xmlns:a16="http://schemas.microsoft.com/office/drawing/2014/main" id="{F606D89E-D933-A53A-6C99-9FE6E7541E77}"/>
@@ -826,7 +1857,7 @@
         </p:nvSpPr>
         <p:spPr>
           <a:xfrm>
-            <a:off x="2879609" y="1886057"/>
+            <a:off x="7152454" y="1130236"/>
             <a:ext cx="331830" cy="331831"/>
           </a:xfrm>
           <a:prstGeom prst="ellipse">
@@ -863,7 +1894,7 @@
       </p:sp>
       <p:sp>
         <p:nvSpPr>
-          <p:cNvPr id="9" name="TextBox 8">
+          <p:cNvPr id="24" name="TextBox 23">
             <a:extLst>
               <a:ext uri="{FF2B5EF4-FFF2-40B4-BE49-F238E27FC236}">
                 <a16:creationId xmlns:a16="http://schemas.microsoft.com/office/drawing/2014/main" id="{428F31FD-C1DB-29F3-66CC-5F3BA99B34FA}"/>
@@ -875,7 +1906,7 @@
         </p:nvSpPr>
         <p:spPr>
           <a:xfrm>
-            <a:off x="3326756" y="1884490"/>
+            <a:off x="7599601" y="1128669"/>
             <a:ext cx="765531" cy="338554"/>
           </a:xfrm>
           <a:prstGeom prst="rect">
@@ -902,7 +1933,7 @@
       </p:sp>
       <p:sp>
         <p:nvSpPr>
-          <p:cNvPr id="11" name="Rectangle 10">
+          <p:cNvPr id="26" name="Rectangle 25">
             <a:extLst>
               <a:ext uri="{FF2B5EF4-FFF2-40B4-BE49-F238E27FC236}">
                 <a16:creationId xmlns:a16="http://schemas.microsoft.com/office/drawing/2014/main" id="{66830A03-7B44-B3C4-7F1B-849A4099CEC5}"/>
@@ -914,7 +1945,7 @@
         </p:nvSpPr>
         <p:spPr>
           <a:xfrm>
-            <a:off x="2743199" y="1738489"/>
+            <a:off x="7016044" y="982668"/>
             <a:ext cx="1619957" cy="643467"/>
           </a:xfrm>
           <a:prstGeom prst="rect">
@@ -950,7 +1981,3528 @@
     </p:spTree>
     <p:extLst>
       <p:ext uri="{BB962C8B-B14F-4D97-AF65-F5344CB8AC3E}">
-        <p14:creationId xmlns:p14="http://schemas.microsoft.com/office/powerpoint/2010/main" val="3631816164"/>
+        <p14:creationId xmlns:p14="http://schemas.microsoft.com/office/powerpoint/2010/main" val="3991939631"/>
+      </p:ext>
+    </p:extLst>
+  </p:cSld>
+  <p:clrMapOvr>
+    <a:masterClrMapping/>
+  </p:clrMapOvr>
+</p:sld>
+</file>
+
+<file path=ppt/slides/slide2.xml><?xml version="1.0" encoding="utf-8"?>
+<p:sld xmlns:a="http://schemas.openxmlformats.org/drawingml/2006/main" xmlns:r="http://schemas.openxmlformats.org/officeDocument/2006/relationships" xmlns:p="http://schemas.openxmlformats.org/presentationml/2006/main">
+  <p:cSld>
+    <p:spTree>
+      <p:nvGrpSpPr>
+        <p:cNvPr id="1" name=""/>
+        <p:cNvGrpSpPr/>
+        <p:nvPr/>
+      </p:nvGrpSpPr>
+      <p:grpSpPr>
+        <a:xfrm>
+          <a:off x="0" y="0"/>
+          <a:ext cx="0" cy="0"/>
+          <a:chOff x="0" y="0"/>
+          <a:chExt cx="0" cy="0"/>
+        </a:xfrm>
+      </p:grpSpPr>
+      <p:sp>
+        <p:nvSpPr>
+          <p:cNvPr id="54" name="Rectangle: Rounded Corners 53">
+            <a:extLst>
+              <a:ext uri="{FF2B5EF4-FFF2-40B4-BE49-F238E27FC236}">
+                <a16:creationId xmlns:a16="http://schemas.microsoft.com/office/drawing/2014/main" id="{6D86CE88-7204-BD52-0A23-B88B1FCC03B8}"/>
+              </a:ext>
+            </a:extLst>
+          </p:cNvPr>
+          <p:cNvSpPr/>
+          <p:nvPr/>
+        </p:nvSpPr>
+        <p:spPr>
+          <a:xfrm>
+            <a:off x="184223" y="323851"/>
+            <a:ext cx="4013127" cy="5149850"/>
+          </a:xfrm>
+          <a:prstGeom prst="roundRect">
+            <a:avLst>
+              <a:gd name="adj" fmla="val 3159"/>
+            </a:avLst>
+          </a:prstGeom>
+          <a:solidFill>
+            <a:schemeClr val="accent6">
+              <a:lumMod val="20000"/>
+              <a:lumOff val="80000"/>
+            </a:schemeClr>
+          </a:solidFill>
+          <a:ln>
+            <a:noFill/>
+          </a:ln>
+        </p:spPr>
+        <p:style>
+          <a:lnRef idx="2">
+            <a:schemeClr val="accent1">
+              <a:shade val="15000"/>
+            </a:schemeClr>
+          </a:lnRef>
+          <a:fillRef idx="1">
+            <a:schemeClr val="accent1"/>
+          </a:fillRef>
+          <a:effectRef idx="0">
+            <a:schemeClr val="accent1"/>
+          </a:effectRef>
+          <a:fontRef idx="minor">
+            <a:schemeClr val="lt1"/>
+          </a:fontRef>
+        </p:style>
+        <p:txBody>
+          <a:bodyPr rtlCol="0" anchor="ctr"/>
+          <a:lstStyle/>
+          <a:p>
+            <a:pPr algn="ctr"/>
+            <a:endParaRPr lang="en-US"/>
+          </a:p>
+        </p:txBody>
+      </p:sp>
+      <p:grpSp>
+        <p:nvGrpSpPr>
+          <p:cNvPr id="4" name="Group 3">
+            <a:extLst>
+              <a:ext uri="{FF2B5EF4-FFF2-40B4-BE49-F238E27FC236}">
+                <a16:creationId xmlns:a16="http://schemas.microsoft.com/office/drawing/2014/main" id="{35D35F47-1CF8-065C-28AA-EC0868ED5F32}"/>
+              </a:ext>
+            </a:extLst>
+          </p:cNvPr>
+          <p:cNvGrpSpPr/>
+          <p:nvPr/>
+        </p:nvGrpSpPr>
+        <p:grpSpPr>
+          <a:xfrm>
+            <a:off x="509471" y="2694917"/>
+            <a:ext cx="1507889" cy="2057400"/>
+            <a:chOff x="413523" y="2694917"/>
+            <a:chExt cx="1507889" cy="2057400"/>
+          </a:xfrm>
+        </p:grpSpPr>
+        <p:sp>
+          <p:nvSpPr>
+            <p:cNvPr id="26" name="Rectangle 25">
+              <a:extLst>
+                <a:ext uri="{FF2B5EF4-FFF2-40B4-BE49-F238E27FC236}">
+                  <a16:creationId xmlns:a16="http://schemas.microsoft.com/office/drawing/2014/main" id="{D239AE96-BA76-EE6D-3AF3-441B7D695C7F}"/>
+                </a:ext>
+              </a:extLst>
+            </p:cNvPr>
+            <p:cNvSpPr/>
+            <p:nvPr/>
+          </p:nvSpPr>
+          <p:spPr>
+            <a:xfrm>
+              <a:off x="413523" y="2694917"/>
+              <a:ext cx="1507889" cy="2057400"/>
+            </a:xfrm>
+            <a:prstGeom prst="rect">
+              <a:avLst/>
+            </a:prstGeom>
+            <a:solidFill>
+              <a:srgbClr val="FFFFFF"/>
+            </a:solidFill>
+            <a:ln w="12700"/>
+          </p:spPr>
+          <p:style>
+            <a:lnRef idx="2">
+              <a:schemeClr val="accent1">
+                <a:shade val="15000"/>
+              </a:schemeClr>
+            </a:lnRef>
+            <a:fillRef idx="1">
+              <a:schemeClr val="accent1"/>
+            </a:fillRef>
+            <a:effectRef idx="0">
+              <a:schemeClr val="accent1"/>
+            </a:effectRef>
+            <a:fontRef idx="minor">
+              <a:schemeClr val="lt1"/>
+            </a:fontRef>
+          </p:style>
+          <p:txBody>
+            <a:bodyPr rtlCol="0" anchor="ctr"/>
+            <a:lstStyle/>
+            <a:p>
+              <a:pPr algn="ctr"/>
+              <a:endParaRPr lang="en-US"/>
+            </a:p>
+          </p:txBody>
+        </p:sp>
+        <p:pic>
+          <p:nvPicPr>
+            <p:cNvPr id="25" name="Picture 24">
+              <a:extLst>
+                <a:ext uri="{FF2B5EF4-FFF2-40B4-BE49-F238E27FC236}">
+                  <a16:creationId xmlns:a16="http://schemas.microsoft.com/office/drawing/2014/main" id="{6D8EA08E-6504-FAF0-23F4-7CFE43BBACCA}"/>
+                </a:ext>
+              </a:extLst>
+            </p:cNvPr>
+            <p:cNvPicPr>
+              <a:picLocks noChangeAspect="1"/>
+            </p:cNvPicPr>
+            <p:nvPr/>
+          </p:nvPicPr>
+          <p:blipFill>
+            <a:blip r:embed="rId3"/>
+            <a:stretch>
+              <a:fillRect/>
+            </a:stretch>
+          </p:blipFill>
+          <p:spPr>
+            <a:xfrm>
+              <a:off x="503182" y="2816077"/>
+              <a:ext cx="1336707" cy="1756815"/>
+            </a:xfrm>
+            <a:prstGeom prst="rect">
+              <a:avLst/>
+            </a:prstGeom>
+            <a:solidFill>
+              <a:schemeClr val="bg1">
+                <a:lumMod val="95000"/>
+              </a:schemeClr>
+            </a:solidFill>
+          </p:spPr>
+        </p:pic>
+      </p:grpSp>
+      <p:pic>
+        <p:nvPicPr>
+          <p:cNvPr id="5" name="Picture 4" descr="A person with a computer&#10;&#10;AI-generated content may be incorrect.">
+            <a:extLst>
+              <a:ext uri="{FF2B5EF4-FFF2-40B4-BE49-F238E27FC236}">
+                <a16:creationId xmlns:a16="http://schemas.microsoft.com/office/drawing/2014/main" id="{C5263302-D730-1267-E86A-B5B21A0DA019}"/>
+              </a:ext>
+            </a:extLst>
+          </p:cNvPr>
+          <p:cNvPicPr>
+            <a:picLocks noChangeAspect="1"/>
+          </p:cNvPicPr>
+          <p:nvPr/>
+        </p:nvPicPr>
+        <p:blipFill>
+          <a:blip r:embed="rId4">
+            <a:extLst>
+              <a:ext uri="{28A0092B-C50C-407E-A947-70E740481C1C}">
+                <a14:useLocalDpi xmlns:a14="http://schemas.microsoft.com/office/drawing/2010/main" val="0"/>
+              </a:ext>
+            </a:extLst>
+          </a:blip>
+          <a:stretch>
+            <a:fillRect/>
+          </a:stretch>
+        </p:blipFill>
+        <p:spPr>
+          <a:xfrm>
+            <a:off x="2981903" y="1137383"/>
+            <a:ext cx="628904" cy="733722"/>
+          </a:xfrm>
+          <a:prstGeom prst="rect">
+            <a:avLst/>
+          </a:prstGeom>
+        </p:spPr>
+      </p:pic>
+      <p:pic>
+        <p:nvPicPr>
+          <p:cNvPr id="7" name="Picture 6" descr="A person in a suit holding a tablet&#10;&#10;AI-generated content may be incorrect.">
+            <a:extLst>
+              <a:ext uri="{FF2B5EF4-FFF2-40B4-BE49-F238E27FC236}">
+                <a16:creationId xmlns:a16="http://schemas.microsoft.com/office/drawing/2014/main" id="{3234AC99-EA49-A55F-4F2A-9B8FA4E45348}"/>
+              </a:ext>
+            </a:extLst>
+          </p:cNvPr>
+          <p:cNvPicPr>
+            <a:picLocks noChangeAspect="1"/>
+          </p:cNvPicPr>
+          <p:nvPr/>
+        </p:nvPicPr>
+        <p:blipFill>
+          <a:blip r:embed="rId5">
+            <a:extLst>
+              <a:ext uri="{28A0092B-C50C-407E-A947-70E740481C1C}">
+                <a14:useLocalDpi xmlns:a14="http://schemas.microsoft.com/office/drawing/2010/main" val="0"/>
+              </a:ext>
+            </a:extLst>
+          </a:blip>
+          <a:stretch>
+            <a:fillRect/>
+          </a:stretch>
+        </p:blipFill>
+        <p:spPr>
+          <a:xfrm flipH="1">
+            <a:off x="1553859" y="1003980"/>
+            <a:ext cx="628904" cy="1000529"/>
+          </a:xfrm>
+          <a:prstGeom prst="rect">
+            <a:avLst/>
+          </a:prstGeom>
+        </p:spPr>
+      </p:pic>
+      <p:sp>
+        <p:nvSpPr>
+          <p:cNvPr id="8" name="Speech Bubble: Rectangle with Corners Rounded 7">
+            <a:extLst>
+              <a:ext uri="{FF2B5EF4-FFF2-40B4-BE49-F238E27FC236}">
+                <a16:creationId xmlns:a16="http://schemas.microsoft.com/office/drawing/2014/main" id="{C2C7CC88-24D9-CC62-4FF1-1E6C3F0A34F5}"/>
+              </a:ext>
+            </a:extLst>
+          </p:cNvPr>
+          <p:cNvSpPr/>
+          <p:nvPr/>
+        </p:nvSpPr>
+        <p:spPr>
+          <a:xfrm>
+            <a:off x="1167467" y="475320"/>
+            <a:ext cx="1083733" cy="505402"/>
+          </a:xfrm>
+          <a:prstGeom prst="wedgeRoundRectCallout">
+            <a:avLst>
+              <a:gd name="adj1" fmla="val -8854"/>
+              <a:gd name="adj2" fmla="val 65850"/>
+              <a:gd name="adj3" fmla="val 16667"/>
+            </a:avLst>
+          </a:prstGeom>
+          <a:solidFill>
+            <a:schemeClr val="bg1"/>
+          </a:solidFill>
+          <a:ln>
+            <a:solidFill>
+              <a:schemeClr val="bg1">
+                <a:lumMod val="75000"/>
+              </a:schemeClr>
+            </a:solidFill>
+          </a:ln>
+        </p:spPr>
+        <p:style>
+          <a:lnRef idx="2">
+            <a:schemeClr val="accent1">
+              <a:shade val="15000"/>
+            </a:schemeClr>
+          </a:lnRef>
+          <a:fillRef idx="1">
+            <a:schemeClr val="accent1"/>
+          </a:fillRef>
+          <a:effectRef idx="0">
+            <a:schemeClr val="accent1"/>
+          </a:effectRef>
+          <a:fontRef idx="minor">
+            <a:schemeClr val="lt1"/>
+          </a:fontRef>
+        </p:style>
+        <p:txBody>
+          <a:bodyPr lIns="45720" rIns="45720" rtlCol="0" anchor="ctr"/>
+          <a:lstStyle/>
+          <a:p>
+            <a:pPr algn="ctr"/>
+            <a:r>
+              <a:rPr lang="en-US" sz="900" dirty="0">
+                <a:solidFill>
+                  <a:schemeClr val="tx1"/>
+                </a:solidFill>
+                <a:latin typeface="Verdana" panose="020B0604030504040204" pitchFamily="34" charset="0"/>
+                <a:ea typeface="Verdana" panose="020B0604030504040204" pitchFamily="34" charset="0"/>
+              </a:rPr>
+              <a:t>I want an API that integrates our systems … </a:t>
+            </a:r>
+          </a:p>
+        </p:txBody>
+      </p:sp>
+      <p:sp>
+        <p:nvSpPr>
+          <p:cNvPr id="9" name="Speech Bubble: Rectangle with Corners Rounded 8">
+            <a:extLst>
+              <a:ext uri="{FF2B5EF4-FFF2-40B4-BE49-F238E27FC236}">
+                <a16:creationId xmlns:a16="http://schemas.microsoft.com/office/drawing/2014/main" id="{29F6822C-C7A4-4B87-40A5-9D3495F4BD29}"/>
+              </a:ext>
+            </a:extLst>
+          </p:cNvPr>
+          <p:cNvSpPr/>
+          <p:nvPr/>
+        </p:nvSpPr>
+        <p:spPr>
+          <a:xfrm>
+            <a:off x="2578691" y="475320"/>
+            <a:ext cx="1405468" cy="505402"/>
+          </a:xfrm>
+          <a:prstGeom prst="wedgeRoundRectCallout">
+            <a:avLst>
+              <a:gd name="adj1" fmla="val -7795"/>
+              <a:gd name="adj2" fmla="val 68084"/>
+              <a:gd name="adj3" fmla="val 16667"/>
+            </a:avLst>
+          </a:prstGeom>
+          <a:solidFill>
+            <a:schemeClr val="bg1"/>
+          </a:solidFill>
+          <a:ln>
+            <a:solidFill>
+              <a:schemeClr val="bg1">
+                <a:lumMod val="75000"/>
+              </a:schemeClr>
+            </a:solidFill>
+          </a:ln>
+        </p:spPr>
+        <p:style>
+          <a:lnRef idx="2">
+            <a:schemeClr val="accent1">
+              <a:shade val="15000"/>
+            </a:schemeClr>
+          </a:lnRef>
+          <a:fillRef idx="1">
+            <a:schemeClr val="accent1"/>
+          </a:fillRef>
+          <a:effectRef idx="0">
+            <a:schemeClr val="accent1"/>
+          </a:effectRef>
+          <a:fontRef idx="minor">
+            <a:schemeClr val="lt1"/>
+          </a:fontRef>
+        </p:style>
+        <p:txBody>
+          <a:bodyPr lIns="45720" rIns="45720" rtlCol="0" anchor="ctr"/>
+          <a:lstStyle/>
+          <a:p>
+            <a:pPr algn="ctr"/>
+            <a:r>
+              <a:rPr lang="en-US" sz="900" dirty="0">
+                <a:solidFill>
+                  <a:schemeClr val="tx1"/>
+                </a:solidFill>
+                <a:latin typeface="Verdana" panose="020B0604030504040204" pitchFamily="34" charset="0"/>
+                <a:ea typeface="Verdana" panose="020B0604030504040204" pitchFamily="34" charset="0"/>
+              </a:rPr>
+              <a:t>What business data resources does</a:t>
+            </a:r>
+            <a:br>
+              <a:rPr lang="en-US" sz="900" dirty="0">
+                <a:solidFill>
+                  <a:schemeClr val="tx1"/>
+                </a:solidFill>
+                <a:latin typeface="Verdana" panose="020B0604030504040204" pitchFamily="34" charset="0"/>
+                <a:ea typeface="Verdana" panose="020B0604030504040204" pitchFamily="34" charset="0"/>
+              </a:rPr>
+            </a:br>
+            <a:r>
+              <a:rPr lang="en-US" sz="900" dirty="0">
+                <a:solidFill>
+                  <a:schemeClr val="tx1"/>
+                </a:solidFill>
+                <a:latin typeface="Verdana" panose="020B0604030504040204" pitchFamily="34" charset="0"/>
+                <a:ea typeface="Verdana" panose="020B0604030504040204" pitchFamily="34" charset="0"/>
+              </a:rPr>
+              <a:t>the API transfer? …</a:t>
+            </a:r>
+          </a:p>
+        </p:txBody>
+      </p:sp>
+      <p:sp>
+        <p:nvSpPr>
+          <p:cNvPr id="10" name="TextBox 9">
+            <a:extLst>
+              <a:ext uri="{FF2B5EF4-FFF2-40B4-BE49-F238E27FC236}">
+                <a16:creationId xmlns:a16="http://schemas.microsoft.com/office/drawing/2014/main" id="{D42CDE89-2080-0986-794E-926850DCD6DB}"/>
+              </a:ext>
+            </a:extLst>
+          </p:cNvPr>
+          <p:cNvSpPr txBox="1"/>
+          <p:nvPr/>
+        </p:nvSpPr>
+        <p:spPr>
+          <a:xfrm>
+            <a:off x="1450671" y="1947333"/>
+            <a:ext cx="713657" cy="400110"/>
+          </a:xfrm>
+          <a:prstGeom prst="rect">
+            <a:avLst/>
+          </a:prstGeom>
+          <a:noFill/>
+        </p:spPr>
+        <p:txBody>
+          <a:bodyPr wrap="none" rtlCol="0">
+            <a:spAutoFit/>
+          </a:bodyPr>
+          <a:lstStyle/>
+          <a:p>
+            <a:pPr algn="ctr"/>
+            <a:r>
+              <a:rPr lang="en-US" sz="1000" dirty="0">
+                <a:latin typeface="Verdana" panose="020B0604030504040204" pitchFamily="34" charset="0"/>
+                <a:ea typeface="Verdana" panose="020B0604030504040204" pitchFamily="34" charset="0"/>
+              </a:rPr>
+              <a:t>Project</a:t>
+            </a:r>
+            <a:br>
+              <a:rPr lang="en-US" sz="1000" dirty="0">
+                <a:latin typeface="Verdana" panose="020B0604030504040204" pitchFamily="34" charset="0"/>
+                <a:ea typeface="Verdana" panose="020B0604030504040204" pitchFamily="34" charset="0"/>
+              </a:rPr>
+            </a:br>
+            <a:r>
+              <a:rPr lang="en-US" sz="1000" dirty="0">
+                <a:latin typeface="Verdana" panose="020B0604030504040204" pitchFamily="34" charset="0"/>
+                <a:ea typeface="Verdana" panose="020B0604030504040204" pitchFamily="34" charset="0"/>
+              </a:rPr>
+              <a:t>Sponsor</a:t>
+            </a:r>
+          </a:p>
+        </p:txBody>
+      </p:sp>
+      <p:sp>
+        <p:nvSpPr>
+          <p:cNvPr id="11" name="TextBox 10">
+            <a:extLst>
+              <a:ext uri="{FF2B5EF4-FFF2-40B4-BE49-F238E27FC236}">
+                <a16:creationId xmlns:a16="http://schemas.microsoft.com/office/drawing/2014/main" id="{252382E5-3A6D-6EBC-76DC-A45C4261DCC4}"/>
+              </a:ext>
+            </a:extLst>
+          </p:cNvPr>
+          <p:cNvSpPr txBox="1"/>
+          <p:nvPr/>
+        </p:nvSpPr>
+        <p:spPr>
+          <a:xfrm>
+            <a:off x="2921092" y="1947333"/>
+            <a:ext cx="750526" cy="400110"/>
+          </a:xfrm>
+          <a:prstGeom prst="rect">
+            <a:avLst/>
+          </a:prstGeom>
+          <a:noFill/>
+        </p:spPr>
+        <p:txBody>
+          <a:bodyPr wrap="none" rtlCol="0">
+            <a:spAutoFit/>
+          </a:bodyPr>
+          <a:lstStyle/>
+          <a:p>
+            <a:pPr algn="ctr"/>
+            <a:r>
+              <a:rPr lang="en-US" sz="1000" dirty="0">
+                <a:latin typeface="Verdana" panose="020B0604030504040204" pitchFamily="34" charset="0"/>
+                <a:ea typeface="Verdana" panose="020B0604030504040204" pitchFamily="34" charset="0"/>
+              </a:rPr>
+              <a:t>Business</a:t>
+            </a:r>
+            <a:br>
+              <a:rPr lang="en-US" sz="1000" dirty="0">
+                <a:latin typeface="Verdana" panose="020B0604030504040204" pitchFamily="34" charset="0"/>
+                <a:ea typeface="Verdana" panose="020B0604030504040204" pitchFamily="34" charset="0"/>
+              </a:rPr>
+            </a:br>
+            <a:r>
+              <a:rPr lang="en-US" sz="1000" dirty="0">
+                <a:latin typeface="Verdana" panose="020B0604030504040204" pitchFamily="34" charset="0"/>
+                <a:ea typeface="Verdana" panose="020B0604030504040204" pitchFamily="34" charset="0"/>
+              </a:rPr>
+              <a:t>Analyst</a:t>
+            </a:r>
+          </a:p>
+        </p:txBody>
+      </p:sp>
+      <p:sp>
+        <p:nvSpPr>
+          <p:cNvPr id="12" name="Arrow: Left-Right-Up 11">
+            <a:extLst>
+              <a:ext uri="{FF2B5EF4-FFF2-40B4-BE49-F238E27FC236}">
+                <a16:creationId xmlns:a16="http://schemas.microsoft.com/office/drawing/2014/main" id="{B80FD71B-E0E8-213C-C681-1D314E157057}"/>
+              </a:ext>
+            </a:extLst>
+          </p:cNvPr>
+          <p:cNvSpPr/>
+          <p:nvPr/>
+        </p:nvSpPr>
+        <p:spPr>
+          <a:xfrm flipV="1">
+            <a:off x="2219040" y="1504243"/>
+            <a:ext cx="628904" cy="1859845"/>
+          </a:xfrm>
+          <a:prstGeom prst="leftRightUpArrow">
+            <a:avLst>
+              <a:gd name="adj1" fmla="val 15335"/>
+              <a:gd name="adj2" fmla="val 19597"/>
+              <a:gd name="adj3" fmla="val 19357"/>
+            </a:avLst>
+          </a:prstGeom>
+          <a:solidFill>
+            <a:schemeClr val="accent4">
+              <a:lumMod val="20000"/>
+              <a:lumOff val="80000"/>
+            </a:schemeClr>
+          </a:solidFill>
+        </p:spPr>
+        <p:style>
+          <a:lnRef idx="2">
+            <a:schemeClr val="accent1">
+              <a:shade val="15000"/>
+            </a:schemeClr>
+          </a:lnRef>
+          <a:fillRef idx="1">
+            <a:schemeClr val="accent1"/>
+          </a:fillRef>
+          <a:effectRef idx="0">
+            <a:schemeClr val="accent1"/>
+          </a:effectRef>
+          <a:fontRef idx="minor">
+            <a:schemeClr val="lt1"/>
+          </a:fontRef>
+        </p:style>
+        <p:txBody>
+          <a:bodyPr rtlCol="0" anchor="ctr"/>
+          <a:lstStyle/>
+          <a:p>
+            <a:pPr algn="ctr"/>
+            <a:endParaRPr lang="en-US"/>
+          </a:p>
+        </p:txBody>
+      </p:sp>
+      <p:sp>
+        <p:nvSpPr>
+          <p:cNvPr id="13" name="Rectangle: Folded Corner 12">
+            <a:extLst>
+              <a:ext uri="{FF2B5EF4-FFF2-40B4-BE49-F238E27FC236}">
+                <a16:creationId xmlns:a16="http://schemas.microsoft.com/office/drawing/2014/main" id="{0C753335-8ED8-BA9D-9A13-B0FA27330854}"/>
+              </a:ext>
+            </a:extLst>
+          </p:cNvPr>
+          <p:cNvSpPr/>
+          <p:nvPr/>
+        </p:nvSpPr>
+        <p:spPr>
+          <a:xfrm>
+            <a:off x="2369803" y="3517900"/>
+            <a:ext cx="327378" cy="355600"/>
+          </a:xfrm>
+          <a:prstGeom prst="foldedCorner">
+            <a:avLst>
+              <a:gd name="adj" fmla="val 29325"/>
+            </a:avLst>
+          </a:prstGeom>
+          <a:solidFill>
+            <a:schemeClr val="bg1">
+              <a:lumMod val="95000"/>
+            </a:schemeClr>
+          </a:solidFill>
+          <a:ln w="12700"/>
+        </p:spPr>
+        <p:style>
+          <a:lnRef idx="2">
+            <a:schemeClr val="accent1">
+              <a:shade val="15000"/>
+            </a:schemeClr>
+          </a:lnRef>
+          <a:fillRef idx="1">
+            <a:schemeClr val="accent1"/>
+          </a:fillRef>
+          <a:effectRef idx="0">
+            <a:schemeClr val="accent1"/>
+          </a:effectRef>
+          <a:fontRef idx="minor">
+            <a:schemeClr val="lt1"/>
+          </a:fontRef>
+        </p:style>
+        <p:txBody>
+          <a:bodyPr rtlCol="0" anchor="ctr"/>
+          <a:lstStyle/>
+          <a:p>
+            <a:pPr algn="ctr"/>
+            <a:endParaRPr lang="en-US"/>
+          </a:p>
+        </p:txBody>
+      </p:sp>
+      <p:sp>
+        <p:nvSpPr>
+          <p:cNvPr id="14" name="Rectangle 13">
+            <a:extLst>
+              <a:ext uri="{FF2B5EF4-FFF2-40B4-BE49-F238E27FC236}">
+                <a16:creationId xmlns:a16="http://schemas.microsoft.com/office/drawing/2014/main" id="{D1AA85BC-711B-9892-4B1D-25A1F4C5CC44}"/>
+              </a:ext>
+            </a:extLst>
+          </p:cNvPr>
+          <p:cNvSpPr/>
+          <p:nvPr/>
+        </p:nvSpPr>
+        <p:spPr>
+          <a:xfrm>
+            <a:off x="2456542" y="3572014"/>
+            <a:ext cx="45719" cy="61402"/>
+          </a:xfrm>
+          <a:prstGeom prst="rect">
+            <a:avLst/>
+          </a:prstGeom>
+          <a:solidFill>
+            <a:schemeClr val="bg1"/>
+          </a:solidFill>
+          <a:ln w="12700"/>
+        </p:spPr>
+        <p:style>
+          <a:lnRef idx="2">
+            <a:schemeClr val="accent1">
+              <a:shade val="15000"/>
+            </a:schemeClr>
+          </a:lnRef>
+          <a:fillRef idx="1">
+            <a:schemeClr val="accent1"/>
+          </a:fillRef>
+          <a:effectRef idx="0">
+            <a:schemeClr val="accent1"/>
+          </a:effectRef>
+          <a:fontRef idx="minor">
+            <a:schemeClr val="lt1"/>
+          </a:fontRef>
+        </p:style>
+        <p:txBody>
+          <a:bodyPr rtlCol="0" anchor="ctr"/>
+          <a:lstStyle/>
+          <a:p>
+            <a:pPr algn="ctr"/>
+            <a:endParaRPr lang="en-US"/>
+          </a:p>
+        </p:txBody>
+      </p:sp>
+      <p:sp>
+        <p:nvSpPr>
+          <p:cNvPr id="15" name="Rectangle 14">
+            <a:extLst>
+              <a:ext uri="{FF2B5EF4-FFF2-40B4-BE49-F238E27FC236}">
+                <a16:creationId xmlns:a16="http://schemas.microsoft.com/office/drawing/2014/main" id="{F83C7784-D835-7C4B-C551-CF71CC88A63C}"/>
+              </a:ext>
+            </a:extLst>
+          </p:cNvPr>
+          <p:cNvSpPr/>
+          <p:nvPr/>
+        </p:nvSpPr>
+        <p:spPr>
+          <a:xfrm>
+            <a:off x="2564275" y="3572753"/>
+            <a:ext cx="45719" cy="61402"/>
+          </a:xfrm>
+          <a:prstGeom prst="rect">
+            <a:avLst/>
+          </a:prstGeom>
+          <a:solidFill>
+            <a:schemeClr val="bg1"/>
+          </a:solidFill>
+          <a:ln w="12700"/>
+        </p:spPr>
+        <p:style>
+          <a:lnRef idx="2">
+            <a:schemeClr val="accent1">
+              <a:shade val="15000"/>
+            </a:schemeClr>
+          </a:lnRef>
+          <a:fillRef idx="1">
+            <a:schemeClr val="accent1"/>
+          </a:fillRef>
+          <a:effectRef idx="0">
+            <a:schemeClr val="accent1"/>
+          </a:effectRef>
+          <a:fontRef idx="minor">
+            <a:schemeClr val="lt1"/>
+          </a:fontRef>
+        </p:style>
+        <p:txBody>
+          <a:bodyPr rtlCol="0" anchor="ctr"/>
+          <a:lstStyle/>
+          <a:p>
+            <a:pPr algn="ctr"/>
+            <a:endParaRPr lang="en-US"/>
+          </a:p>
+        </p:txBody>
+      </p:sp>
+      <p:sp>
+        <p:nvSpPr>
+          <p:cNvPr id="16" name="Rectangle 15">
+            <a:extLst>
+              <a:ext uri="{FF2B5EF4-FFF2-40B4-BE49-F238E27FC236}">
+                <a16:creationId xmlns:a16="http://schemas.microsoft.com/office/drawing/2014/main" id="{0DA0C403-3DF0-D37E-A083-D3F6724BC84B}"/>
+              </a:ext>
+            </a:extLst>
+          </p:cNvPr>
+          <p:cNvSpPr/>
+          <p:nvPr/>
+        </p:nvSpPr>
+        <p:spPr>
+          <a:xfrm>
+            <a:off x="2450552" y="3705366"/>
+            <a:ext cx="45719" cy="61402"/>
+          </a:xfrm>
+          <a:prstGeom prst="rect">
+            <a:avLst/>
+          </a:prstGeom>
+          <a:solidFill>
+            <a:schemeClr val="bg1"/>
+          </a:solidFill>
+          <a:ln w="12700"/>
+        </p:spPr>
+        <p:style>
+          <a:lnRef idx="2">
+            <a:schemeClr val="accent1">
+              <a:shade val="15000"/>
+            </a:schemeClr>
+          </a:lnRef>
+          <a:fillRef idx="1">
+            <a:schemeClr val="accent1"/>
+          </a:fillRef>
+          <a:effectRef idx="0">
+            <a:schemeClr val="accent1"/>
+          </a:effectRef>
+          <a:fontRef idx="minor">
+            <a:schemeClr val="lt1"/>
+          </a:fontRef>
+        </p:style>
+        <p:txBody>
+          <a:bodyPr rtlCol="0" anchor="ctr"/>
+          <a:lstStyle/>
+          <a:p>
+            <a:pPr algn="ctr"/>
+            <a:endParaRPr lang="en-US"/>
+          </a:p>
+        </p:txBody>
+      </p:sp>
+      <p:cxnSp>
+        <p:nvCxnSpPr>
+          <p:cNvPr id="18" name="Straight Connector 17">
+            <a:extLst>
+              <a:ext uri="{FF2B5EF4-FFF2-40B4-BE49-F238E27FC236}">
+                <a16:creationId xmlns:a16="http://schemas.microsoft.com/office/drawing/2014/main" id="{E052AA15-76EB-F729-25E5-226BC898C784}"/>
+              </a:ext>
+            </a:extLst>
+          </p:cNvPr>
+          <p:cNvCxnSpPr>
+            <a:cxnSpLocks/>
+            <a:stCxn id="15" idx="1"/>
+            <a:endCxn id="14" idx="3"/>
+          </p:cNvCxnSpPr>
+          <p:nvPr/>
+        </p:nvCxnSpPr>
+        <p:spPr>
+          <a:xfrm flipH="1" flipV="1">
+            <a:off x="2502261" y="3602715"/>
+            <a:ext cx="62014" cy="739"/>
+          </a:xfrm>
+          <a:prstGeom prst="line">
+            <a:avLst/>
+          </a:prstGeom>
+          <a:ln w="12700"/>
+        </p:spPr>
+        <p:style>
+          <a:lnRef idx="2">
+            <a:schemeClr val="accent1"/>
+          </a:lnRef>
+          <a:fillRef idx="0">
+            <a:schemeClr val="accent1"/>
+          </a:fillRef>
+          <a:effectRef idx="1">
+            <a:schemeClr val="accent1"/>
+          </a:effectRef>
+          <a:fontRef idx="minor">
+            <a:schemeClr val="tx1"/>
+          </a:fontRef>
+        </p:style>
+      </p:cxnSp>
+      <p:cxnSp>
+        <p:nvCxnSpPr>
+          <p:cNvPr id="20" name="Straight Connector 19">
+            <a:extLst>
+              <a:ext uri="{FF2B5EF4-FFF2-40B4-BE49-F238E27FC236}">
+                <a16:creationId xmlns:a16="http://schemas.microsoft.com/office/drawing/2014/main" id="{65FD14F3-50FE-0182-B835-4C264CCD3276}"/>
+              </a:ext>
+            </a:extLst>
+          </p:cNvPr>
+          <p:cNvCxnSpPr>
+            <a:cxnSpLocks/>
+            <a:stCxn id="14" idx="2"/>
+            <a:endCxn id="16" idx="0"/>
+          </p:cNvCxnSpPr>
+          <p:nvPr/>
+        </p:nvCxnSpPr>
+        <p:spPr>
+          <a:xfrm flipH="1">
+            <a:off x="2473412" y="3633416"/>
+            <a:ext cx="5990" cy="71950"/>
+          </a:xfrm>
+          <a:prstGeom prst="line">
+            <a:avLst/>
+          </a:prstGeom>
+          <a:ln w="12700"/>
+        </p:spPr>
+        <p:style>
+          <a:lnRef idx="2">
+            <a:schemeClr val="accent1"/>
+          </a:lnRef>
+          <a:fillRef idx="0">
+            <a:schemeClr val="accent1"/>
+          </a:fillRef>
+          <a:effectRef idx="1">
+            <a:schemeClr val="accent1"/>
+          </a:effectRef>
+          <a:fontRef idx="minor">
+            <a:schemeClr val="tx1"/>
+          </a:fontRef>
+        </p:style>
+      </p:cxnSp>
+      <p:sp>
+        <p:nvSpPr>
+          <p:cNvPr id="28" name="Freeform: Shape 27">
+            <a:extLst>
+              <a:ext uri="{FF2B5EF4-FFF2-40B4-BE49-F238E27FC236}">
+                <a16:creationId xmlns:a16="http://schemas.microsoft.com/office/drawing/2014/main" id="{DF001677-4818-744C-8865-6E36DCCA8847}"/>
+              </a:ext>
+            </a:extLst>
+          </p:cNvPr>
+          <p:cNvSpPr/>
+          <p:nvPr/>
+        </p:nvSpPr>
+        <p:spPr>
+          <a:xfrm>
+            <a:off x="2014668" y="2692400"/>
+            <a:ext cx="309431" cy="2101850"/>
+          </a:xfrm>
+          <a:custGeom>
+            <a:avLst/>
+            <a:gdLst>
+              <a:gd name="connsiteX0" fmla="*/ 0 w 412750"/>
+              <a:gd name="connsiteY0" fmla="*/ 0 h 2051050"/>
+              <a:gd name="connsiteX1" fmla="*/ 412750 w 412750"/>
+              <a:gd name="connsiteY1" fmla="*/ 800100 h 2051050"/>
+              <a:gd name="connsiteX2" fmla="*/ 406400 w 412750"/>
+              <a:gd name="connsiteY2" fmla="*/ 1162050 h 2051050"/>
+              <a:gd name="connsiteX3" fmla="*/ 19050 w 412750"/>
+              <a:gd name="connsiteY3" fmla="*/ 2051050 h 2051050"/>
+              <a:gd name="connsiteX4" fmla="*/ 0 w 412750"/>
+              <a:gd name="connsiteY4" fmla="*/ 0 h 2051050"/>
+            </a:gdLst>
+            <a:ahLst/>
+            <a:cxnLst>
+              <a:cxn ang="0">
+                <a:pos x="connsiteX0" y="connsiteY0"/>
+              </a:cxn>
+              <a:cxn ang="0">
+                <a:pos x="connsiteX1" y="connsiteY1"/>
+              </a:cxn>
+              <a:cxn ang="0">
+                <a:pos x="connsiteX2" y="connsiteY2"/>
+              </a:cxn>
+              <a:cxn ang="0">
+                <a:pos x="connsiteX3" y="connsiteY3"/>
+              </a:cxn>
+              <a:cxn ang="0">
+                <a:pos x="connsiteX4" y="connsiteY4"/>
+              </a:cxn>
+            </a:cxnLst>
+            <a:rect l="l" t="t" r="r" b="b"/>
+            <a:pathLst>
+              <a:path w="412750" h="2051050">
+                <a:moveTo>
+                  <a:pt x="0" y="0"/>
+                </a:moveTo>
+                <a:lnTo>
+                  <a:pt x="412750" y="800100"/>
+                </a:lnTo>
+                <a:lnTo>
+                  <a:pt x="406400" y="1162050"/>
+                </a:lnTo>
+                <a:lnTo>
+                  <a:pt x="19050" y="2051050"/>
+                </a:lnTo>
+                <a:lnTo>
+                  <a:pt x="0" y="0"/>
+                </a:lnTo>
+                <a:close/>
+              </a:path>
+            </a:pathLst>
+          </a:custGeom>
+          <a:solidFill>
+            <a:schemeClr val="bg1">
+              <a:lumMod val="85000"/>
+            </a:schemeClr>
+          </a:solidFill>
+          <a:ln>
+            <a:noFill/>
+          </a:ln>
+        </p:spPr>
+        <p:style>
+          <a:lnRef idx="2">
+            <a:schemeClr val="accent1">
+              <a:shade val="15000"/>
+            </a:schemeClr>
+          </a:lnRef>
+          <a:fillRef idx="1">
+            <a:schemeClr val="accent1"/>
+          </a:fillRef>
+          <a:effectRef idx="0">
+            <a:schemeClr val="accent1"/>
+          </a:effectRef>
+          <a:fontRef idx="minor">
+            <a:schemeClr val="lt1"/>
+          </a:fontRef>
+        </p:style>
+        <p:txBody>
+          <a:bodyPr rtlCol="0" anchor="ctr"/>
+          <a:lstStyle/>
+          <a:p>
+            <a:pPr algn="ctr"/>
+            <a:endParaRPr lang="en-US"/>
+          </a:p>
+        </p:txBody>
+      </p:sp>
+      <p:sp>
+        <p:nvSpPr>
+          <p:cNvPr id="29" name="TextBox 28">
+            <a:extLst>
+              <a:ext uri="{FF2B5EF4-FFF2-40B4-BE49-F238E27FC236}">
+                <a16:creationId xmlns:a16="http://schemas.microsoft.com/office/drawing/2014/main" id="{0FFED269-3352-8944-9DA6-D24529252ABE}"/>
+              </a:ext>
+            </a:extLst>
+          </p:cNvPr>
+          <p:cNvSpPr txBox="1"/>
+          <p:nvPr/>
+        </p:nvSpPr>
+        <p:spPr>
+          <a:xfrm>
+            <a:off x="184222" y="4824620"/>
+            <a:ext cx="2139877" cy="553998"/>
+          </a:xfrm>
+          <a:prstGeom prst="rect">
+            <a:avLst/>
+          </a:prstGeom>
+          <a:noFill/>
+        </p:spPr>
+        <p:txBody>
+          <a:bodyPr wrap="square" rtlCol="0">
+            <a:spAutoFit/>
+          </a:bodyPr>
+          <a:lstStyle/>
+          <a:p>
+            <a:pPr algn="ctr"/>
+            <a:r>
+              <a:rPr lang="en-US" sz="1000" dirty="0">
+                <a:latin typeface="Verdana" panose="020B0604030504040204" pitchFamily="34" charset="0"/>
+                <a:ea typeface="Verdana" panose="020B0604030504040204" pitchFamily="34" charset="0"/>
+              </a:rPr>
+              <a:t>Business Domain Model depicting API data resources, fields, and relationships</a:t>
+            </a:r>
+          </a:p>
+        </p:txBody>
+      </p:sp>
+      <p:sp>
+        <p:nvSpPr>
+          <p:cNvPr id="30" name="Rectangle: Rounded Corners 29">
+            <a:extLst>
+              <a:ext uri="{FF2B5EF4-FFF2-40B4-BE49-F238E27FC236}">
+                <a16:creationId xmlns:a16="http://schemas.microsoft.com/office/drawing/2014/main" id="{D2617177-A654-291C-96AF-5F18767D6D00}"/>
+              </a:ext>
+            </a:extLst>
+          </p:cNvPr>
+          <p:cNvSpPr/>
+          <p:nvPr/>
+        </p:nvSpPr>
+        <p:spPr>
+          <a:xfrm>
+            <a:off x="2886780" y="4171950"/>
+            <a:ext cx="819150" cy="622300"/>
+          </a:xfrm>
+          <a:prstGeom prst="roundRect">
+            <a:avLst/>
+          </a:prstGeom>
+          <a:solidFill>
+            <a:schemeClr val="bg1">
+              <a:lumMod val="95000"/>
+            </a:schemeClr>
+          </a:solidFill>
+          <a:effectLst>
+            <a:outerShdw blurRad="50800" dist="38100" dir="2700000" algn="tl" rotWithShape="0">
+              <a:prstClr val="black">
+                <a:alpha val="40000"/>
+              </a:prstClr>
+            </a:outerShdw>
+          </a:effectLst>
+        </p:spPr>
+        <p:style>
+          <a:lnRef idx="2">
+            <a:schemeClr val="accent1">
+              <a:shade val="15000"/>
+            </a:schemeClr>
+          </a:lnRef>
+          <a:fillRef idx="1">
+            <a:schemeClr val="accent1"/>
+          </a:fillRef>
+          <a:effectRef idx="0">
+            <a:schemeClr val="accent1"/>
+          </a:effectRef>
+          <a:fontRef idx="minor">
+            <a:schemeClr val="lt1"/>
+          </a:fontRef>
+        </p:style>
+        <p:txBody>
+          <a:bodyPr lIns="45720" rIns="45720" rtlCol="0" anchor="ctr"/>
+          <a:lstStyle/>
+          <a:p>
+            <a:pPr algn="ctr"/>
+            <a:r>
+              <a:rPr lang="en-US" sz="1200" dirty="0">
+                <a:solidFill>
+                  <a:schemeClr val="tx1"/>
+                </a:solidFill>
+              </a:rPr>
+              <a:t>API Spec Generator Tool</a:t>
+            </a:r>
+          </a:p>
+        </p:txBody>
+      </p:sp>
+      <p:sp>
+        <p:nvSpPr>
+          <p:cNvPr id="31" name="Arrow: Bent-Up 30">
+            <a:extLst>
+              <a:ext uri="{FF2B5EF4-FFF2-40B4-BE49-F238E27FC236}">
+                <a16:creationId xmlns:a16="http://schemas.microsoft.com/office/drawing/2014/main" id="{88B40475-9179-96C6-764E-0BC1FF9FB75B}"/>
+              </a:ext>
+            </a:extLst>
+          </p:cNvPr>
+          <p:cNvSpPr/>
+          <p:nvPr/>
+        </p:nvSpPr>
+        <p:spPr>
+          <a:xfrm rot="5400000">
+            <a:off x="2340721" y="4126183"/>
+            <a:ext cx="566040" cy="327378"/>
+          </a:xfrm>
+          <a:prstGeom prst="bentUpArrow">
+            <a:avLst/>
+          </a:prstGeom>
+          <a:solidFill>
+            <a:srgbClr val="CAEEFB"/>
+          </a:solidFill>
+        </p:spPr>
+        <p:style>
+          <a:lnRef idx="2">
+            <a:schemeClr val="accent1">
+              <a:shade val="15000"/>
+            </a:schemeClr>
+          </a:lnRef>
+          <a:fillRef idx="1">
+            <a:schemeClr val="accent1"/>
+          </a:fillRef>
+          <a:effectRef idx="0">
+            <a:schemeClr val="accent1"/>
+          </a:effectRef>
+          <a:fontRef idx="minor">
+            <a:schemeClr val="lt1"/>
+          </a:fontRef>
+        </p:style>
+        <p:txBody>
+          <a:bodyPr rtlCol="0" anchor="ctr"/>
+          <a:lstStyle/>
+          <a:p>
+            <a:pPr algn="ctr"/>
+            <a:endParaRPr lang="en-US"/>
+          </a:p>
+        </p:txBody>
+      </p:sp>
+      <p:cxnSp>
+        <p:nvCxnSpPr>
+          <p:cNvPr id="36" name="Straight Arrow Connector 35">
+            <a:extLst>
+              <a:ext uri="{FF2B5EF4-FFF2-40B4-BE49-F238E27FC236}">
+                <a16:creationId xmlns:a16="http://schemas.microsoft.com/office/drawing/2014/main" id="{85211883-0874-FF4A-D3D7-5D82604C2AF7}"/>
+              </a:ext>
+            </a:extLst>
+          </p:cNvPr>
+          <p:cNvCxnSpPr/>
+          <p:nvPr/>
+        </p:nvCxnSpPr>
+        <p:spPr>
+          <a:xfrm>
+            <a:off x="3296355" y="2411588"/>
+            <a:ext cx="0" cy="1593850"/>
+          </a:xfrm>
+          <a:prstGeom prst="straightConnector1">
+            <a:avLst/>
+          </a:prstGeom>
+          <a:ln>
+            <a:prstDash val="dash"/>
+            <a:headEnd type="none" w="med" len="med"/>
+            <a:tailEnd type="triangle" w="lg" len="med"/>
+          </a:ln>
+        </p:spPr>
+        <p:style>
+          <a:lnRef idx="2">
+            <a:schemeClr val="accent1"/>
+          </a:lnRef>
+          <a:fillRef idx="0">
+            <a:schemeClr val="accent1"/>
+          </a:fillRef>
+          <a:effectRef idx="1">
+            <a:schemeClr val="accent1"/>
+          </a:effectRef>
+          <a:fontRef idx="minor">
+            <a:schemeClr val="tx1"/>
+          </a:fontRef>
+        </p:style>
+      </p:cxnSp>
+      <p:sp>
+        <p:nvSpPr>
+          <p:cNvPr id="37" name="Oval 36">
+            <a:extLst>
+              <a:ext uri="{FF2B5EF4-FFF2-40B4-BE49-F238E27FC236}">
+                <a16:creationId xmlns:a16="http://schemas.microsoft.com/office/drawing/2014/main" id="{6B0CC831-BD9C-AE6D-9CC3-310C9B55B21C}"/>
+              </a:ext>
+            </a:extLst>
+          </p:cNvPr>
+          <p:cNvSpPr/>
+          <p:nvPr/>
+        </p:nvSpPr>
+        <p:spPr>
+          <a:xfrm>
+            <a:off x="2420761" y="2377927"/>
+            <a:ext cx="222250" cy="222250"/>
+          </a:xfrm>
+          <a:prstGeom prst="ellipse">
+            <a:avLst/>
+          </a:prstGeom>
+          <a:solidFill>
+            <a:srgbClr val="FFFF66"/>
+          </a:solidFill>
+          <a:ln w="12700"/>
+        </p:spPr>
+        <p:style>
+          <a:lnRef idx="2">
+            <a:schemeClr val="accent1">
+              <a:shade val="15000"/>
+            </a:schemeClr>
+          </a:lnRef>
+          <a:fillRef idx="1">
+            <a:schemeClr val="accent1"/>
+          </a:fillRef>
+          <a:effectRef idx="0">
+            <a:schemeClr val="accent1"/>
+          </a:effectRef>
+          <a:fontRef idx="minor">
+            <a:schemeClr val="lt1"/>
+          </a:fontRef>
+        </p:style>
+        <p:txBody>
+          <a:bodyPr lIns="45720" rIns="45720" rtlCol="0" anchor="ctr"/>
+          <a:lstStyle/>
+          <a:p>
+            <a:pPr algn="ctr"/>
+            <a:r>
+              <a:rPr lang="en-US" sz="1000" b="1" dirty="0">
+                <a:solidFill>
+                  <a:schemeClr val="tx1"/>
+                </a:solidFill>
+              </a:rPr>
+              <a:t>1</a:t>
+            </a:r>
+            <a:endParaRPr lang="en-US" sz="800" b="1" dirty="0">
+              <a:solidFill>
+                <a:schemeClr val="tx1"/>
+              </a:solidFill>
+            </a:endParaRPr>
+          </a:p>
+        </p:txBody>
+      </p:sp>
+      <p:sp>
+        <p:nvSpPr>
+          <p:cNvPr id="38" name="Oval 37">
+            <a:extLst>
+              <a:ext uri="{FF2B5EF4-FFF2-40B4-BE49-F238E27FC236}">
+                <a16:creationId xmlns:a16="http://schemas.microsoft.com/office/drawing/2014/main" id="{069BA5F3-B483-461D-CCDA-2BE85B31A497}"/>
+              </a:ext>
+            </a:extLst>
+          </p:cNvPr>
+          <p:cNvSpPr/>
+          <p:nvPr/>
+        </p:nvSpPr>
+        <p:spPr>
+          <a:xfrm>
+            <a:off x="3185230" y="3278620"/>
+            <a:ext cx="222250" cy="222250"/>
+          </a:xfrm>
+          <a:prstGeom prst="ellipse">
+            <a:avLst/>
+          </a:prstGeom>
+          <a:solidFill>
+            <a:srgbClr val="FFFF66"/>
+          </a:solidFill>
+          <a:ln w="12700"/>
+        </p:spPr>
+        <p:style>
+          <a:lnRef idx="2">
+            <a:schemeClr val="accent1">
+              <a:shade val="15000"/>
+            </a:schemeClr>
+          </a:lnRef>
+          <a:fillRef idx="1">
+            <a:schemeClr val="accent1"/>
+          </a:fillRef>
+          <a:effectRef idx="0">
+            <a:schemeClr val="accent1"/>
+          </a:effectRef>
+          <a:fontRef idx="minor">
+            <a:schemeClr val="lt1"/>
+          </a:fontRef>
+        </p:style>
+        <p:txBody>
+          <a:bodyPr lIns="45720" rIns="45720" rtlCol="0" anchor="ctr"/>
+          <a:lstStyle/>
+          <a:p>
+            <a:pPr algn="ctr"/>
+            <a:r>
+              <a:rPr lang="en-US" sz="1000" b="1" dirty="0">
+                <a:solidFill>
+                  <a:schemeClr val="tx1"/>
+                </a:solidFill>
+              </a:rPr>
+              <a:t>2</a:t>
+            </a:r>
+            <a:endParaRPr lang="en-US" sz="800" b="1" dirty="0">
+              <a:solidFill>
+                <a:schemeClr val="tx1"/>
+              </a:solidFill>
+            </a:endParaRPr>
+          </a:p>
+        </p:txBody>
+      </p:sp>
+      <p:sp>
+        <p:nvSpPr>
+          <p:cNvPr id="57" name="Rectangle: Rounded Corners 56">
+            <a:extLst>
+              <a:ext uri="{FF2B5EF4-FFF2-40B4-BE49-F238E27FC236}">
+                <a16:creationId xmlns:a16="http://schemas.microsoft.com/office/drawing/2014/main" id="{88A82881-0D00-D919-F9CF-C8D2BDB16332}"/>
+              </a:ext>
+            </a:extLst>
+          </p:cNvPr>
+          <p:cNvSpPr/>
+          <p:nvPr/>
+        </p:nvSpPr>
+        <p:spPr>
+          <a:xfrm>
+            <a:off x="4401310" y="920045"/>
+            <a:ext cx="2482090" cy="4553656"/>
+          </a:xfrm>
+          <a:prstGeom prst="roundRect">
+            <a:avLst>
+              <a:gd name="adj" fmla="val 4546"/>
+            </a:avLst>
+          </a:prstGeom>
+          <a:solidFill>
+            <a:srgbClr val="DCEAF7"/>
+          </a:solidFill>
+          <a:ln>
+            <a:noFill/>
+          </a:ln>
+        </p:spPr>
+        <p:style>
+          <a:lnRef idx="2">
+            <a:schemeClr val="accent1">
+              <a:shade val="15000"/>
+            </a:schemeClr>
+          </a:lnRef>
+          <a:fillRef idx="1">
+            <a:schemeClr val="accent1"/>
+          </a:fillRef>
+          <a:effectRef idx="0">
+            <a:schemeClr val="accent1"/>
+          </a:effectRef>
+          <a:fontRef idx="minor">
+            <a:schemeClr val="lt1"/>
+          </a:fontRef>
+        </p:style>
+        <p:txBody>
+          <a:bodyPr rtlCol="0" anchor="ctr"/>
+          <a:lstStyle/>
+          <a:p>
+            <a:pPr algn="ctr"/>
+            <a:endParaRPr lang="en-US"/>
+          </a:p>
+        </p:txBody>
+      </p:sp>
+      <p:grpSp>
+        <p:nvGrpSpPr>
+          <p:cNvPr id="53" name="Group 52">
+            <a:extLst>
+              <a:ext uri="{FF2B5EF4-FFF2-40B4-BE49-F238E27FC236}">
+                <a16:creationId xmlns:a16="http://schemas.microsoft.com/office/drawing/2014/main" id="{D29875BD-862C-9BFF-00CA-224EDF9D3F11}"/>
+              </a:ext>
+            </a:extLst>
+          </p:cNvPr>
+          <p:cNvGrpSpPr/>
+          <p:nvPr/>
+        </p:nvGrpSpPr>
+        <p:grpSpPr>
+          <a:xfrm>
+            <a:off x="4838700" y="4271887"/>
+            <a:ext cx="279400" cy="422426"/>
+            <a:chOff x="4508500" y="4271887"/>
+            <a:chExt cx="279400" cy="422426"/>
+          </a:xfrm>
+        </p:grpSpPr>
+        <p:sp>
+          <p:nvSpPr>
+            <p:cNvPr id="39" name="Rectangle: Folded Corner 38">
+              <a:extLst>
+                <a:ext uri="{FF2B5EF4-FFF2-40B4-BE49-F238E27FC236}">
+                  <a16:creationId xmlns:a16="http://schemas.microsoft.com/office/drawing/2014/main" id="{1A656027-B041-00CA-8AE8-4A2C3DCB5761}"/>
+                </a:ext>
+              </a:extLst>
+            </p:cNvPr>
+            <p:cNvSpPr/>
+            <p:nvPr/>
+          </p:nvSpPr>
+          <p:spPr>
+            <a:xfrm>
+              <a:off x="4508500" y="4271887"/>
+              <a:ext cx="279400" cy="422426"/>
+            </a:xfrm>
+            <a:prstGeom prst="foldedCorner">
+              <a:avLst>
+                <a:gd name="adj" fmla="val 33334"/>
+              </a:avLst>
+            </a:prstGeom>
+            <a:solidFill>
+              <a:schemeClr val="bg1">
+                <a:lumMod val="95000"/>
+              </a:schemeClr>
+            </a:solidFill>
+            <a:ln w="12700"/>
+          </p:spPr>
+          <p:style>
+            <a:lnRef idx="2">
+              <a:schemeClr val="accent1">
+                <a:shade val="15000"/>
+              </a:schemeClr>
+            </a:lnRef>
+            <a:fillRef idx="1">
+              <a:schemeClr val="accent1"/>
+            </a:fillRef>
+            <a:effectRef idx="0">
+              <a:schemeClr val="accent1"/>
+            </a:effectRef>
+            <a:fontRef idx="minor">
+              <a:schemeClr val="lt1"/>
+            </a:fontRef>
+          </p:style>
+          <p:txBody>
+            <a:bodyPr rtlCol="0" anchor="ctr"/>
+            <a:lstStyle/>
+            <a:p>
+              <a:pPr algn="ctr"/>
+              <a:endParaRPr lang="en-US"/>
+            </a:p>
+          </p:txBody>
+        </p:sp>
+        <p:cxnSp>
+          <p:nvCxnSpPr>
+            <p:cNvPr id="42" name="Straight Connector 41">
+              <a:extLst>
+                <a:ext uri="{FF2B5EF4-FFF2-40B4-BE49-F238E27FC236}">
+                  <a16:creationId xmlns:a16="http://schemas.microsoft.com/office/drawing/2014/main" id="{1FD21157-9951-C9A6-5A34-E5893ACE556A}"/>
+                </a:ext>
+              </a:extLst>
+            </p:cNvPr>
+            <p:cNvCxnSpPr/>
+            <p:nvPr/>
+          </p:nvCxnSpPr>
+          <p:spPr>
+            <a:xfrm>
+              <a:off x="4548414" y="4333404"/>
+              <a:ext cx="192919" cy="0"/>
+            </a:xfrm>
+            <a:prstGeom prst="line">
+              <a:avLst/>
+            </a:prstGeom>
+          </p:spPr>
+          <p:style>
+            <a:lnRef idx="2">
+              <a:schemeClr val="accent1"/>
+            </a:lnRef>
+            <a:fillRef idx="0">
+              <a:schemeClr val="accent1"/>
+            </a:fillRef>
+            <a:effectRef idx="1">
+              <a:schemeClr val="accent1"/>
+            </a:effectRef>
+            <a:fontRef idx="minor">
+              <a:schemeClr val="tx1"/>
+            </a:fontRef>
+          </p:style>
+        </p:cxnSp>
+        <p:cxnSp>
+          <p:nvCxnSpPr>
+            <p:cNvPr id="43" name="Straight Connector 42">
+              <a:extLst>
+                <a:ext uri="{FF2B5EF4-FFF2-40B4-BE49-F238E27FC236}">
+                  <a16:creationId xmlns:a16="http://schemas.microsoft.com/office/drawing/2014/main" id="{431221CE-5BA0-CE33-03CD-A35035CF6A11}"/>
+                </a:ext>
+              </a:extLst>
+            </p:cNvPr>
+            <p:cNvCxnSpPr>
+              <a:cxnSpLocks/>
+            </p:cNvCxnSpPr>
+            <p:nvPr/>
+          </p:nvCxnSpPr>
+          <p:spPr>
+            <a:xfrm>
+              <a:off x="4548414" y="4396202"/>
+              <a:ext cx="133048" cy="0"/>
+            </a:xfrm>
+            <a:prstGeom prst="line">
+              <a:avLst/>
+            </a:prstGeom>
+          </p:spPr>
+          <p:style>
+            <a:lnRef idx="2">
+              <a:schemeClr val="accent1"/>
+            </a:lnRef>
+            <a:fillRef idx="0">
+              <a:schemeClr val="accent1"/>
+            </a:fillRef>
+            <a:effectRef idx="1">
+              <a:schemeClr val="accent1"/>
+            </a:effectRef>
+            <a:fontRef idx="minor">
+              <a:schemeClr val="tx1"/>
+            </a:fontRef>
+          </p:style>
+        </p:cxnSp>
+        <p:cxnSp>
+          <p:nvCxnSpPr>
+            <p:cNvPr id="45" name="Straight Connector 44">
+              <a:extLst>
+                <a:ext uri="{FF2B5EF4-FFF2-40B4-BE49-F238E27FC236}">
+                  <a16:creationId xmlns:a16="http://schemas.microsoft.com/office/drawing/2014/main" id="{82DF898F-831A-5FA0-1DB1-FE1985E35995}"/>
+                </a:ext>
+              </a:extLst>
+            </p:cNvPr>
+            <p:cNvCxnSpPr/>
+            <p:nvPr/>
+          </p:nvCxnSpPr>
+          <p:spPr>
+            <a:xfrm>
+              <a:off x="4548414" y="4459000"/>
+              <a:ext cx="192919" cy="0"/>
+            </a:xfrm>
+            <a:prstGeom prst="line">
+              <a:avLst/>
+            </a:prstGeom>
+          </p:spPr>
+          <p:style>
+            <a:lnRef idx="2">
+              <a:schemeClr val="accent1"/>
+            </a:lnRef>
+            <a:fillRef idx="0">
+              <a:schemeClr val="accent1"/>
+            </a:fillRef>
+            <a:effectRef idx="1">
+              <a:schemeClr val="accent1"/>
+            </a:effectRef>
+            <a:fontRef idx="minor">
+              <a:schemeClr val="tx1"/>
+            </a:fontRef>
+          </p:style>
+        </p:cxnSp>
+        <p:cxnSp>
+          <p:nvCxnSpPr>
+            <p:cNvPr id="46" name="Straight Connector 45">
+              <a:extLst>
+                <a:ext uri="{FF2B5EF4-FFF2-40B4-BE49-F238E27FC236}">
+                  <a16:creationId xmlns:a16="http://schemas.microsoft.com/office/drawing/2014/main" id="{1E65C5A0-8E29-0032-E010-15C29FCE0806}"/>
+                </a:ext>
+              </a:extLst>
+            </p:cNvPr>
+            <p:cNvCxnSpPr>
+              <a:cxnSpLocks/>
+            </p:cNvCxnSpPr>
+            <p:nvPr/>
+          </p:nvCxnSpPr>
+          <p:spPr>
+            <a:xfrm>
+              <a:off x="4548414" y="4521798"/>
+              <a:ext cx="133048" cy="0"/>
+            </a:xfrm>
+            <a:prstGeom prst="line">
+              <a:avLst/>
+            </a:prstGeom>
+          </p:spPr>
+          <p:style>
+            <a:lnRef idx="2">
+              <a:schemeClr val="accent1"/>
+            </a:lnRef>
+            <a:fillRef idx="0">
+              <a:schemeClr val="accent1"/>
+            </a:fillRef>
+            <a:effectRef idx="1">
+              <a:schemeClr val="accent1"/>
+            </a:effectRef>
+            <a:fontRef idx="minor">
+              <a:schemeClr val="tx1"/>
+            </a:fontRef>
+          </p:style>
+        </p:cxnSp>
+        <p:cxnSp>
+          <p:nvCxnSpPr>
+            <p:cNvPr id="52" name="Straight Connector 51">
+              <a:extLst>
+                <a:ext uri="{FF2B5EF4-FFF2-40B4-BE49-F238E27FC236}">
+                  <a16:creationId xmlns:a16="http://schemas.microsoft.com/office/drawing/2014/main" id="{6A7C63A3-D0AD-9605-FF17-5CA411C122EF}"/>
+                </a:ext>
+              </a:extLst>
+            </p:cNvPr>
+            <p:cNvCxnSpPr>
+              <a:cxnSpLocks/>
+            </p:cNvCxnSpPr>
+            <p:nvPr/>
+          </p:nvCxnSpPr>
+          <p:spPr>
+            <a:xfrm>
+              <a:off x="4548414" y="4584596"/>
+              <a:ext cx="133048" cy="0"/>
+            </a:xfrm>
+            <a:prstGeom prst="line">
+              <a:avLst/>
+            </a:prstGeom>
+          </p:spPr>
+          <p:style>
+            <a:lnRef idx="2">
+              <a:schemeClr val="accent1"/>
+            </a:lnRef>
+            <a:fillRef idx="0">
+              <a:schemeClr val="accent1"/>
+            </a:fillRef>
+            <a:effectRef idx="1">
+              <a:schemeClr val="accent1"/>
+            </a:effectRef>
+            <a:fontRef idx="minor">
+              <a:schemeClr val="tx1"/>
+            </a:fontRef>
+          </p:style>
+        </p:cxnSp>
+      </p:grpSp>
+      <p:grpSp>
+        <p:nvGrpSpPr>
+          <p:cNvPr id="59" name="Group 58">
+            <a:extLst>
+              <a:ext uri="{FF2B5EF4-FFF2-40B4-BE49-F238E27FC236}">
+                <a16:creationId xmlns:a16="http://schemas.microsoft.com/office/drawing/2014/main" id="{07456F6A-EEBB-9541-B518-A7A626BEEEF6}"/>
+              </a:ext>
+            </a:extLst>
+          </p:cNvPr>
+          <p:cNvGrpSpPr/>
+          <p:nvPr/>
+        </p:nvGrpSpPr>
+        <p:grpSpPr>
+          <a:xfrm>
+            <a:off x="5176103" y="1596026"/>
+            <a:ext cx="776665" cy="1341299"/>
+            <a:chOff x="5569803" y="1926226"/>
+            <a:chExt cx="776665" cy="1341299"/>
+          </a:xfrm>
+        </p:grpSpPr>
+        <p:pic>
+          <p:nvPicPr>
+            <p:cNvPr id="56" name="Picture 55" descr="A person sitting in a chair with a computer&#10;&#10;AI-generated content may be incorrect.">
+              <a:extLst>
+                <a:ext uri="{FF2B5EF4-FFF2-40B4-BE49-F238E27FC236}">
+                  <a16:creationId xmlns:a16="http://schemas.microsoft.com/office/drawing/2014/main" id="{0C8BBDA0-D799-B613-B57C-024A25416C5D}"/>
+                </a:ext>
+              </a:extLst>
+            </p:cNvPr>
+            <p:cNvPicPr>
+              <a:picLocks noChangeAspect="1"/>
+            </p:cNvPicPr>
+            <p:nvPr/>
+          </p:nvPicPr>
+          <p:blipFill>
+            <a:blip r:embed="rId6">
+              <a:extLst>
+                <a:ext uri="{28A0092B-C50C-407E-A947-70E740481C1C}">
+                  <a14:useLocalDpi xmlns:a14="http://schemas.microsoft.com/office/drawing/2010/main" val="0"/>
+                </a:ext>
+              </a:extLst>
+            </a:blip>
+            <a:stretch>
+              <a:fillRect/>
+            </a:stretch>
+          </p:blipFill>
+          <p:spPr>
+            <a:xfrm>
+              <a:off x="5569803" y="1926226"/>
+              <a:ext cx="743250" cy="952885"/>
+            </a:xfrm>
+            <a:prstGeom prst="rect">
+              <a:avLst/>
+            </a:prstGeom>
+          </p:spPr>
+        </p:pic>
+        <p:sp>
+          <p:nvSpPr>
+            <p:cNvPr id="58" name="TextBox 57">
+              <a:extLst>
+                <a:ext uri="{FF2B5EF4-FFF2-40B4-BE49-F238E27FC236}">
+                  <a16:creationId xmlns:a16="http://schemas.microsoft.com/office/drawing/2014/main" id="{642FEC64-DBF3-6005-8DA0-699CB5FB7111}"/>
+                </a:ext>
+              </a:extLst>
+            </p:cNvPr>
+            <p:cNvSpPr txBox="1"/>
+            <p:nvPr/>
+          </p:nvSpPr>
+          <p:spPr>
+            <a:xfrm>
+              <a:off x="5587927" y="2867415"/>
+              <a:ext cx="758541" cy="400110"/>
+            </a:xfrm>
+            <a:prstGeom prst="rect">
+              <a:avLst/>
+            </a:prstGeom>
+            <a:noFill/>
+          </p:spPr>
+          <p:txBody>
+            <a:bodyPr wrap="none" rtlCol="0">
+              <a:spAutoFit/>
+            </a:bodyPr>
+            <a:lstStyle/>
+            <a:p>
+              <a:pPr algn="ctr"/>
+              <a:r>
+                <a:rPr lang="en-US" sz="1000" dirty="0">
+                  <a:latin typeface="Verdana" panose="020B0604030504040204" pitchFamily="34" charset="0"/>
+                  <a:ea typeface="Verdana" panose="020B0604030504040204" pitchFamily="34" charset="0"/>
+                </a:rPr>
+                <a:t>Software</a:t>
+              </a:r>
+              <a:br>
+                <a:rPr lang="en-US" sz="1000" dirty="0">
+                  <a:latin typeface="Verdana" panose="020B0604030504040204" pitchFamily="34" charset="0"/>
+                  <a:ea typeface="Verdana" panose="020B0604030504040204" pitchFamily="34" charset="0"/>
+                </a:rPr>
+              </a:br>
+              <a:r>
+                <a:rPr lang="en-US" sz="1000" dirty="0">
+                  <a:latin typeface="Verdana" panose="020B0604030504040204" pitchFamily="34" charset="0"/>
+                  <a:ea typeface="Verdana" panose="020B0604030504040204" pitchFamily="34" charset="0"/>
+                </a:rPr>
+                <a:t>Architect</a:t>
+              </a:r>
+            </a:p>
+          </p:txBody>
+        </p:sp>
+      </p:grpSp>
+      <p:sp>
+        <p:nvSpPr>
+          <p:cNvPr id="64" name="Rectangle: Rounded Corners 63">
+            <a:extLst>
+              <a:ext uri="{FF2B5EF4-FFF2-40B4-BE49-F238E27FC236}">
+                <a16:creationId xmlns:a16="http://schemas.microsoft.com/office/drawing/2014/main" id="{F439670C-4936-1986-DB13-FBE5E5CF30F2}"/>
+              </a:ext>
+            </a:extLst>
+          </p:cNvPr>
+          <p:cNvSpPr/>
+          <p:nvPr/>
+        </p:nvSpPr>
+        <p:spPr>
+          <a:xfrm>
+            <a:off x="5788730" y="4171950"/>
+            <a:ext cx="819150" cy="622300"/>
+          </a:xfrm>
+          <a:prstGeom prst="roundRect">
+            <a:avLst/>
+          </a:prstGeom>
+          <a:solidFill>
+            <a:schemeClr val="bg1">
+              <a:lumMod val="95000"/>
+            </a:schemeClr>
+          </a:solidFill>
+          <a:effectLst>
+            <a:outerShdw blurRad="50800" dist="38100" dir="2700000" algn="tl" rotWithShape="0">
+              <a:prstClr val="black">
+                <a:alpha val="40000"/>
+              </a:prstClr>
+            </a:outerShdw>
+          </a:effectLst>
+        </p:spPr>
+        <p:style>
+          <a:lnRef idx="2">
+            <a:schemeClr val="accent1">
+              <a:shade val="15000"/>
+            </a:schemeClr>
+          </a:lnRef>
+          <a:fillRef idx="1">
+            <a:schemeClr val="accent1"/>
+          </a:fillRef>
+          <a:effectRef idx="0">
+            <a:schemeClr val="accent1"/>
+          </a:effectRef>
+          <a:fontRef idx="minor">
+            <a:schemeClr val="lt1"/>
+          </a:fontRef>
+        </p:style>
+        <p:txBody>
+          <a:bodyPr lIns="45720" rIns="45720" rtlCol="0" anchor="ctr"/>
+          <a:lstStyle/>
+          <a:p>
+            <a:pPr algn="ctr"/>
+            <a:r>
+              <a:rPr lang="en-US" sz="1200" dirty="0">
+                <a:solidFill>
+                  <a:schemeClr val="tx1"/>
+                </a:solidFill>
+              </a:rPr>
+              <a:t>API Code Generator Tool</a:t>
+            </a:r>
+          </a:p>
+        </p:txBody>
+      </p:sp>
+      <p:sp>
+        <p:nvSpPr>
+          <p:cNvPr id="65" name="Arrow: Right 64">
+            <a:extLst>
+              <a:ext uri="{FF2B5EF4-FFF2-40B4-BE49-F238E27FC236}">
+                <a16:creationId xmlns:a16="http://schemas.microsoft.com/office/drawing/2014/main" id="{BB8A6EE8-22F0-D7CF-CD41-5BED2FD2C5AF}"/>
+              </a:ext>
+            </a:extLst>
+          </p:cNvPr>
+          <p:cNvSpPr/>
+          <p:nvPr/>
+        </p:nvSpPr>
+        <p:spPr>
+          <a:xfrm>
+            <a:off x="5224538" y="4394768"/>
+            <a:ext cx="466820" cy="178124"/>
+          </a:xfrm>
+          <a:prstGeom prst="rightArrow">
+            <a:avLst/>
+          </a:prstGeom>
+          <a:solidFill>
+            <a:srgbClr val="CAEEFB"/>
+          </a:solidFill>
+        </p:spPr>
+        <p:style>
+          <a:lnRef idx="2">
+            <a:schemeClr val="accent1">
+              <a:shade val="15000"/>
+            </a:schemeClr>
+          </a:lnRef>
+          <a:fillRef idx="1">
+            <a:schemeClr val="accent1"/>
+          </a:fillRef>
+          <a:effectRef idx="0">
+            <a:schemeClr val="accent1"/>
+          </a:effectRef>
+          <a:fontRef idx="minor">
+            <a:schemeClr val="lt1"/>
+          </a:fontRef>
+        </p:style>
+        <p:txBody>
+          <a:bodyPr rtlCol="0" anchor="ctr"/>
+          <a:lstStyle/>
+          <a:p>
+            <a:pPr algn="ctr"/>
+            <a:endParaRPr lang="en-US"/>
+          </a:p>
+        </p:txBody>
+      </p:sp>
+      <p:grpSp>
+        <p:nvGrpSpPr>
+          <p:cNvPr id="68" name="Group 67">
+            <a:extLst>
+              <a:ext uri="{FF2B5EF4-FFF2-40B4-BE49-F238E27FC236}">
+                <a16:creationId xmlns:a16="http://schemas.microsoft.com/office/drawing/2014/main" id="{EFC374CC-1777-3E38-C614-2CD503F5785B}"/>
+              </a:ext>
+            </a:extLst>
+          </p:cNvPr>
+          <p:cNvGrpSpPr/>
+          <p:nvPr/>
+        </p:nvGrpSpPr>
+        <p:grpSpPr>
+          <a:xfrm>
+            <a:off x="4940300" y="2998842"/>
+            <a:ext cx="1282700" cy="1063392"/>
+            <a:chOff x="5334000" y="2998842"/>
+            <a:chExt cx="1282700" cy="1128658"/>
+          </a:xfrm>
+        </p:grpSpPr>
+        <p:cxnSp>
+          <p:nvCxnSpPr>
+            <p:cNvPr id="61" name="Connector: Elbow 60">
+              <a:extLst>
+                <a:ext uri="{FF2B5EF4-FFF2-40B4-BE49-F238E27FC236}">
+                  <a16:creationId xmlns:a16="http://schemas.microsoft.com/office/drawing/2014/main" id="{5E9448E5-94F5-1A38-646A-C20B9BCB8831}"/>
+                </a:ext>
+              </a:extLst>
+            </p:cNvPr>
+            <p:cNvCxnSpPr>
+              <a:cxnSpLocks/>
+            </p:cNvCxnSpPr>
+            <p:nvPr/>
+          </p:nvCxnSpPr>
+          <p:spPr>
+            <a:xfrm rot="5400000">
+              <a:off x="5090346" y="3242496"/>
+              <a:ext cx="1128658" cy="641350"/>
+            </a:xfrm>
+            <a:prstGeom prst="bentConnector3">
+              <a:avLst>
+                <a:gd name="adj1" fmla="val 35669"/>
+              </a:avLst>
+            </a:prstGeom>
+            <a:ln w="19050">
+              <a:prstDash val="dash"/>
+              <a:tailEnd type="triangle" w="lg" len="med"/>
+            </a:ln>
+          </p:spPr>
+          <p:style>
+            <a:lnRef idx="2">
+              <a:schemeClr val="accent1"/>
+            </a:lnRef>
+            <a:fillRef idx="0">
+              <a:schemeClr val="accent1"/>
+            </a:fillRef>
+            <a:effectRef idx="1">
+              <a:schemeClr val="accent1"/>
+            </a:effectRef>
+            <a:fontRef idx="minor">
+              <a:schemeClr val="tx1"/>
+            </a:fontRef>
+          </p:style>
+        </p:cxnSp>
+        <p:cxnSp>
+          <p:nvCxnSpPr>
+            <p:cNvPr id="67" name="Connector: Elbow 66">
+              <a:extLst>
+                <a:ext uri="{FF2B5EF4-FFF2-40B4-BE49-F238E27FC236}">
+                  <a16:creationId xmlns:a16="http://schemas.microsoft.com/office/drawing/2014/main" id="{C47CC5DD-F8F6-42AF-BBDA-2D6E24A0CF5E}"/>
+                </a:ext>
+              </a:extLst>
+            </p:cNvPr>
+            <p:cNvCxnSpPr>
+              <a:cxnSpLocks/>
+            </p:cNvCxnSpPr>
+            <p:nvPr/>
+          </p:nvCxnSpPr>
+          <p:spPr>
+            <a:xfrm rot="16200000" flipH="1">
+              <a:off x="5731696" y="3242496"/>
+              <a:ext cx="1128658" cy="641350"/>
+            </a:xfrm>
+            <a:prstGeom prst="bentConnector3">
+              <a:avLst>
+                <a:gd name="adj1" fmla="val 36266"/>
+              </a:avLst>
+            </a:prstGeom>
+            <a:ln w="19050">
+              <a:prstDash val="dash"/>
+              <a:tailEnd type="triangle" w="lg" len="med"/>
+            </a:ln>
+          </p:spPr>
+          <p:style>
+            <a:lnRef idx="2">
+              <a:schemeClr val="accent1"/>
+            </a:lnRef>
+            <a:fillRef idx="0">
+              <a:schemeClr val="accent1"/>
+            </a:fillRef>
+            <a:effectRef idx="1">
+              <a:schemeClr val="accent1"/>
+            </a:effectRef>
+            <a:fontRef idx="minor">
+              <a:schemeClr val="tx1"/>
+            </a:fontRef>
+          </p:style>
+        </p:cxnSp>
+      </p:grpSp>
+      <p:sp>
+        <p:nvSpPr>
+          <p:cNvPr id="69" name="Oval 68">
+            <a:extLst>
+              <a:ext uri="{FF2B5EF4-FFF2-40B4-BE49-F238E27FC236}">
+                <a16:creationId xmlns:a16="http://schemas.microsoft.com/office/drawing/2014/main" id="{9829AF0B-C129-AC54-AE56-AF73F22FA565}"/>
+              </a:ext>
+            </a:extLst>
+          </p:cNvPr>
+          <p:cNvSpPr/>
+          <p:nvPr/>
+        </p:nvSpPr>
+        <p:spPr>
+          <a:xfrm>
+            <a:off x="5149850" y="3278620"/>
+            <a:ext cx="222250" cy="222250"/>
+          </a:xfrm>
+          <a:prstGeom prst="ellipse">
+            <a:avLst/>
+          </a:prstGeom>
+          <a:solidFill>
+            <a:srgbClr val="FFFF66"/>
+          </a:solidFill>
+          <a:ln w="12700"/>
+        </p:spPr>
+        <p:style>
+          <a:lnRef idx="2">
+            <a:schemeClr val="accent1">
+              <a:shade val="15000"/>
+            </a:schemeClr>
+          </a:lnRef>
+          <a:fillRef idx="1">
+            <a:schemeClr val="accent1"/>
+          </a:fillRef>
+          <a:effectRef idx="0">
+            <a:schemeClr val="accent1"/>
+          </a:effectRef>
+          <a:fontRef idx="minor">
+            <a:schemeClr val="lt1"/>
+          </a:fontRef>
+        </p:style>
+        <p:txBody>
+          <a:bodyPr lIns="45720" rIns="45720" rtlCol="0" anchor="ctr"/>
+          <a:lstStyle/>
+          <a:p>
+            <a:pPr algn="ctr"/>
+            <a:r>
+              <a:rPr lang="en-US" sz="1000" b="1" dirty="0">
+                <a:solidFill>
+                  <a:schemeClr val="tx1"/>
+                </a:solidFill>
+              </a:rPr>
+              <a:t>3</a:t>
+            </a:r>
+            <a:endParaRPr lang="en-US" sz="800" b="1" dirty="0">
+              <a:solidFill>
+                <a:schemeClr val="tx1"/>
+              </a:solidFill>
+            </a:endParaRPr>
+          </a:p>
+        </p:txBody>
+      </p:sp>
+      <p:sp>
+        <p:nvSpPr>
+          <p:cNvPr id="70" name="Oval 69">
+            <a:extLst>
+              <a:ext uri="{FF2B5EF4-FFF2-40B4-BE49-F238E27FC236}">
+                <a16:creationId xmlns:a16="http://schemas.microsoft.com/office/drawing/2014/main" id="{7138C130-0E8B-923A-5D65-F1CD9AEBCE89}"/>
+              </a:ext>
+            </a:extLst>
+          </p:cNvPr>
+          <p:cNvSpPr/>
+          <p:nvPr/>
+        </p:nvSpPr>
+        <p:spPr>
+          <a:xfrm>
+            <a:off x="5800725" y="3278620"/>
+            <a:ext cx="222250" cy="222250"/>
+          </a:xfrm>
+          <a:prstGeom prst="ellipse">
+            <a:avLst/>
+          </a:prstGeom>
+          <a:solidFill>
+            <a:srgbClr val="FFFF66"/>
+          </a:solidFill>
+          <a:ln w="12700"/>
+        </p:spPr>
+        <p:style>
+          <a:lnRef idx="2">
+            <a:schemeClr val="accent1">
+              <a:shade val="15000"/>
+            </a:schemeClr>
+          </a:lnRef>
+          <a:fillRef idx="1">
+            <a:schemeClr val="accent1"/>
+          </a:fillRef>
+          <a:effectRef idx="0">
+            <a:schemeClr val="accent1"/>
+          </a:effectRef>
+          <a:fontRef idx="minor">
+            <a:schemeClr val="lt1"/>
+          </a:fontRef>
+        </p:style>
+        <p:txBody>
+          <a:bodyPr lIns="45720" rIns="45720" rtlCol="0" anchor="ctr"/>
+          <a:lstStyle/>
+          <a:p>
+            <a:pPr algn="ctr"/>
+            <a:r>
+              <a:rPr lang="en-US" sz="1000" b="1" dirty="0">
+                <a:solidFill>
+                  <a:schemeClr val="tx1"/>
+                </a:solidFill>
+              </a:rPr>
+              <a:t>4</a:t>
+            </a:r>
+            <a:endParaRPr lang="en-US" sz="800" b="1" dirty="0">
+              <a:solidFill>
+                <a:schemeClr val="tx1"/>
+              </a:solidFill>
+            </a:endParaRPr>
+          </a:p>
+        </p:txBody>
+      </p:sp>
+      <p:sp>
+        <p:nvSpPr>
+          <p:cNvPr id="71" name="TextBox 70">
+            <a:extLst>
+              <a:ext uri="{FF2B5EF4-FFF2-40B4-BE49-F238E27FC236}">
+                <a16:creationId xmlns:a16="http://schemas.microsoft.com/office/drawing/2014/main" id="{38D0EE2C-20C3-B26B-3647-17629F216BB0}"/>
+              </a:ext>
+            </a:extLst>
+          </p:cNvPr>
+          <p:cNvSpPr txBox="1"/>
+          <p:nvPr/>
+        </p:nvSpPr>
+        <p:spPr>
+          <a:xfrm>
+            <a:off x="4453248" y="4816499"/>
+            <a:ext cx="1043650" cy="553998"/>
+          </a:xfrm>
+          <a:prstGeom prst="rect">
+            <a:avLst/>
+          </a:prstGeom>
+          <a:noFill/>
+        </p:spPr>
+        <p:txBody>
+          <a:bodyPr wrap="square" rtlCol="0">
+            <a:spAutoFit/>
+          </a:bodyPr>
+          <a:lstStyle/>
+          <a:p>
+            <a:pPr algn="ctr"/>
+            <a:r>
+              <a:rPr lang="en-US" sz="1000" dirty="0">
+                <a:latin typeface="Verdana" panose="020B0604030504040204" pitchFamily="34" charset="0"/>
+                <a:ea typeface="Verdana" panose="020B0604030504040204" pitchFamily="34" charset="0"/>
+              </a:rPr>
+              <a:t>OpenAPI</a:t>
+            </a:r>
+          </a:p>
+          <a:p>
+            <a:pPr algn="ctr"/>
+            <a:r>
+              <a:rPr lang="en-US" sz="1000" dirty="0">
+                <a:latin typeface="Verdana" panose="020B0604030504040204" pitchFamily="34" charset="0"/>
+                <a:ea typeface="Verdana" panose="020B0604030504040204" pitchFamily="34" charset="0"/>
+              </a:rPr>
+              <a:t>Interface</a:t>
+            </a:r>
+            <a:br>
+              <a:rPr lang="en-US" sz="1000" dirty="0">
+                <a:latin typeface="Verdana" panose="020B0604030504040204" pitchFamily="34" charset="0"/>
+                <a:ea typeface="Verdana" panose="020B0604030504040204" pitchFamily="34" charset="0"/>
+              </a:rPr>
+            </a:br>
+            <a:r>
+              <a:rPr lang="en-US" sz="1000" dirty="0">
+                <a:latin typeface="Verdana" panose="020B0604030504040204" pitchFamily="34" charset="0"/>
+                <a:ea typeface="Verdana" panose="020B0604030504040204" pitchFamily="34" charset="0"/>
+              </a:rPr>
+              <a:t>Specification</a:t>
+            </a:r>
+          </a:p>
+        </p:txBody>
+      </p:sp>
+      <p:sp>
+        <p:nvSpPr>
+          <p:cNvPr id="98" name="TextBox 97">
+            <a:extLst>
+              <a:ext uri="{FF2B5EF4-FFF2-40B4-BE49-F238E27FC236}">
+                <a16:creationId xmlns:a16="http://schemas.microsoft.com/office/drawing/2014/main" id="{01C544DD-5B4B-DF96-EC4A-EE26DDB1382A}"/>
+              </a:ext>
+            </a:extLst>
+          </p:cNvPr>
+          <p:cNvSpPr txBox="1"/>
+          <p:nvPr/>
+        </p:nvSpPr>
+        <p:spPr>
+          <a:xfrm>
+            <a:off x="4524841" y="402845"/>
+            <a:ext cx="4219591" cy="369332"/>
+          </a:xfrm>
+          <a:prstGeom prst="rect">
+            <a:avLst/>
+          </a:prstGeom>
+          <a:noFill/>
+        </p:spPr>
+        <p:txBody>
+          <a:bodyPr wrap="square" rtlCol="0">
+            <a:spAutoFit/>
+          </a:bodyPr>
+          <a:lstStyle/>
+          <a:p>
+            <a:r>
+              <a:rPr lang="en-US" b="1" dirty="0">
+                <a:latin typeface="Arial" panose="020B0604020202020204" pitchFamily="34" charset="0"/>
+                <a:ea typeface="Verdana" panose="020B0604030504040204" pitchFamily="34" charset="0"/>
+                <a:cs typeface="Arial" panose="020B0604020202020204" pitchFamily="34" charset="0"/>
+              </a:rPr>
+              <a:t>Steps for Efficient API Development</a:t>
+            </a:r>
+          </a:p>
+        </p:txBody>
+      </p:sp>
+      <p:sp>
+        <p:nvSpPr>
+          <p:cNvPr id="95" name="Rectangle: Rounded Corners 94">
+            <a:extLst>
+              <a:ext uri="{FF2B5EF4-FFF2-40B4-BE49-F238E27FC236}">
+                <a16:creationId xmlns:a16="http://schemas.microsoft.com/office/drawing/2014/main" id="{2C915655-D3AF-4BBA-64CB-F59881082F42}"/>
+              </a:ext>
+            </a:extLst>
+          </p:cNvPr>
+          <p:cNvSpPr/>
+          <p:nvPr/>
+        </p:nvSpPr>
+        <p:spPr>
+          <a:xfrm>
+            <a:off x="7024403" y="914913"/>
+            <a:ext cx="1696962" cy="4553656"/>
+          </a:xfrm>
+          <a:prstGeom prst="roundRect">
+            <a:avLst>
+              <a:gd name="adj" fmla="val 4546"/>
+            </a:avLst>
+          </a:prstGeom>
+          <a:solidFill>
+            <a:schemeClr val="accent2">
+              <a:lumMod val="20000"/>
+              <a:lumOff val="80000"/>
+            </a:schemeClr>
+          </a:solidFill>
+          <a:ln>
+            <a:noFill/>
+          </a:ln>
+        </p:spPr>
+        <p:style>
+          <a:lnRef idx="2">
+            <a:schemeClr val="accent1">
+              <a:shade val="15000"/>
+            </a:schemeClr>
+          </a:lnRef>
+          <a:fillRef idx="1">
+            <a:schemeClr val="accent1"/>
+          </a:fillRef>
+          <a:effectRef idx="0">
+            <a:schemeClr val="accent1"/>
+          </a:effectRef>
+          <a:fontRef idx="minor">
+            <a:schemeClr val="lt1"/>
+          </a:fontRef>
+        </p:style>
+        <p:txBody>
+          <a:bodyPr rtlCol="0" anchor="ctr"/>
+          <a:lstStyle/>
+          <a:p>
+            <a:pPr algn="ctr"/>
+            <a:endParaRPr lang="en-US"/>
+          </a:p>
+        </p:txBody>
+      </p:sp>
+      <p:grpSp>
+        <p:nvGrpSpPr>
+          <p:cNvPr id="75" name="Group 74">
+            <a:extLst>
+              <a:ext uri="{FF2B5EF4-FFF2-40B4-BE49-F238E27FC236}">
+                <a16:creationId xmlns:a16="http://schemas.microsoft.com/office/drawing/2014/main" id="{1435C108-77DA-08C5-502E-95EAAFE4367C}"/>
+              </a:ext>
+            </a:extLst>
+          </p:cNvPr>
+          <p:cNvGrpSpPr/>
+          <p:nvPr/>
+        </p:nvGrpSpPr>
+        <p:grpSpPr>
+          <a:xfrm>
+            <a:off x="7768920" y="3937000"/>
+            <a:ext cx="280700" cy="340115"/>
+            <a:chOff x="7714600" y="4181682"/>
+            <a:chExt cx="280700" cy="340115"/>
+          </a:xfrm>
+        </p:grpSpPr>
+        <p:sp>
+          <p:nvSpPr>
+            <p:cNvPr id="72" name="Rectangle: Folded Corner 71">
+              <a:extLst>
+                <a:ext uri="{FF2B5EF4-FFF2-40B4-BE49-F238E27FC236}">
+                  <a16:creationId xmlns:a16="http://schemas.microsoft.com/office/drawing/2014/main" id="{4637098F-0109-5FD1-F3D0-71D601E677D5}"/>
+                </a:ext>
+              </a:extLst>
+            </p:cNvPr>
+            <p:cNvSpPr/>
+            <p:nvPr/>
+          </p:nvSpPr>
+          <p:spPr>
+            <a:xfrm>
+              <a:off x="7854950" y="4295054"/>
+              <a:ext cx="140350" cy="226743"/>
+            </a:xfrm>
+            <a:prstGeom prst="foldedCorner">
+              <a:avLst>
+                <a:gd name="adj" fmla="val 48923"/>
+              </a:avLst>
+            </a:prstGeom>
+            <a:solidFill>
+              <a:schemeClr val="bg1">
+                <a:lumMod val="95000"/>
+              </a:schemeClr>
+            </a:solidFill>
+          </p:spPr>
+          <p:style>
+            <a:lnRef idx="2">
+              <a:schemeClr val="accent1">
+                <a:shade val="15000"/>
+              </a:schemeClr>
+            </a:lnRef>
+            <a:fillRef idx="1">
+              <a:schemeClr val="accent1"/>
+            </a:fillRef>
+            <a:effectRef idx="0">
+              <a:schemeClr val="accent1"/>
+            </a:effectRef>
+            <a:fontRef idx="minor">
+              <a:schemeClr val="lt1"/>
+            </a:fontRef>
+          </p:style>
+          <p:txBody>
+            <a:bodyPr rtlCol="0" anchor="ctr"/>
+            <a:lstStyle/>
+            <a:p>
+              <a:pPr algn="ctr"/>
+              <a:endParaRPr lang="en-US"/>
+            </a:p>
+          </p:txBody>
+        </p:sp>
+        <p:sp>
+          <p:nvSpPr>
+            <p:cNvPr id="73" name="Rectangle: Folded Corner 72">
+              <a:extLst>
+                <a:ext uri="{FF2B5EF4-FFF2-40B4-BE49-F238E27FC236}">
+                  <a16:creationId xmlns:a16="http://schemas.microsoft.com/office/drawing/2014/main" id="{B4D36000-F1ED-6463-32F4-244059F01A48}"/>
+                </a:ext>
+              </a:extLst>
+            </p:cNvPr>
+            <p:cNvSpPr/>
+            <p:nvPr/>
+          </p:nvSpPr>
+          <p:spPr>
+            <a:xfrm>
+              <a:off x="7784775" y="4232257"/>
+              <a:ext cx="140350" cy="226743"/>
+            </a:xfrm>
+            <a:prstGeom prst="foldedCorner">
+              <a:avLst>
+                <a:gd name="adj" fmla="val 48923"/>
+              </a:avLst>
+            </a:prstGeom>
+            <a:solidFill>
+              <a:schemeClr val="bg1">
+                <a:lumMod val="95000"/>
+              </a:schemeClr>
+            </a:solidFill>
+          </p:spPr>
+          <p:style>
+            <a:lnRef idx="2">
+              <a:schemeClr val="accent1">
+                <a:shade val="15000"/>
+              </a:schemeClr>
+            </a:lnRef>
+            <a:fillRef idx="1">
+              <a:schemeClr val="accent1"/>
+            </a:fillRef>
+            <a:effectRef idx="0">
+              <a:schemeClr val="accent1"/>
+            </a:effectRef>
+            <a:fontRef idx="minor">
+              <a:schemeClr val="lt1"/>
+            </a:fontRef>
+          </p:style>
+          <p:txBody>
+            <a:bodyPr rtlCol="0" anchor="ctr"/>
+            <a:lstStyle/>
+            <a:p>
+              <a:pPr algn="ctr"/>
+              <a:endParaRPr lang="en-US"/>
+            </a:p>
+          </p:txBody>
+        </p:sp>
+        <p:sp>
+          <p:nvSpPr>
+            <p:cNvPr id="74" name="Rectangle: Folded Corner 73">
+              <a:extLst>
+                <a:ext uri="{FF2B5EF4-FFF2-40B4-BE49-F238E27FC236}">
+                  <a16:creationId xmlns:a16="http://schemas.microsoft.com/office/drawing/2014/main" id="{1CA79FBB-3B1D-DA40-BA86-254DA7976DFF}"/>
+                </a:ext>
+              </a:extLst>
+            </p:cNvPr>
+            <p:cNvSpPr/>
+            <p:nvPr/>
+          </p:nvSpPr>
+          <p:spPr>
+            <a:xfrm>
+              <a:off x="7714600" y="4181682"/>
+              <a:ext cx="140350" cy="226743"/>
+            </a:xfrm>
+            <a:prstGeom prst="foldedCorner">
+              <a:avLst>
+                <a:gd name="adj" fmla="val 48923"/>
+              </a:avLst>
+            </a:prstGeom>
+            <a:solidFill>
+              <a:schemeClr val="bg1">
+                <a:lumMod val="95000"/>
+              </a:schemeClr>
+            </a:solidFill>
+          </p:spPr>
+          <p:style>
+            <a:lnRef idx="2">
+              <a:schemeClr val="accent1">
+                <a:shade val="15000"/>
+              </a:schemeClr>
+            </a:lnRef>
+            <a:fillRef idx="1">
+              <a:schemeClr val="accent1"/>
+            </a:fillRef>
+            <a:effectRef idx="0">
+              <a:schemeClr val="accent1"/>
+            </a:effectRef>
+            <a:fontRef idx="minor">
+              <a:schemeClr val="lt1"/>
+            </a:fontRef>
+          </p:style>
+          <p:txBody>
+            <a:bodyPr rtlCol="0" anchor="ctr"/>
+            <a:lstStyle/>
+            <a:p>
+              <a:pPr algn="ctr"/>
+              <a:endParaRPr lang="en-US"/>
+            </a:p>
+          </p:txBody>
+        </p:sp>
+      </p:grpSp>
+      <p:grpSp>
+        <p:nvGrpSpPr>
+          <p:cNvPr id="76" name="Group 75">
+            <a:extLst>
+              <a:ext uri="{FF2B5EF4-FFF2-40B4-BE49-F238E27FC236}">
+                <a16:creationId xmlns:a16="http://schemas.microsoft.com/office/drawing/2014/main" id="{6A4B7316-3101-EA0F-E8B0-65DEC458DB41}"/>
+              </a:ext>
+            </a:extLst>
+          </p:cNvPr>
+          <p:cNvGrpSpPr/>
+          <p:nvPr/>
+        </p:nvGrpSpPr>
+        <p:grpSpPr>
+          <a:xfrm>
+            <a:off x="7768920" y="4366612"/>
+            <a:ext cx="280700" cy="340115"/>
+            <a:chOff x="7714600" y="4181682"/>
+            <a:chExt cx="280700" cy="340115"/>
+          </a:xfrm>
+        </p:grpSpPr>
+        <p:sp>
+          <p:nvSpPr>
+            <p:cNvPr id="77" name="Rectangle: Folded Corner 76">
+              <a:extLst>
+                <a:ext uri="{FF2B5EF4-FFF2-40B4-BE49-F238E27FC236}">
+                  <a16:creationId xmlns:a16="http://schemas.microsoft.com/office/drawing/2014/main" id="{F40E8B13-A4FE-0F7F-0C5A-F6C6D693020B}"/>
+                </a:ext>
+              </a:extLst>
+            </p:cNvPr>
+            <p:cNvSpPr/>
+            <p:nvPr/>
+          </p:nvSpPr>
+          <p:spPr>
+            <a:xfrm>
+              <a:off x="7854950" y="4295054"/>
+              <a:ext cx="140350" cy="226743"/>
+            </a:xfrm>
+            <a:prstGeom prst="foldedCorner">
+              <a:avLst>
+                <a:gd name="adj" fmla="val 48923"/>
+              </a:avLst>
+            </a:prstGeom>
+            <a:solidFill>
+              <a:schemeClr val="bg1">
+                <a:lumMod val="95000"/>
+              </a:schemeClr>
+            </a:solidFill>
+          </p:spPr>
+          <p:style>
+            <a:lnRef idx="2">
+              <a:schemeClr val="accent1">
+                <a:shade val="15000"/>
+              </a:schemeClr>
+            </a:lnRef>
+            <a:fillRef idx="1">
+              <a:schemeClr val="accent1"/>
+            </a:fillRef>
+            <a:effectRef idx="0">
+              <a:schemeClr val="accent1"/>
+            </a:effectRef>
+            <a:fontRef idx="minor">
+              <a:schemeClr val="lt1"/>
+            </a:fontRef>
+          </p:style>
+          <p:txBody>
+            <a:bodyPr rtlCol="0" anchor="ctr"/>
+            <a:lstStyle/>
+            <a:p>
+              <a:pPr algn="ctr"/>
+              <a:endParaRPr lang="en-US"/>
+            </a:p>
+          </p:txBody>
+        </p:sp>
+        <p:sp>
+          <p:nvSpPr>
+            <p:cNvPr id="78" name="Rectangle: Folded Corner 77">
+              <a:extLst>
+                <a:ext uri="{FF2B5EF4-FFF2-40B4-BE49-F238E27FC236}">
+                  <a16:creationId xmlns:a16="http://schemas.microsoft.com/office/drawing/2014/main" id="{4ACDD2B3-3C92-EE98-2F0F-AF11E57E5A3A}"/>
+                </a:ext>
+              </a:extLst>
+            </p:cNvPr>
+            <p:cNvSpPr/>
+            <p:nvPr/>
+          </p:nvSpPr>
+          <p:spPr>
+            <a:xfrm>
+              <a:off x="7784775" y="4232257"/>
+              <a:ext cx="140350" cy="226743"/>
+            </a:xfrm>
+            <a:prstGeom prst="foldedCorner">
+              <a:avLst>
+                <a:gd name="adj" fmla="val 48923"/>
+              </a:avLst>
+            </a:prstGeom>
+            <a:solidFill>
+              <a:schemeClr val="bg1">
+                <a:lumMod val="95000"/>
+              </a:schemeClr>
+            </a:solidFill>
+          </p:spPr>
+          <p:style>
+            <a:lnRef idx="2">
+              <a:schemeClr val="accent1">
+                <a:shade val="15000"/>
+              </a:schemeClr>
+            </a:lnRef>
+            <a:fillRef idx="1">
+              <a:schemeClr val="accent1"/>
+            </a:fillRef>
+            <a:effectRef idx="0">
+              <a:schemeClr val="accent1"/>
+            </a:effectRef>
+            <a:fontRef idx="minor">
+              <a:schemeClr val="lt1"/>
+            </a:fontRef>
+          </p:style>
+          <p:txBody>
+            <a:bodyPr rtlCol="0" anchor="ctr"/>
+            <a:lstStyle/>
+            <a:p>
+              <a:pPr algn="ctr"/>
+              <a:endParaRPr lang="en-US"/>
+            </a:p>
+          </p:txBody>
+        </p:sp>
+        <p:sp>
+          <p:nvSpPr>
+            <p:cNvPr id="79" name="Rectangle: Folded Corner 78">
+              <a:extLst>
+                <a:ext uri="{FF2B5EF4-FFF2-40B4-BE49-F238E27FC236}">
+                  <a16:creationId xmlns:a16="http://schemas.microsoft.com/office/drawing/2014/main" id="{AE8DD084-20C9-A108-841C-0A475A6AF515}"/>
+                </a:ext>
+              </a:extLst>
+            </p:cNvPr>
+            <p:cNvSpPr/>
+            <p:nvPr/>
+          </p:nvSpPr>
+          <p:spPr>
+            <a:xfrm>
+              <a:off x="7714600" y="4181682"/>
+              <a:ext cx="140350" cy="226743"/>
+            </a:xfrm>
+            <a:prstGeom prst="foldedCorner">
+              <a:avLst>
+                <a:gd name="adj" fmla="val 48923"/>
+              </a:avLst>
+            </a:prstGeom>
+            <a:solidFill>
+              <a:schemeClr val="bg1">
+                <a:lumMod val="95000"/>
+              </a:schemeClr>
+            </a:solidFill>
+          </p:spPr>
+          <p:style>
+            <a:lnRef idx="2">
+              <a:schemeClr val="accent1">
+                <a:shade val="15000"/>
+              </a:schemeClr>
+            </a:lnRef>
+            <a:fillRef idx="1">
+              <a:schemeClr val="accent1"/>
+            </a:fillRef>
+            <a:effectRef idx="0">
+              <a:schemeClr val="accent1"/>
+            </a:effectRef>
+            <a:fontRef idx="minor">
+              <a:schemeClr val="lt1"/>
+            </a:fontRef>
+          </p:style>
+          <p:txBody>
+            <a:bodyPr rtlCol="0" anchor="ctr"/>
+            <a:lstStyle/>
+            <a:p>
+              <a:pPr algn="ctr"/>
+              <a:endParaRPr lang="en-US"/>
+            </a:p>
+          </p:txBody>
+        </p:sp>
+      </p:grpSp>
+      <p:pic>
+        <p:nvPicPr>
+          <p:cNvPr id="82" name="Picture 81" descr="A person sitting at a desk with a computer&#10;&#10;AI-generated content may be incorrect.">
+            <a:extLst>
+              <a:ext uri="{FF2B5EF4-FFF2-40B4-BE49-F238E27FC236}">
+                <a16:creationId xmlns:a16="http://schemas.microsoft.com/office/drawing/2014/main" id="{17B3D799-502B-FFA2-D030-640BF2C76374}"/>
+              </a:ext>
+            </a:extLst>
+          </p:cNvPr>
+          <p:cNvPicPr>
+            <a:picLocks noChangeAspect="1"/>
+          </p:cNvPicPr>
+          <p:nvPr/>
+        </p:nvPicPr>
+        <p:blipFill>
+          <a:blip r:embed="rId7">
+            <a:extLst>
+              <a:ext uri="{28A0092B-C50C-407E-A947-70E740481C1C}">
+                <a14:useLocalDpi xmlns:a14="http://schemas.microsoft.com/office/drawing/2010/main" val="0"/>
+              </a:ext>
+            </a:extLst>
+          </a:blip>
+          <a:stretch>
+            <a:fillRect/>
+          </a:stretch>
+        </p:blipFill>
+        <p:spPr>
+          <a:xfrm>
+            <a:off x="7637698" y="1709398"/>
+            <a:ext cx="543145" cy="733722"/>
+          </a:xfrm>
+          <a:prstGeom prst="rect">
+            <a:avLst/>
+          </a:prstGeom>
+        </p:spPr>
+      </p:pic>
+      <p:sp>
+        <p:nvSpPr>
+          <p:cNvPr id="85" name="TextBox 84">
+            <a:extLst>
+              <a:ext uri="{FF2B5EF4-FFF2-40B4-BE49-F238E27FC236}">
+                <a16:creationId xmlns:a16="http://schemas.microsoft.com/office/drawing/2014/main" id="{EE59CEBE-1F5C-9753-08F6-A57E3642235B}"/>
+              </a:ext>
+            </a:extLst>
+          </p:cNvPr>
+          <p:cNvSpPr txBox="1"/>
+          <p:nvPr/>
+        </p:nvSpPr>
+        <p:spPr>
+          <a:xfrm>
+            <a:off x="7489924" y="2538257"/>
+            <a:ext cx="838692" cy="400110"/>
+          </a:xfrm>
+          <a:prstGeom prst="rect">
+            <a:avLst/>
+          </a:prstGeom>
+          <a:noFill/>
+        </p:spPr>
+        <p:txBody>
+          <a:bodyPr wrap="none" rtlCol="0">
+            <a:spAutoFit/>
+          </a:bodyPr>
+          <a:lstStyle/>
+          <a:p>
+            <a:pPr algn="ctr"/>
+            <a:r>
+              <a:rPr lang="en-US" sz="1000" dirty="0">
+                <a:latin typeface="Verdana" panose="020B0604030504040204" pitchFamily="34" charset="0"/>
+                <a:ea typeface="Verdana" panose="020B0604030504040204" pitchFamily="34" charset="0"/>
+              </a:rPr>
+              <a:t>Software</a:t>
+            </a:r>
+            <a:br>
+              <a:rPr lang="en-US" sz="1000" dirty="0">
+                <a:latin typeface="Verdana" panose="020B0604030504040204" pitchFamily="34" charset="0"/>
+                <a:ea typeface="Verdana" panose="020B0604030504040204" pitchFamily="34" charset="0"/>
+              </a:rPr>
+            </a:br>
+            <a:r>
+              <a:rPr lang="en-US" sz="1000" dirty="0">
+                <a:latin typeface="Verdana" panose="020B0604030504040204" pitchFamily="34" charset="0"/>
+                <a:ea typeface="Verdana" panose="020B0604030504040204" pitchFamily="34" charset="0"/>
+              </a:rPr>
+              <a:t>Developer</a:t>
+            </a:r>
+          </a:p>
+        </p:txBody>
+      </p:sp>
+      <p:sp>
+        <p:nvSpPr>
+          <p:cNvPr id="89" name="TextBox 88">
+            <a:extLst>
+              <a:ext uri="{FF2B5EF4-FFF2-40B4-BE49-F238E27FC236}">
+                <a16:creationId xmlns:a16="http://schemas.microsoft.com/office/drawing/2014/main" id="{3860A71F-DE28-1273-8BA1-4FEF3664FD9C}"/>
+              </a:ext>
+            </a:extLst>
+          </p:cNvPr>
+          <p:cNvSpPr txBox="1"/>
+          <p:nvPr/>
+        </p:nvSpPr>
+        <p:spPr>
+          <a:xfrm>
+            <a:off x="7299460" y="4827046"/>
+            <a:ext cx="1219620" cy="553998"/>
+          </a:xfrm>
+          <a:prstGeom prst="rect">
+            <a:avLst/>
+          </a:prstGeom>
+          <a:noFill/>
+        </p:spPr>
+        <p:txBody>
+          <a:bodyPr wrap="square" rtlCol="0">
+            <a:spAutoFit/>
+          </a:bodyPr>
+          <a:lstStyle/>
+          <a:p>
+            <a:pPr algn="ctr"/>
+            <a:r>
+              <a:rPr lang="en-US" sz="1000" dirty="0">
+                <a:latin typeface="Verdana" panose="020B0604030504040204" pitchFamily="34" charset="0"/>
+                <a:ea typeface="Verdana" panose="020B0604030504040204" pitchFamily="34" charset="0"/>
+              </a:rPr>
+              <a:t>API</a:t>
+            </a:r>
+            <a:br>
+              <a:rPr lang="en-US" sz="1000" dirty="0">
+                <a:latin typeface="Verdana" panose="020B0604030504040204" pitchFamily="34" charset="0"/>
+                <a:ea typeface="Verdana" panose="020B0604030504040204" pitchFamily="34" charset="0"/>
+              </a:rPr>
+            </a:br>
+            <a:r>
+              <a:rPr lang="en-US" sz="1000" dirty="0">
+                <a:latin typeface="Verdana" panose="020B0604030504040204" pitchFamily="34" charset="0"/>
+                <a:ea typeface="Verdana" panose="020B0604030504040204" pitchFamily="34" charset="0"/>
+              </a:rPr>
+              <a:t>Implementation</a:t>
+            </a:r>
+            <a:br>
+              <a:rPr lang="en-US" sz="1000" dirty="0">
+                <a:latin typeface="Verdana" panose="020B0604030504040204" pitchFamily="34" charset="0"/>
+                <a:ea typeface="Verdana" panose="020B0604030504040204" pitchFamily="34" charset="0"/>
+              </a:rPr>
+            </a:br>
+            <a:r>
+              <a:rPr lang="en-US" sz="1000" dirty="0">
+                <a:latin typeface="Verdana" panose="020B0604030504040204" pitchFamily="34" charset="0"/>
+                <a:ea typeface="Verdana" panose="020B0604030504040204" pitchFamily="34" charset="0"/>
+              </a:rPr>
+              <a:t>Code</a:t>
+            </a:r>
+          </a:p>
+        </p:txBody>
+      </p:sp>
+      <p:cxnSp>
+        <p:nvCxnSpPr>
+          <p:cNvPr id="113" name="Straight Arrow Connector 112">
+            <a:extLst>
+              <a:ext uri="{FF2B5EF4-FFF2-40B4-BE49-F238E27FC236}">
+                <a16:creationId xmlns:a16="http://schemas.microsoft.com/office/drawing/2014/main" id="{BB3BCB29-65F7-9F13-F782-94C4A5BCCF5C}"/>
+              </a:ext>
+            </a:extLst>
+          </p:cNvPr>
+          <p:cNvCxnSpPr>
+            <a:cxnSpLocks/>
+          </p:cNvCxnSpPr>
+          <p:nvPr/>
+        </p:nvCxnSpPr>
+        <p:spPr>
+          <a:xfrm>
+            <a:off x="7907450" y="2998841"/>
+            <a:ext cx="0" cy="828649"/>
+          </a:xfrm>
+          <a:prstGeom prst="straightConnector1">
+            <a:avLst/>
+          </a:prstGeom>
+          <a:ln>
+            <a:prstDash val="dash"/>
+            <a:headEnd type="none" w="med" len="med"/>
+            <a:tailEnd type="triangle" w="lg" len="med"/>
+          </a:ln>
+        </p:spPr>
+        <p:style>
+          <a:lnRef idx="2">
+            <a:schemeClr val="accent1"/>
+          </a:lnRef>
+          <a:fillRef idx="0">
+            <a:schemeClr val="accent1"/>
+          </a:fillRef>
+          <a:effectRef idx="1">
+            <a:schemeClr val="accent1"/>
+          </a:effectRef>
+          <a:fontRef idx="minor">
+            <a:schemeClr val="tx1"/>
+          </a:fontRef>
+        </p:style>
+      </p:cxnSp>
+      <p:sp>
+        <p:nvSpPr>
+          <p:cNvPr id="91" name="Oval 90">
+            <a:extLst>
+              <a:ext uri="{FF2B5EF4-FFF2-40B4-BE49-F238E27FC236}">
+                <a16:creationId xmlns:a16="http://schemas.microsoft.com/office/drawing/2014/main" id="{3D305D9F-7BE1-E11D-4E4A-CABC42A88123}"/>
+              </a:ext>
+            </a:extLst>
+          </p:cNvPr>
+          <p:cNvSpPr/>
+          <p:nvPr/>
+        </p:nvSpPr>
+        <p:spPr>
+          <a:xfrm>
+            <a:off x="7796325" y="3278620"/>
+            <a:ext cx="222250" cy="222250"/>
+          </a:xfrm>
+          <a:prstGeom prst="ellipse">
+            <a:avLst/>
+          </a:prstGeom>
+          <a:solidFill>
+            <a:srgbClr val="FFFF66"/>
+          </a:solidFill>
+          <a:ln w="12700"/>
+        </p:spPr>
+        <p:style>
+          <a:lnRef idx="2">
+            <a:schemeClr val="accent1">
+              <a:shade val="15000"/>
+            </a:schemeClr>
+          </a:lnRef>
+          <a:fillRef idx="1">
+            <a:schemeClr val="accent1"/>
+          </a:fillRef>
+          <a:effectRef idx="0">
+            <a:schemeClr val="accent1"/>
+          </a:effectRef>
+          <a:fontRef idx="minor">
+            <a:schemeClr val="lt1"/>
+          </a:fontRef>
+        </p:style>
+        <p:txBody>
+          <a:bodyPr lIns="45720" rIns="45720" rtlCol="0" anchor="ctr"/>
+          <a:lstStyle/>
+          <a:p>
+            <a:pPr algn="ctr"/>
+            <a:r>
+              <a:rPr lang="en-US" sz="1000" b="1" dirty="0">
+                <a:solidFill>
+                  <a:schemeClr val="tx1"/>
+                </a:solidFill>
+              </a:rPr>
+              <a:t>5</a:t>
+            </a:r>
+            <a:endParaRPr lang="en-US" sz="800" b="1" dirty="0">
+              <a:solidFill>
+                <a:schemeClr val="tx1"/>
+              </a:solidFill>
+            </a:endParaRPr>
+          </a:p>
+        </p:txBody>
+      </p:sp>
+      <p:sp>
+        <p:nvSpPr>
+          <p:cNvPr id="97" name="TextBox 96">
+            <a:extLst>
+              <a:ext uri="{FF2B5EF4-FFF2-40B4-BE49-F238E27FC236}">
+                <a16:creationId xmlns:a16="http://schemas.microsoft.com/office/drawing/2014/main" id="{7FAF938E-C212-9EF2-09ED-7502D826CA28}"/>
+              </a:ext>
+            </a:extLst>
+          </p:cNvPr>
+          <p:cNvSpPr txBox="1"/>
+          <p:nvPr/>
+        </p:nvSpPr>
+        <p:spPr>
+          <a:xfrm>
+            <a:off x="8951776" y="4108613"/>
+            <a:ext cx="984138" cy="707886"/>
+          </a:xfrm>
+          <a:prstGeom prst="rect">
+            <a:avLst/>
+          </a:prstGeom>
+          <a:noFill/>
+        </p:spPr>
+        <p:txBody>
+          <a:bodyPr wrap="square" rtlCol="0">
+            <a:spAutoFit/>
+          </a:bodyPr>
+          <a:lstStyle/>
+          <a:p>
+            <a:r>
+              <a:rPr lang="en-US" sz="1000" dirty="0">
+                <a:latin typeface="Verdana" panose="020B0604030504040204" pitchFamily="34" charset="0"/>
+                <a:ea typeface="Verdana" panose="020B0604030504040204" pitchFamily="34" charset="0"/>
+              </a:rPr>
+              <a:t>Finished API ready for</a:t>
+            </a:r>
+          </a:p>
+          <a:p>
+            <a:r>
+              <a:rPr lang="en-US" sz="1000" dirty="0">
+                <a:latin typeface="Verdana" panose="020B0604030504040204" pitchFamily="34" charset="0"/>
+                <a:ea typeface="Verdana" panose="020B0604030504040204" pitchFamily="34" charset="0"/>
+              </a:rPr>
+              <a:t>testing and deployment</a:t>
+            </a:r>
+          </a:p>
+        </p:txBody>
+      </p:sp>
+      <p:sp>
+        <p:nvSpPr>
+          <p:cNvPr id="120" name="TextBox 119">
+            <a:extLst>
+              <a:ext uri="{FF2B5EF4-FFF2-40B4-BE49-F238E27FC236}">
+                <a16:creationId xmlns:a16="http://schemas.microsoft.com/office/drawing/2014/main" id="{7F3CEFAF-BD18-9AE5-BA96-4A7744A20B51}"/>
+              </a:ext>
+            </a:extLst>
+          </p:cNvPr>
+          <p:cNvSpPr txBox="1"/>
+          <p:nvPr/>
+        </p:nvSpPr>
+        <p:spPr>
+          <a:xfrm>
+            <a:off x="1355023" y="5546004"/>
+            <a:ext cx="1785827" cy="584775"/>
+          </a:xfrm>
+          <a:prstGeom prst="rect">
+            <a:avLst/>
+          </a:prstGeom>
+          <a:noFill/>
+        </p:spPr>
+        <p:txBody>
+          <a:bodyPr wrap="square" rtlCol="0">
+            <a:spAutoFit/>
+          </a:bodyPr>
+          <a:lstStyle/>
+          <a:p>
+            <a:pPr algn="ctr"/>
+            <a:r>
+              <a:rPr lang="en-US" sz="1600" dirty="0">
+                <a:latin typeface="Arial" panose="020B0604020202020204" pitchFamily="34" charset="0"/>
+                <a:ea typeface="Verdana" panose="020B0604030504040204" pitchFamily="34" charset="0"/>
+                <a:cs typeface="Arial" panose="020B0604020202020204" pitchFamily="34" charset="0"/>
+              </a:rPr>
+              <a:t>API Ideation</a:t>
+            </a:r>
+            <a:br>
+              <a:rPr lang="en-US" sz="1600" dirty="0">
+                <a:latin typeface="Arial" panose="020B0604020202020204" pitchFamily="34" charset="0"/>
+                <a:ea typeface="Verdana" panose="020B0604030504040204" pitchFamily="34" charset="0"/>
+                <a:cs typeface="Arial" panose="020B0604020202020204" pitchFamily="34" charset="0"/>
+              </a:rPr>
+            </a:br>
+            <a:r>
+              <a:rPr lang="en-US" sz="1600" dirty="0">
+                <a:latin typeface="Arial" panose="020B0604020202020204" pitchFamily="34" charset="0"/>
+                <a:ea typeface="Verdana" panose="020B0604030504040204" pitchFamily="34" charset="0"/>
+                <a:cs typeface="Arial" panose="020B0604020202020204" pitchFamily="34" charset="0"/>
+              </a:rPr>
+              <a:t>Phase</a:t>
+            </a:r>
+          </a:p>
+        </p:txBody>
+      </p:sp>
+      <p:sp>
+        <p:nvSpPr>
+          <p:cNvPr id="121" name="TextBox 120">
+            <a:extLst>
+              <a:ext uri="{FF2B5EF4-FFF2-40B4-BE49-F238E27FC236}">
+                <a16:creationId xmlns:a16="http://schemas.microsoft.com/office/drawing/2014/main" id="{B026EF62-3A0E-11FD-BE12-7947CD9BA60C}"/>
+              </a:ext>
+            </a:extLst>
+          </p:cNvPr>
+          <p:cNvSpPr txBox="1"/>
+          <p:nvPr/>
+        </p:nvSpPr>
+        <p:spPr>
+          <a:xfrm>
+            <a:off x="4749442" y="5555969"/>
+            <a:ext cx="1785827" cy="584775"/>
+          </a:xfrm>
+          <a:prstGeom prst="rect">
+            <a:avLst/>
+          </a:prstGeom>
+          <a:noFill/>
+        </p:spPr>
+        <p:txBody>
+          <a:bodyPr wrap="square" rtlCol="0">
+            <a:spAutoFit/>
+          </a:bodyPr>
+          <a:lstStyle/>
+          <a:p>
+            <a:pPr algn="ctr"/>
+            <a:r>
+              <a:rPr lang="en-US" sz="1600" dirty="0">
+                <a:latin typeface="Arial" panose="020B0604020202020204" pitchFamily="34" charset="0"/>
+                <a:ea typeface="Verdana" panose="020B0604030504040204" pitchFamily="34" charset="0"/>
+                <a:cs typeface="Arial" panose="020B0604020202020204" pitchFamily="34" charset="0"/>
+              </a:rPr>
+              <a:t>API Design</a:t>
+            </a:r>
+            <a:br>
+              <a:rPr lang="en-US" sz="1600" dirty="0">
+                <a:latin typeface="Arial" panose="020B0604020202020204" pitchFamily="34" charset="0"/>
+                <a:ea typeface="Verdana" panose="020B0604030504040204" pitchFamily="34" charset="0"/>
+                <a:cs typeface="Arial" panose="020B0604020202020204" pitchFamily="34" charset="0"/>
+              </a:rPr>
+            </a:br>
+            <a:r>
+              <a:rPr lang="en-US" sz="1600" dirty="0">
+                <a:latin typeface="Arial" panose="020B0604020202020204" pitchFamily="34" charset="0"/>
+                <a:ea typeface="Verdana" panose="020B0604030504040204" pitchFamily="34" charset="0"/>
+                <a:cs typeface="Arial" panose="020B0604020202020204" pitchFamily="34" charset="0"/>
+              </a:rPr>
+              <a:t>Phase</a:t>
+            </a:r>
+          </a:p>
+        </p:txBody>
+      </p:sp>
+      <p:sp>
+        <p:nvSpPr>
+          <p:cNvPr id="122" name="TextBox 121">
+            <a:extLst>
+              <a:ext uri="{FF2B5EF4-FFF2-40B4-BE49-F238E27FC236}">
+                <a16:creationId xmlns:a16="http://schemas.microsoft.com/office/drawing/2014/main" id="{DA50C721-A7F0-F8F6-31F0-BB1FBDFDE590}"/>
+              </a:ext>
+            </a:extLst>
+          </p:cNvPr>
+          <p:cNvSpPr txBox="1"/>
+          <p:nvPr/>
+        </p:nvSpPr>
+        <p:spPr>
+          <a:xfrm>
+            <a:off x="6979971" y="5561643"/>
+            <a:ext cx="1785827" cy="584775"/>
+          </a:xfrm>
+          <a:prstGeom prst="rect">
+            <a:avLst/>
+          </a:prstGeom>
+          <a:noFill/>
+        </p:spPr>
+        <p:txBody>
+          <a:bodyPr wrap="square" rtlCol="0">
+            <a:spAutoFit/>
+          </a:bodyPr>
+          <a:lstStyle/>
+          <a:p>
+            <a:pPr algn="ctr"/>
+            <a:r>
+              <a:rPr lang="en-US" sz="1600" dirty="0">
+                <a:latin typeface="Arial" panose="020B0604020202020204" pitchFamily="34" charset="0"/>
+                <a:ea typeface="Verdana" panose="020B0604030504040204" pitchFamily="34" charset="0"/>
+                <a:cs typeface="Arial" panose="020B0604020202020204" pitchFamily="34" charset="0"/>
+              </a:rPr>
+              <a:t>Implementation Phase</a:t>
+            </a:r>
+          </a:p>
+        </p:txBody>
+      </p:sp>
+      <p:sp>
+        <p:nvSpPr>
+          <p:cNvPr id="88" name="Arrow: Right 87">
+            <a:extLst>
+              <a:ext uri="{FF2B5EF4-FFF2-40B4-BE49-F238E27FC236}">
+                <a16:creationId xmlns:a16="http://schemas.microsoft.com/office/drawing/2014/main" id="{821E3524-497E-42F2-2D4E-48A17D7F7D47}"/>
+              </a:ext>
+            </a:extLst>
+          </p:cNvPr>
+          <p:cNvSpPr/>
+          <p:nvPr/>
+        </p:nvSpPr>
+        <p:spPr>
+          <a:xfrm>
+            <a:off x="6749650" y="4394768"/>
+            <a:ext cx="838692" cy="189828"/>
+          </a:xfrm>
+          <a:prstGeom prst="rightArrow">
+            <a:avLst/>
+          </a:prstGeom>
+          <a:solidFill>
+            <a:srgbClr val="CAEEFB"/>
+          </a:solidFill>
+        </p:spPr>
+        <p:style>
+          <a:lnRef idx="2">
+            <a:schemeClr val="accent1">
+              <a:shade val="15000"/>
+            </a:schemeClr>
+          </a:lnRef>
+          <a:fillRef idx="1">
+            <a:schemeClr val="accent1"/>
+          </a:fillRef>
+          <a:effectRef idx="0">
+            <a:schemeClr val="accent1"/>
+          </a:effectRef>
+          <a:fontRef idx="minor">
+            <a:schemeClr val="lt1"/>
+          </a:fontRef>
+        </p:style>
+        <p:txBody>
+          <a:bodyPr rtlCol="0" anchor="ctr"/>
+          <a:lstStyle/>
+          <a:p>
+            <a:pPr algn="ctr"/>
+            <a:endParaRPr lang="en-US"/>
+          </a:p>
+        </p:txBody>
+      </p:sp>
+      <p:sp>
+        <p:nvSpPr>
+          <p:cNvPr id="51" name="Arrow: Right 50">
+            <a:extLst>
+              <a:ext uri="{FF2B5EF4-FFF2-40B4-BE49-F238E27FC236}">
+                <a16:creationId xmlns:a16="http://schemas.microsoft.com/office/drawing/2014/main" id="{1772C38D-E485-8A6C-BB56-3BC4688A51D9}"/>
+              </a:ext>
+            </a:extLst>
+          </p:cNvPr>
+          <p:cNvSpPr/>
+          <p:nvPr/>
+        </p:nvSpPr>
+        <p:spPr>
+          <a:xfrm>
+            <a:off x="3873500" y="4394768"/>
+            <a:ext cx="858762" cy="178124"/>
+          </a:xfrm>
+          <a:prstGeom prst="rightArrow">
+            <a:avLst/>
+          </a:prstGeom>
+          <a:solidFill>
+            <a:srgbClr val="CAEEFB"/>
+          </a:solidFill>
+        </p:spPr>
+        <p:style>
+          <a:lnRef idx="2">
+            <a:schemeClr val="accent1">
+              <a:shade val="15000"/>
+            </a:schemeClr>
+          </a:lnRef>
+          <a:fillRef idx="1">
+            <a:schemeClr val="accent1"/>
+          </a:fillRef>
+          <a:effectRef idx="0">
+            <a:schemeClr val="accent1"/>
+          </a:effectRef>
+          <a:fontRef idx="minor">
+            <a:schemeClr val="lt1"/>
+          </a:fontRef>
+        </p:style>
+        <p:txBody>
+          <a:bodyPr rtlCol="0" anchor="ctr"/>
+          <a:lstStyle/>
+          <a:p>
+            <a:pPr algn="ctr"/>
+            <a:endParaRPr lang="en-US"/>
+          </a:p>
+        </p:txBody>
+      </p:sp>
+      <p:sp>
+        <p:nvSpPr>
+          <p:cNvPr id="96" name="Arrow: Right 95">
+            <a:extLst>
+              <a:ext uri="{FF2B5EF4-FFF2-40B4-BE49-F238E27FC236}">
+                <a16:creationId xmlns:a16="http://schemas.microsoft.com/office/drawing/2014/main" id="{1EB382A9-171F-6147-845C-750A9B787C2B}"/>
+              </a:ext>
+            </a:extLst>
+          </p:cNvPr>
+          <p:cNvSpPr/>
+          <p:nvPr/>
+        </p:nvSpPr>
+        <p:spPr>
+          <a:xfrm>
+            <a:off x="8209856" y="4390497"/>
+            <a:ext cx="724631" cy="182395"/>
+          </a:xfrm>
+          <a:prstGeom prst="rightArrow">
+            <a:avLst/>
+          </a:prstGeom>
+          <a:solidFill>
+            <a:srgbClr val="CAEEFB"/>
+          </a:solidFill>
+        </p:spPr>
+        <p:style>
+          <a:lnRef idx="2">
+            <a:schemeClr val="accent1">
+              <a:shade val="15000"/>
+            </a:schemeClr>
+          </a:lnRef>
+          <a:fillRef idx="1">
+            <a:schemeClr val="accent1"/>
+          </a:fillRef>
+          <a:effectRef idx="0">
+            <a:schemeClr val="accent1"/>
+          </a:effectRef>
+          <a:fontRef idx="minor">
+            <a:schemeClr val="lt1"/>
+          </a:fontRef>
+        </p:style>
+        <p:txBody>
+          <a:bodyPr rtlCol="0" anchor="ctr"/>
+          <a:lstStyle/>
+          <a:p>
+            <a:pPr algn="ctr"/>
+            <a:endParaRPr lang="en-US"/>
+          </a:p>
+        </p:txBody>
+      </p:sp>
+      <p:sp>
+        <p:nvSpPr>
+          <p:cNvPr id="2" name="Speech Bubble: Rectangle with Corners Rounded 1">
+            <a:extLst>
+              <a:ext uri="{FF2B5EF4-FFF2-40B4-BE49-F238E27FC236}">
+                <a16:creationId xmlns:a16="http://schemas.microsoft.com/office/drawing/2014/main" id="{0451D47E-1A88-B8A3-91EE-32CC6710EB5E}"/>
+              </a:ext>
+            </a:extLst>
+          </p:cNvPr>
+          <p:cNvSpPr/>
+          <p:nvPr/>
+        </p:nvSpPr>
+        <p:spPr>
+          <a:xfrm>
+            <a:off x="4830178" y="1097297"/>
+            <a:ext cx="1332084" cy="505402"/>
+          </a:xfrm>
+          <a:prstGeom prst="wedgeRoundRectCallout">
+            <a:avLst>
+              <a:gd name="adj1" fmla="val -7795"/>
+              <a:gd name="adj2" fmla="val 68084"/>
+              <a:gd name="adj3" fmla="val 16667"/>
+            </a:avLst>
+          </a:prstGeom>
+          <a:solidFill>
+            <a:schemeClr val="bg1"/>
+          </a:solidFill>
+          <a:ln>
+            <a:solidFill>
+              <a:schemeClr val="bg1">
+                <a:lumMod val="75000"/>
+              </a:schemeClr>
+            </a:solidFill>
+          </a:ln>
+        </p:spPr>
+        <p:style>
+          <a:lnRef idx="2">
+            <a:schemeClr val="accent1">
+              <a:shade val="15000"/>
+            </a:schemeClr>
+          </a:lnRef>
+          <a:fillRef idx="1">
+            <a:schemeClr val="accent1"/>
+          </a:fillRef>
+          <a:effectRef idx="0">
+            <a:schemeClr val="accent1"/>
+          </a:effectRef>
+          <a:fontRef idx="minor">
+            <a:schemeClr val="lt1"/>
+          </a:fontRef>
+        </p:style>
+        <p:txBody>
+          <a:bodyPr lIns="45720" rIns="45720" rtlCol="0" anchor="ctr"/>
+          <a:lstStyle/>
+          <a:p>
+            <a:pPr algn="ctr"/>
+            <a:r>
+              <a:rPr lang="en-US" sz="900" dirty="0">
+                <a:solidFill>
+                  <a:schemeClr val="tx1"/>
+                </a:solidFill>
+                <a:latin typeface="Verdana" panose="020B0604030504040204" pitchFamily="34" charset="0"/>
+                <a:ea typeface="Verdana" panose="020B0604030504040204" pitchFamily="34" charset="0"/>
+              </a:rPr>
+              <a:t>Which API endpoints can I remove?</a:t>
+            </a:r>
+          </a:p>
+        </p:txBody>
+      </p:sp>
+      <p:sp>
+        <p:nvSpPr>
+          <p:cNvPr id="3" name="Speech Bubble: Rectangle with Corners Rounded 2">
+            <a:extLst>
+              <a:ext uri="{FF2B5EF4-FFF2-40B4-BE49-F238E27FC236}">
+                <a16:creationId xmlns:a16="http://schemas.microsoft.com/office/drawing/2014/main" id="{5CBAEC4D-155A-43DB-0477-1B8A02A02DC0}"/>
+              </a:ext>
+            </a:extLst>
+          </p:cNvPr>
+          <p:cNvSpPr/>
+          <p:nvPr/>
+        </p:nvSpPr>
+        <p:spPr>
+          <a:xfrm>
+            <a:off x="7206842" y="1064107"/>
+            <a:ext cx="1332084" cy="505402"/>
+          </a:xfrm>
+          <a:prstGeom prst="wedgeRoundRectCallout">
+            <a:avLst>
+              <a:gd name="adj1" fmla="val -7795"/>
+              <a:gd name="adj2" fmla="val 68084"/>
+              <a:gd name="adj3" fmla="val 16667"/>
+            </a:avLst>
+          </a:prstGeom>
+          <a:solidFill>
+            <a:schemeClr val="bg1"/>
+          </a:solidFill>
+          <a:ln>
+            <a:solidFill>
+              <a:schemeClr val="bg1">
+                <a:lumMod val="75000"/>
+              </a:schemeClr>
+            </a:solidFill>
+          </a:ln>
+        </p:spPr>
+        <p:style>
+          <a:lnRef idx="2">
+            <a:schemeClr val="accent1">
+              <a:shade val="15000"/>
+            </a:schemeClr>
+          </a:lnRef>
+          <a:fillRef idx="1">
+            <a:schemeClr val="accent1"/>
+          </a:fillRef>
+          <a:effectRef idx="0">
+            <a:schemeClr val="accent1"/>
+          </a:effectRef>
+          <a:fontRef idx="minor">
+            <a:schemeClr val="lt1"/>
+          </a:fontRef>
+        </p:style>
+        <p:txBody>
+          <a:bodyPr lIns="45720" rIns="45720" rtlCol="0" anchor="ctr"/>
+          <a:lstStyle/>
+          <a:p>
+            <a:pPr algn="ctr"/>
+            <a:r>
+              <a:rPr lang="en-US" sz="900" dirty="0">
+                <a:solidFill>
+                  <a:schemeClr val="tx1"/>
+                </a:solidFill>
+                <a:latin typeface="Verdana" panose="020B0604030504040204" pitchFamily="34" charset="0"/>
+                <a:ea typeface="Verdana" panose="020B0604030504040204" pitchFamily="34" charset="0"/>
+              </a:rPr>
+              <a:t>Now to add business logic to</a:t>
+            </a:r>
+            <a:br>
+              <a:rPr lang="en-US" sz="900" dirty="0">
+                <a:solidFill>
+                  <a:schemeClr val="tx1"/>
+                </a:solidFill>
+                <a:latin typeface="Verdana" panose="020B0604030504040204" pitchFamily="34" charset="0"/>
+                <a:ea typeface="Verdana" panose="020B0604030504040204" pitchFamily="34" charset="0"/>
+              </a:rPr>
+            </a:br>
+            <a:r>
+              <a:rPr lang="en-US" sz="900" dirty="0">
+                <a:solidFill>
+                  <a:schemeClr val="tx1"/>
+                </a:solidFill>
+                <a:latin typeface="Verdana" panose="020B0604030504040204" pitchFamily="34" charset="0"/>
+                <a:ea typeface="Verdana" panose="020B0604030504040204" pitchFamily="34" charset="0"/>
+              </a:rPr>
+              <a:t>the endpoint stubs</a:t>
+            </a:r>
+          </a:p>
+        </p:txBody>
+      </p:sp>
+      <p:sp>
+        <p:nvSpPr>
+          <p:cNvPr id="23" name="Rectangle 22">
+            <a:extLst>
+              <a:ext uri="{FF2B5EF4-FFF2-40B4-BE49-F238E27FC236}">
+                <a16:creationId xmlns:a16="http://schemas.microsoft.com/office/drawing/2014/main" id="{6E470E63-18C6-E16F-4067-26131B9903C4}"/>
+              </a:ext>
+            </a:extLst>
+          </p:cNvPr>
+          <p:cNvSpPr/>
+          <p:nvPr/>
+        </p:nvSpPr>
+        <p:spPr>
+          <a:xfrm>
+            <a:off x="2565946" y="3705059"/>
+            <a:ext cx="45719" cy="61402"/>
+          </a:xfrm>
+          <a:prstGeom prst="rect">
+            <a:avLst/>
+          </a:prstGeom>
+          <a:solidFill>
+            <a:schemeClr val="bg1"/>
+          </a:solidFill>
+          <a:ln w="12700"/>
+        </p:spPr>
+        <p:style>
+          <a:lnRef idx="2">
+            <a:schemeClr val="accent1">
+              <a:shade val="15000"/>
+            </a:schemeClr>
+          </a:lnRef>
+          <a:fillRef idx="1">
+            <a:schemeClr val="accent1"/>
+          </a:fillRef>
+          <a:effectRef idx="0">
+            <a:schemeClr val="accent1"/>
+          </a:effectRef>
+          <a:fontRef idx="minor">
+            <a:schemeClr val="lt1"/>
+          </a:fontRef>
+        </p:style>
+        <p:txBody>
+          <a:bodyPr rtlCol="0" anchor="ctr"/>
+          <a:lstStyle/>
+          <a:p>
+            <a:pPr algn="ctr"/>
+            <a:endParaRPr lang="en-US"/>
+          </a:p>
+        </p:txBody>
+      </p:sp>
+      <p:sp>
+        <p:nvSpPr>
+          <p:cNvPr id="24" name="Rectangle 23">
+            <a:extLst>
+              <a:ext uri="{FF2B5EF4-FFF2-40B4-BE49-F238E27FC236}">
+                <a16:creationId xmlns:a16="http://schemas.microsoft.com/office/drawing/2014/main" id="{5884380C-1368-D9F1-34D5-87B4C1913E8D}"/>
+              </a:ext>
+            </a:extLst>
+          </p:cNvPr>
+          <p:cNvSpPr/>
+          <p:nvPr/>
+        </p:nvSpPr>
+        <p:spPr>
+          <a:xfrm>
+            <a:off x="2455215" y="3825967"/>
+            <a:ext cx="109060" cy="45719"/>
+          </a:xfrm>
+          <a:prstGeom prst="rect">
+            <a:avLst/>
+          </a:prstGeom>
+          <a:solidFill>
+            <a:schemeClr val="bg1"/>
+          </a:solidFill>
+          <a:ln w="12700"/>
+        </p:spPr>
+        <p:style>
+          <a:lnRef idx="2">
+            <a:schemeClr val="accent1">
+              <a:shade val="15000"/>
+            </a:schemeClr>
+          </a:lnRef>
+          <a:fillRef idx="1">
+            <a:schemeClr val="accent1"/>
+          </a:fillRef>
+          <a:effectRef idx="0">
+            <a:schemeClr val="accent1"/>
+          </a:effectRef>
+          <a:fontRef idx="minor">
+            <a:schemeClr val="lt1"/>
+          </a:fontRef>
+        </p:style>
+        <p:txBody>
+          <a:bodyPr rtlCol="0" anchor="ctr"/>
+          <a:lstStyle/>
+          <a:p>
+            <a:pPr algn="ctr"/>
+            <a:endParaRPr lang="en-US"/>
+          </a:p>
+        </p:txBody>
+      </p:sp>
+      <p:cxnSp>
+        <p:nvCxnSpPr>
+          <p:cNvPr id="27" name="Straight Connector 26">
+            <a:extLst>
+              <a:ext uri="{FF2B5EF4-FFF2-40B4-BE49-F238E27FC236}">
+                <a16:creationId xmlns:a16="http://schemas.microsoft.com/office/drawing/2014/main" id="{F486E55D-F1A0-DC4C-3934-FC9BCA608733}"/>
+              </a:ext>
+            </a:extLst>
+          </p:cNvPr>
+          <p:cNvCxnSpPr>
+            <a:cxnSpLocks/>
+            <a:stCxn id="23" idx="1"/>
+            <a:endCxn id="16" idx="3"/>
+          </p:cNvCxnSpPr>
+          <p:nvPr/>
+        </p:nvCxnSpPr>
+        <p:spPr>
+          <a:xfrm flipH="1">
+            <a:off x="2496271" y="3735760"/>
+            <a:ext cx="69675" cy="307"/>
+          </a:xfrm>
+          <a:prstGeom prst="line">
+            <a:avLst/>
+          </a:prstGeom>
+          <a:ln w="12700"/>
+        </p:spPr>
+        <p:style>
+          <a:lnRef idx="2">
+            <a:schemeClr val="accent1"/>
+          </a:lnRef>
+          <a:fillRef idx="0">
+            <a:schemeClr val="accent1"/>
+          </a:fillRef>
+          <a:effectRef idx="1">
+            <a:schemeClr val="accent1"/>
+          </a:effectRef>
+          <a:fontRef idx="minor">
+            <a:schemeClr val="tx1"/>
+          </a:fontRef>
+        </p:style>
+      </p:cxnSp>
+      <p:cxnSp>
+        <p:nvCxnSpPr>
+          <p:cNvPr id="34" name="Straight Connector 33">
+            <a:extLst>
+              <a:ext uri="{FF2B5EF4-FFF2-40B4-BE49-F238E27FC236}">
+                <a16:creationId xmlns:a16="http://schemas.microsoft.com/office/drawing/2014/main" id="{77AAE231-810F-33A1-F620-E1598D3AF100}"/>
+              </a:ext>
+            </a:extLst>
+          </p:cNvPr>
+          <p:cNvCxnSpPr>
+            <a:cxnSpLocks/>
+            <a:stCxn id="24" idx="0"/>
+            <a:endCxn id="16" idx="2"/>
+          </p:cNvCxnSpPr>
+          <p:nvPr/>
+        </p:nvCxnSpPr>
+        <p:spPr>
+          <a:xfrm flipH="1" flipV="1">
+            <a:off x="2473412" y="3766768"/>
+            <a:ext cx="36333" cy="59199"/>
+          </a:xfrm>
+          <a:prstGeom prst="line">
+            <a:avLst/>
+          </a:prstGeom>
+          <a:ln w="12700"/>
+        </p:spPr>
+        <p:style>
+          <a:lnRef idx="2">
+            <a:schemeClr val="accent1"/>
+          </a:lnRef>
+          <a:fillRef idx="0">
+            <a:schemeClr val="accent1"/>
+          </a:fillRef>
+          <a:effectRef idx="1">
+            <a:schemeClr val="accent1"/>
+          </a:effectRef>
+          <a:fontRef idx="minor">
+            <a:schemeClr val="tx1"/>
+          </a:fontRef>
+        </p:style>
+      </p:cxnSp>
+    </p:spTree>
+    <p:extLst>
+      <p:ext uri="{BB962C8B-B14F-4D97-AF65-F5344CB8AC3E}">
+        <p14:creationId xmlns:p14="http://schemas.microsoft.com/office/powerpoint/2010/main" val="84280624"/>
       </p:ext>
     </p:extLst>
   </p:cSld>
@@ -1273,4 +5825,319 @@
     </a:ext>
   </a:extLst>
 </a:theme>
+</file>
+
+<file path=ppt/theme/theme2.xml><?xml version="1.0" encoding="utf-8"?>
+<a:theme xmlns:a="http://schemas.openxmlformats.org/drawingml/2006/main" name="Office Theme">
+  <a:themeElements>
+    <a:clrScheme name="Office">
+      <a:dk1>
+        <a:sysClr val="windowText" lastClr="000000"/>
+      </a:dk1>
+      <a:lt1>
+        <a:sysClr val="window" lastClr="FFFFFF"/>
+      </a:lt1>
+      <a:dk2>
+        <a:srgbClr val="0E2841"/>
+      </a:dk2>
+      <a:lt2>
+        <a:srgbClr val="E8E8E8"/>
+      </a:lt2>
+      <a:accent1>
+        <a:srgbClr val="156082"/>
+      </a:accent1>
+      <a:accent2>
+        <a:srgbClr val="E97132"/>
+      </a:accent2>
+      <a:accent3>
+        <a:srgbClr val="196B24"/>
+      </a:accent3>
+      <a:accent4>
+        <a:srgbClr val="0F9ED5"/>
+      </a:accent4>
+      <a:accent5>
+        <a:srgbClr val="A02B93"/>
+      </a:accent5>
+      <a:accent6>
+        <a:srgbClr val="4EA72E"/>
+      </a:accent6>
+      <a:hlink>
+        <a:srgbClr val="467886"/>
+      </a:hlink>
+      <a:folHlink>
+        <a:srgbClr val="96607D"/>
+      </a:folHlink>
+    </a:clrScheme>
+    <a:fontScheme name="Office">
+      <a:majorFont>
+        <a:latin typeface="Aptos Display" panose="02110004020202020204"/>
+        <a:ea typeface=""/>
+        <a:cs typeface=""/>
+        <a:font script="Jpan" typeface="游ゴシック Light"/>
+        <a:font script="Hang" typeface="맑은 고딕"/>
+        <a:font script="Hans" typeface="等线 Light"/>
+        <a:font script="Hant" typeface="新細明體"/>
+        <a:font script="Arab" typeface="Times New Roman"/>
+        <a:font script="Hebr" typeface="Times New Roman"/>
+        <a:font script="Thai" typeface="Angsana New"/>
+        <a:font script="Ethi" typeface="Nyala"/>
+        <a:font script="Beng" typeface="Vrinda"/>
+        <a:font script="Gujr" typeface="Shruti"/>
+        <a:font script="Khmr" typeface="MoolBoran"/>
+        <a:font script="Knda" typeface="Tunga"/>
+        <a:font script="Guru" typeface="Raavi"/>
+        <a:font script="Cans" typeface="Euphemia"/>
+        <a:font script="Cher" typeface="Plantagenet Cherokee"/>
+        <a:font script="Yiii" typeface="Microsoft Yi Baiti"/>
+        <a:font script="Tibt" typeface="Microsoft Himalaya"/>
+        <a:font script="Thaa" typeface="MV Boli"/>
+        <a:font script="Deva" typeface="Mangal"/>
+        <a:font script="Telu" typeface="Gautami"/>
+        <a:font script="Taml" typeface="Latha"/>
+        <a:font script="Syrc" typeface="Estrangelo Edessa"/>
+        <a:font script="Orya" typeface="Kalinga"/>
+        <a:font script="Mlym" typeface="Kartika"/>
+        <a:font script="Laoo" typeface="DokChampa"/>
+        <a:font script="Sinh" typeface="Iskoola Pota"/>
+        <a:font script="Mong" typeface="Mongolian Baiti"/>
+        <a:font script="Viet" typeface="Times New Roman"/>
+        <a:font script="Uigh" typeface="Microsoft Uighur"/>
+        <a:font script="Geor" typeface="Sylfaen"/>
+        <a:font script="Armn" typeface="Arial"/>
+        <a:font script="Bugi" typeface="Leelawadee UI"/>
+        <a:font script="Bopo" typeface="Microsoft JhengHei"/>
+        <a:font script="Java" typeface="Javanese Text"/>
+        <a:font script="Lisu" typeface="Segoe UI"/>
+        <a:font script="Mymr" typeface="Myanmar Text"/>
+        <a:font script="Nkoo" typeface="Ebrima"/>
+        <a:font script="Olck" typeface="Nirmala UI"/>
+        <a:font script="Osma" typeface="Ebrima"/>
+        <a:font script="Phag" typeface="Phagspa"/>
+        <a:font script="Syrn" typeface="Estrangelo Edessa"/>
+        <a:font script="Syrj" typeface="Estrangelo Edessa"/>
+        <a:font script="Syre" typeface="Estrangelo Edessa"/>
+        <a:font script="Sora" typeface="Nirmala UI"/>
+        <a:font script="Tale" typeface="Microsoft Tai Le"/>
+        <a:font script="Talu" typeface="Microsoft New Tai Lue"/>
+        <a:font script="Tfng" typeface="Ebrima"/>
+      </a:majorFont>
+      <a:minorFont>
+        <a:latin typeface="Aptos" panose="02110004020202020204"/>
+        <a:ea typeface=""/>
+        <a:cs typeface=""/>
+        <a:font script="Jpan" typeface="游ゴシック"/>
+        <a:font script="Hang" typeface="맑은 고딕"/>
+        <a:font script="Hans" typeface="等线"/>
+        <a:font script="Hant" typeface="新細明體"/>
+        <a:font script="Arab" typeface="Arial"/>
+        <a:font script="Hebr" typeface="Arial"/>
+        <a:font script="Thai" typeface="Cordia New"/>
+        <a:font script="Ethi" typeface="Nyala"/>
+        <a:font script="Beng" typeface="Vrinda"/>
+        <a:font script="Gujr" typeface="Shruti"/>
+        <a:font script="Khmr" typeface="DaunPenh"/>
+        <a:font script="Knda" typeface="Tunga"/>
+        <a:font script="Guru" typeface="Raavi"/>
+        <a:font script="Cans" typeface="Euphemia"/>
+        <a:font script="Cher" typeface="Plantagenet Cherokee"/>
+        <a:font script="Yiii" typeface="Microsoft Yi Baiti"/>
+        <a:font script="Tibt" typeface="Microsoft Himalaya"/>
+        <a:font script="Thaa" typeface="MV Boli"/>
+        <a:font script="Deva" typeface="Mangal"/>
+        <a:font script="Telu" typeface="Gautami"/>
+        <a:font script="Taml" typeface="Latha"/>
+        <a:font script="Syrc" typeface="Estrangelo Edessa"/>
+        <a:font script="Orya" typeface="Kalinga"/>
+        <a:font script="Mlym" typeface="Kartika"/>
+        <a:font script="Laoo" typeface="DokChampa"/>
+        <a:font script="Sinh" typeface="Iskoola Pota"/>
+        <a:font script="Mong" typeface="Mongolian Baiti"/>
+        <a:font script="Viet" typeface="Arial"/>
+        <a:font script="Uigh" typeface="Microsoft Uighur"/>
+        <a:font script="Geor" typeface="Sylfaen"/>
+        <a:font script="Armn" typeface="Arial"/>
+        <a:font script="Bugi" typeface="Leelawadee UI"/>
+        <a:font script="Bopo" typeface="Microsoft JhengHei"/>
+        <a:font script="Java" typeface="Javanese Text"/>
+        <a:font script="Lisu" typeface="Segoe UI"/>
+        <a:font script="Mymr" typeface="Myanmar Text"/>
+        <a:font script="Nkoo" typeface="Ebrima"/>
+        <a:font script="Olck" typeface="Nirmala UI"/>
+        <a:font script="Osma" typeface="Ebrima"/>
+        <a:font script="Phag" typeface="Phagspa"/>
+        <a:font script="Syrn" typeface="Estrangelo Edessa"/>
+        <a:font script="Syrj" typeface="Estrangelo Edessa"/>
+        <a:font script="Syre" typeface="Estrangelo Edessa"/>
+        <a:font script="Sora" typeface="Nirmala UI"/>
+        <a:font script="Tale" typeface="Microsoft Tai Le"/>
+        <a:font script="Talu" typeface="Microsoft New Tai Lue"/>
+        <a:font script="Tfng" typeface="Ebrima"/>
+      </a:minorFont>
+    </a:fontScheme>
+    <a:fmtScheme name="Office">
+      <a:fillStyleLst>
+        <a:solidFill>
+          <a:schemeClr val="phClr"/>
+        </a:solidFill>
+        <a:gradFill rotWithShape="1">
+          <a:gsLst>
+            <a:gs pos="0">
+              <a:schemeClr val="phClr">
+                <a:lumMod val="110000"/>
+                <a:satMod val="105000"/>
+                <a:tint val="67000"/>
+              </a:schemeClr>
+            </a:gs>
+            <a:gs pos="50000">
+              <a:schemeClr val="phClr">
+                <a:lumMod val="105000"/>
+                <a:satMod val="103000"/>
+                <a:tint val="73000"/>
+              </a:schemeClr>
+            </a:gs>
+            <a:gs pos="100000">
+              <a:schemeClr val="phClr">
+                <a:lumMod val="105000"/>
+                <a:satMod val="109000"/>
+                <a:tint val="81000"/>
+              </a:schemeClr>
+            </a:gs>
+          </a:gsLst>
+          <a:lin ang="5400000" scaled="0"/>
+        </a:gradFill>
+        <a:gradFill rotWithShape="1">
+          <a:gsLst>
+            <a:gs pos="0">
+              <a:schemeClr val="phClr">
+                <a:satMod val="103000"/>
+                <a:lumMod val="102000"/>
+                <a:tint val="94000"/>
+              </a:schemeClr>
+            </a:gs>
+            <a:gs pos="50000">
+              <a:schemeClr val="phClr">
+                <a:satMod val="110000"/>
+                <a:lumMod val="100000"/>
+                <a:shade val="100000"/>
+              </a:schemeClr>
+            </a:gs>
+            <a:gs pos="100000">
+              <a:schemeClr val="phClr">
+                <a:lumMod val="99000"/>
+                <a:satMod val="120000"/>
+                <a:shade val="78000"/>
+              </a:schemeClr>
+            </a:gs>
+          </a:gsLst>
+          <a:lin ang="5400000" scaled="0"/>
+        </a:gradFill>
+      </a:fillStyleLst>
+      <a:lnStyleLst>
+        <a:ln w="12700" cap="flat" cmpd="sng" algn="ctr">
+          <a:solidFill>
+            <a:schemeClr val="phClr"/>
+          </a:solidFill>
+          <a:prstDash val="solid"/>
+          <a:miter lim="800000"/>
+        </a:ln>
+        <a:ln w="19050" cap="flat" cmpd="sng" algn="ctr">
+          <a:solidFill>
+            <a:schemeClr val="phClr"/>
+          </a:solidFill>
+          <a:prstDash val="solid"/>
+          <a:miter lim="800000"/>
+        </a:ln>
+        <a:ln w="25400" cap="flat" cmpd="sng" algn="ctr">
+          <a:solidFill>
+            <a:schemeClr val="phClr"/>
+          </a:solidFill>
+          <a:prstDash val="solid"/>
+          <a:miter lim="800000"/>
+        </a:ln>
+      </a:lnStyleLst>
+      <a:effectStyleLst>
+        <a:effectStyle>
+          <a:effectLst/>
+        </a:effectStyle>
+        <a:effectStyle>
+          <a:effectLst/>
+        </a:effectStyle>
+        <a:effectStyle>
+          <a:effectLst>
+            <a:outerShdw blurRad="57150" dist="19050" dir="5400000" algn="ctr" rotWithShape="0">
+              <a:srgbClr val="000000">
+                <a:alpha val="63000"/>
+              </a:srgbClr>
+            </a:outerShdw>
+          </a:effectLst>
+        </a:effectStyle>
+      </a:effectStyleLst>
+      <a:bgFillStyleLst>
+        <a:solidFill>
+          <a:schemeClr val="phClr"/>
+        </a:solidFill>
+        <a:solidFill>
+          <a:schemeClr val="phClr">
+            <a:tint val="95000"/>
+            <a:satMod val="170000"/>
+          </a:schemeClr>
+        </a:solidFill>
+        <a:gradFill rotWithShape="1">
+          <a:gsLst>
+            <a:gs pos="0">
+              <a:schemeClr val="phClr">
+                <a:tint val="93000"/>
+                <a:satMod val="150000"/>
+                <a:shade val="98000"/>
+                <a:lumMod val="102000"/>
+              </a:schemeClr>
+            </a:gs>
+            <a:gs pos="50000">
+              <a:schemeClr val="phClr">
+                <a:tint val="98000"/>
+                <a:satMod val="130000"/>
+                <a:shade val="90000"/>
+                <a:lumMod val="103000"/>
+              </a:schemeClr>
+            </a:gs>
+            <a:gs pos="100000">
+              <a:schemeClr val="phClr">
+                <a:shade val="63000"/>
+                <a:satMod val="120000"/>
+              </a:schemeClr>
+            </a:gs>
+          </a:gsLst>
+          <a:lin ang="5400000" scaled="0"/>
+        </a:gradFill>
+      </a:bgFillStyleLst>
+    </a:fmtScheme>
+  </a:themeElements>
+  <a:objectDefaults>
+    <a:lnDef>
+      <a:spPr/>
+      <a:bodyPr/>
+      <a:lstStyle/>
+      <a:style>
+        <a:lnRef idx="2">
+          <a:schemeClr val="accent1"/>
+        </a:lnRef>
+        <a:fillRef idx="0">
+          <a:schemeClr val="accent1"/>
+        </a:fillRef>
+        <a:effectRef idx="1">
+          <a:schemeClr val="accent1"/>
+        </a:effectRef>
+        <a:fontRef idx="minor">
+          <a:schemeClr val="tx1"/>
+        </a:fontRef>
+      </a:style>
+    </a:lnDef>
+  </a:objectDefaults>
+  <a:extraClrSchemeLst/>
+  <a:extLst>
+    <a:ext uri="{05A4C25C-085E-4340-85A3-A5531E510DB2}">
+      <thm15:themeFamily xmlns:thm15="http://schemas.microsoft.com/office/thememl/2012/main" name="Office Theme" id="{2E142A2C-CD16-42D6-873A-C26D2A0506FA}" vid="{1BDDFF52-6CD6-40A5-AB3C-68EB2F1E4D0A}"/>
+    </a:ext>
+  </a:extLst>
+</a:theme>
 </file>
</xml_diff>

<commit_message>
Added phases graphic to index page
</commit_message>
<xml_diff>
--- a/src/main/webapp/images/images.pptx
+++ b/src/main/webapp/images/images.pptx
@@ -2010,6 +2010,60 @@
       </p:grpSpPr>
       <p:sp>
         <p:nvSpPr>
+          <p:cNvPr id="6" name="Rectangle 5">
+            <a:extLst>
+              <a:ext uri="{FF2B5EF4-FFF2-40B4-BE49-F238E27FC236}">
+                <a16:creationId xmlns:a16="http://schemas.microsoft.com/office/drawing/2014/main" id="{602976A5-0CB1-68BF-4ED4-4DB1905D6FCC}"/>
+              </a:ext>
+            </a:extLst>
+          </p:cNvPr>
+          <p:cNvSpPr/>
+          <p:nvPr/>
+        </p:nvSpPr>
+        <p:spPr>
+          <a:xfrm>
+            <a:off x="637309" y="271549"/>
+            <a:ext cx="10467151" cy="5857702"/>
+          </a:xfrm>
+          <a:prstGeom prst="rect">
+            <a:avLst/>
+          </a:prstGeom>
+          <a:solidFill>
+            <a:schemeClr val="bg1">
+              <a:lumMod val="95000"/>
+            </a:schemeClr>
+          </a:solidFill>
+          <a:ln>
+            <a:noFill/>
+          </a:ln>
+        </p:spPr>
+        <p:style>
+          <a:lnRef idx="2">
+            <a:schemeClr val="accent1">
+              <a:shade val="15000"/>
+            </a:schemeClr>
+          </a:lnRef>
+          <a:fillRef idx="1">
+            <a:schemeClr val="accent1"/>
+          </a:fillRef>
+          <a:effectRef idx="0">
+            <a:schemeClr val="accent1"/>
+          </a:effectRef>
+          <a:fontRef idx="minor">
+            <a:schemeClr val="lt1"/>
+          </a:fontRef>
+        </p:style>
+        <p:txBody>
+          <a:bodyPr rtlCol="0" anchor="ctr"/>
+          <a:lstStyle/>
+          <a:p>
+            <a:pPr algn="ctr"/>
+            <a:endParaRPr lang="en-US"/>
+          </a:p>
+        </p:txBody>
+      </p:sp>
+      <p:sp>
+        <p:nvSpPr>
           <p:cNvPr id="54" name="Rectangle: Rounded Corners 53">
             <a:extLst>
               <a:ext uri="{FF2B5EF4-FFF2-40B4-BE49-F238E27FC236}">
@@ -2022,7 +2076,7 @@
         </p:nvSpPr>
         <p:spPr>
           <a:xfrm>
-            <a:off x="184223" y="323851"/>
+            <a:off x="1087540" y="484564"/>
             <a:ext cx="4013127" cy="5149850"/>
           </a:xfrm>
           <a:prstGeom prst="roundRect">
@@ -2037,7 +2091,11 @@
             </a:schemeClr>
           </a:solidFill>
           <a:ln>
-            <a:noFill/>
+            <a:solidFill>
+              <a:schemeClr val="bg1">
+                <a:lumMod val="75000"/>
+              </a:schemeClr>
+            </a:solidFill>
           </a:ln>
         </p:spPr>
         <p:style>
@@ -2079,7 +2137,7 @@
         </p:nvGrpSpPr>
         <p:grpSpPr>
           <a:xfrm>
-            <a:off x="509471" y="2694917"/>
+            <a:off x="1412788" y="2855630"/>
             <a:ext cx="1507889" cy="2057400"/>
             <a:chOff x="413523" y="2694917"/>
             <a:chExt cx="1507889" cy="2057400"/>
@@ -2199,7 +2257,7 @@
         </p:blipFill>
         <p:spPr>
           <a:xfrm>
-            <a:off x="2981903" y="1137383"/>
+            <a:off x="3885220" y="1298096"/>
             <a:ext cx="628904" cy="733722"/>
           </a:xfrm>
           <a:prstGeom prst="rect">
@@ -2235,7 +2293,7 @@
         </p:blipFill>
         <p:spPr>
           <a:xfrm flipH="1">
-            <a:off x="1553859" y="1003980"/>
+            <a:off x="2457176" y="1164693"/>
             <a:ext cx="628904" cy="1000529"/>
           </a:xfrm>
           <a:prstGeom prst="rect">
@@ -2257,7 +2315,7 @@
         </p:nvSpPr>
         <p:spPr>
           <a:xfrm>
-            <a:off x="1167467" y="475320"/>
+            <a:off x="2070784" y="636033"/>
             <a:ext cx="1083733" cy="505402"/>
           </a:xfrm>
           <a:prstGeom prst="wedgeRoundRectCallout">
@@ -2326,7 +2384,7 @@
         </p:nvSpPr>
         <p:spPr>
           <a:xfrm>
-            <a:off x="2578691" y="475320"/>
+            <a:off x="3482008" y="636033"/>
             <a:ext cx="1405468" cy="505402"/>
           </a:xfrm>
           <a:prstGeom prst="wedgeRoundRectCallout">
@@ -2414,7 +2472,7 @@
         </p:nvSpPr>
         <p:spPr>
           <a:xfrm>
-            <a:off x="1450671" y="1947333"/>
+            <a:off x="2353988" y="2108046"/>
             <a:ext cx="713657" cy="400110"/>
           </a:xfrm>
           <a:prstGeom prst="rect">
@@ -2466,7 +2524,7 @@
         </p:nvSpPr>
         <p:spPr>
           <a:xfrm>
-            <a:off x="2921092" y="1947333"/>
+            <a:off x="3824409" y="2108046"/>
             <a:ext cx="750526" cy="400110"/>
           </a:xfrm>
           <a:prstGeom prst="rect">
@@ -2518,7 +2576,7 @@
         </p:nvSpPr>
         <p:spPr>
           <a:xfrm flipV="1">
-            <a:off x="2219040" y="1504243"/>
+            <a:off x="3122357" y="1664956"/>
             <a:ext cx="628904" cy="1859845"/>
           </a:xfrm>
           <a:prstGeom prst="leftRightUpArrow">
@@ -2574,7 +2632,7 @@
         </p:nvSpPr>
         <p:spPr>
           <a:xfrm>
-            <a:off x="2369803" y="3517900"/>
+            <a:off x="3273120" y="3678613"/>
             <a:ext cx="327378" cy="355600"/>
           </a:xfrm>
           <a:prstGeom prst="foldedCorner">
@@ -2628,7 +2686,7 @@
         </p:nvSpPr>
         <p:spPr>
           <a:xfrm>
-            <a:off x="2456542" y="3572014"/>
+            <a:off x="3359859" y="3732727"/>
             <a:ext cx="45719" cy="61402"/>
           </a:xfrm>
           <a:prstGeom prst="rect">
@@ -2678,7 +2736,7 @@
         </p:nvSpPr>
         <p:spPr>
           <a:xfrm>
-            <a:off x="2564275" y="3572753"/>
+            <a:off x="3467592" y="3733466"/>
             <a:ext cx="45719" cy="61402"/>
           </a:xfrm>
           <a:prstGeom prst="rect">
@@ -2728,7 +2786,7 @@
         </p:nvSpPr>
         <p:spPr>
           <a:xfrm>
-            <a:off x="2450552" y="3705366"/>
+            <a:off x="3353869" y="3866079"/>
             <a:ext cx="45719" cy="61402"/>
           </a:xfrm>
           <a:prstGeom prst="rect">
@@ -2782,7 +2840,7 @@
         </p:nvCxnSpPr>
         <p:spPr>
           <a:xfrm flipH="1" flipV="1">
-            <a:off x="2502261" y="3602715"/>
+            <a:off x="3405578" y="3763428"/>
             <a:ext cx="62014" cy="739"/>
           </a:xfrm>
           <a:prstGeom prst="line">
@@ -2823,7 +2881,7 @@
         </p:nvCxnSpPr>
         <p:spPr>
           <a:xfrm flipH="1">
-            <a:off x="2473412" y="3633416"/>
+            <a:off x="3376729" y="3794129"/>
             <a:ext cx="5990" cy="71950"/>
           </a:xfrm>
           <a:prstGeom prst="line">
@@ -2860,7 +2918,7 @@
         </p:nvSpPr>
         <p:spPr>
           <a:xfrm>
-            <a:off x="2014668" y="2692400"/>
+            <a:off x="2917985" y="2853113"/>
             <a:ext cx="309431" cy="2101850"/>
           </a:xfrm>
           <a:custGeom>
@@ -2965,7 +3023,7 @@
         </p:nvSpPr>
         <p:spPr>
           <a:xfrm>
-            <a:off x="184222" y="4824620"/>
+            <a:off x="1087539" y="4985333"/>
             <a:ext cx="2139877" cy="553998"/>
           </a:xfrm>
           <a:prstGeom prst="rect">
@@ -3004,16 +3062,14 @@
         </p:nvSpPr>
         <p:spPr>
           <a:xfrm>
-            <a:off x="2886780" y="4171950"/>
+            <a:off x="3790097" y="4332663"/>
             <a:ext cx="819150" cy="622300"/>
           </a:xfrm>
           <a:prstGeom prst="roundRect">
             <a:avLst/>
           </a:prstGeom>
           <a:solidFill>
-            <a:schemeClr val="bg1">
-              <a:lumMod val="95000"/>
-            </a:schemeClr>
+            <a:srgbClr val="FFFFCC"/>
           </a:solidFill>
           <a:effectLst>
             <a:outerShdw blurRad="50800" dist="38100" dir="2700000" algn="tl" rotWithShape="0">
@@ -3069,7 +3125,7 @@
         </p:nvSpPr>
         <p:spPr>
           <a:xfrm rot="5400000">
-            <a:off x="2340721" y="4126183"/>
+            <a:off x="3244038" y="4286896"/>
             <a:ext cx="566040" cy="327378"/>
           </a:xfrm>
           <a:prstGeom prst="bentUpArrow">
@@ -3118,7 +3174,7 @@
         </p:nvCxnSpPr>
         <p:spPr>
           <a:xfrm>
-            <a:off x="3296355" y="2411588"/>
+            <a:off x="4199672" y="2572301"/>
             <a:ext cx="0" cy="1593850"/>
           </a:xfrm>
           <a:prstGeom prst="straightConnector1">
@@ -3159,7 +3215,7 @@
         </p:nvSpPr>
         <p:spPr>
           <a:xfrm>
-            <a:off x="2420761" y="2377927"/>
+            <a:off x="3324078" y="2538640"/>
             <a:ext cx="222250" cy="222250"/>
           </a:xfrm>
           <a:prstGeom prst="ellipse">
@@ -3221,7 +3277,7 @@
         </p:nvSpPr>
         <p:spPr>
           <a:xfrm>
-            <a:off x="3185230" y="3278620"/>
+            <a:off x="4088547" y="3439333"/>
             <a:ext cx="222250" cy="222250"/>
           </a:xfrm>
           <a:prstGeom prst="ellipse">
@@ -3283,7 +3339,7 @@
         </p:nvSpPr>
         <p:spPr>
           <a:xfrm>
-            <a:off x="4401310" y="920045"/>
+            <a:off x="5304627" y="1080758"/>
             <a:ext cx="2482090" cy="4553656"/>
           </a:xfrm>
           <a:prstGeom prst="roundRect">
@@ -3295,7 +3351,11 @@
             <a:srgbClr val="DCEAF7"/>
           </a:solidFill>
           <a:ln>
-            <a:noFill/>
+            <a:solidFill>
+              <a:schemeClr val="bg1">
+                <a:lumMod val="75000"/>
+              </a:schemeClr>
+            </a:solidFill>
           </a:ln>
         </p:spPr>
         <p:style>
@@ -3337,7 +3397,7 @@
         </p:nvGrpSpPr>
         <p:grpSpPr>
           <a:xfrm>
-            <a:off x="4838700" y="4271887"/>
+            <a:off x="5742017" y="4432600"/>
             <a:ext cx="279400" cy="422426"/>
             <a:chOff x="4508500" y="4271887"/>
             <a:chExt cx="279400" cy="422426"/>
@@ -3598,7 +3658,7 @@
         </p:nvGrpSpPr>
         <p:grpSpPr>
           <a:xfrm>
-            <a:off x="5176103" y="1596026"/>
+            <a:off x="6079420" y="1756739"/>
             <a:ext cx="776665" cy="1341299"/>
             <a:chOff x="5569803" y="1926226"/>
             <a:chExt cx="776665" cy="1341299"/>
@@ -3707,16 +3767,14 @@
         </p:nvSpPr>
         <p:spPr>
           <a:xfrm>
-            <a:off x="5788730" y="4171950"/>
+            <a:off x="6692047" y="4332663"/>
             <a:ext cx="819150" cy="622300"/>
           </a:xfrm>
           <a:prstGeom prst="roundRect">
             <a:avLst/>
           </a:prstGeom>
           <a:solidFill>
-            <a:schemeClr val="bg1">
-              <a:lumMod val="95000"/>
-            </a:schemeClr>
+            <a:srgbClr val="FFFFCC"/>
           </a:solidFill>
           <a:effectLst>
             <a:outerShdw blurRad="50800" dist="38100" dir="2700000" algn="tl" rotWithShape="0">
@@ -3772,7 +3830,7 @@
         </p:nvSpPr>
         <p:spPr>
           <a:xfrm>
-            <a:off x="5224538" y="4394768"/>
+            <a:off x="6127855" y="4555481"/>
             <a:ext cx="466820" cy="178124"/>
           </a:xfrm>
           <a:prstGeom prst="rightArrow">
@@ -3821,7 +3879,7 @@
         </p:nvGrpSpPr>
         <p:grpSpPr>
           <a:xfrm>
-            <a:off x="4940300" y="2998842"/>
+            <a:off x="5843617" y="3159555"/>
             <a:ext cx="1282700" cy="1063392"/>
             <a:chOff x="5334000" y="2998842"/>
             <a:chExt cx="1282700" cy="1128658"/>
@@ -3930,7 +3988,7 @@
         </p:nvSpPr>
         <p:spPr>
           <a:xfrm>
-            <a:off x="5149850" y="3278620"/>
+            <a:off x="6053167" y="3439333"/>
             <a:ext cx="222250" cy="222250"/>
           </a:xfrm>
           <a:prstGeom prst="ellipse">
@@ -3992,7 +4050,7 @@
         </p:nvSpPr>
         <p:spPr>
           <a:xfrm>
-            <a:off x="5800725" y="3278620"/>
+            <a:off x="6704042" y="3439333"/>
             <a:ext cx="222250" cy="222250"/>
           </a:xfrm>
           <a:prstGeom prst="ellipse">
@@ -4054,7 +4112,7 @@
         </p:nvSpPr>
         <p:spPr>
           <a:xfrm>
-            <a:off x="4453248" y="4816499"/>
+            <a:off x="5356565" y="4977212"/>
             <a:ext cx="1043650" cy="553998"/>
           </a:xfrm>
           <a:prstGeom prst="rect">
@@ -4116,8 +4174,8 @@
         </p:nvSpPr>
         <p:spPr>
           <a:xfrm>
-            <a:off x="4524841" y="402845"/>
-            <a:ext cx="4219591" cy="369332"/>
+            <a:off x="5318016" y="551631"/>
+            <a:ext cx="4306666" cy="369332"/>
           </a:xfrm>
           <a:prstGeom prst="rect">
             <a:avLst/>
@@ -4136,7 +4194,7 @@
                 <a:ea typeface="Verdana" panose="020B0604030504040204" pitchFamily="34" charset="0"/>
                 <a:cs typeface="Arial" panose="020B0604020202020204" pitchFamily="34" charset="0"/>
               </a:rPr>
-              <a:t>Steps for Efficient API Development</a:t>
+              <a:t>Phases for Efficient API Development</a:t>
             </a:r>
           </a:p>
         </p:txBody>
@@ -4155,7 +4213,7 @@
         </p:nvSpPr>
         <p:spPr>
           <a:xfrm>
-            <a:off x="7024403" y="914913"/>
+            <a:off x="7927720" y="1075626"/>
             <a:ext cx="1696962" cy="4553656"/>
           </a:xfrm>
           <a:prstGeom prst="roundRect">
@@ -4170,7 +4228,11 @@
             </a:schemeClr>
           </a:solidFill>
           <a:ln>
-            <a:noFill/>
+            <a:solidFill>
+              <a:schemeClr val="bg1">
+                <a:lumMod val="75000"/>
+              </a:schemeClr>
+            </a:solidFill>
           </a:ln>
         </p:spPr>
         <p:style>
@@ -4212,7 +4274,7 @@
         </p:nvGrpSpPr>
         <p:grpSpPr>
           <a:xfrm>
-            <a:off x="7768920" y="3937000"/>
+            <a:off x="8672237" y="4097713"/>
             <a:ext cx="280700" cy="340115"/>
             <a:chOff x="7714600" y="4181682"/>
             <a:chExt cx="280700" cy="340115"/>
@@ -4392,7 +4454,7 @@
         </p:nvGrpSpPr>
         <p:grpSpPr>
           <a:xfrm>
-            <a:off x="7768920" y="4366612"/>
+            <a:off x="8672237" y="4527325"/>
             <a:ext cx="280700" cy="340115"/>
             <a:chOff x="7714600" y="4181682"/>
             <a:chExt cx="280700" cy="340115"/>
@@ -4586,7 +4648,7 @@
         </p:blipFill>
         <p:spPr>
           <a:xfrm>
-            <a:off x="7637698" y="1709398"/>
+            <a:off x="8541015" y="1870111"/>
             <a:ext cx="543145" cy="733722"/>
           </a:xfrm>
           <a:prstGeom prst="rect">
@@ -4608,7 +4670,7 @@
         </p:nvSpPr>
         <p:spPr>
           <a:xfrm>
-            <a:off x="7489924" y="2538257"/>
+            <a:off x="8393241" y="2698970"/>
             <a:ext cx="838692" cy="400110"/>
           </a:xfrm>
           <a:prstGeom prst="rect">
@@ -4660,7 +4722,7 @@
         </p:nvSpPr>
         <p:spPr>
           <a:xfrm>
-            <a:off x="7299460" y="4827046"/>
+            <a:off x="8202777" y="4987759"/>
             <a:ext cx="1219620" cy="553998"/>
           </a:xfrm>
           <a:prstGeom prst="rect">
@@ -4727,7 +4789,7 @@
         </p:nvCxnSpPr>
         <p:spPr>
           <a:xfrm>
-            <a:off x="7907450" y="2998841"/>
+            <a:off x="8810767" y="3159554"/>
             <a:ext cx="0" cy="828649"/>
           </a:xfrm>
           <a:prstGeom prst="straightConnector1">
@@ -4768,7 +4830,7 @@
         </p:nvSpPr>
         <p:spPr>
           <a:xfrm>
-            <a:off x="7796325" y="3278620"/>
+            <a:off x="8699642" y="3439333"/>
             <a:ext cx="222250" cy="222250"/>
           </a:xfrm>
           <a:prstGeom prst="ellipse">
@@ -4830,7 +4892,7 @@
         </p:nvSpPr>
         <p:spPr>
           <a:xfrm>
-            <a:off x="8951776" y="4108613"/>
+            <a:off x="9855093" y="4269326"/>
             <a:ext cx="984138" cy="707886"/>
           </a:xfrm>
           <a:prstGeom prst="rect">
@@ -4877,8 +4939,8 @@
         </p:nvSpPr>
         <p:spPr>
           <a:xfrm>
-            <a:off x="1355023" y="5546004"/>
-            <a:ext cx="1785827" cy="584775"/>
+            <a:off x="2258340" y="5706717"/>
+            <a:ext cx="1785827" cy="338554"/>
           </a:xfrm>
           <a:prstGeom prst="rect">
             <a:avLst/>
@@ -4900,21 +4962,6 @@
               </a:rPr>
               <a:t>API Ideation</a:t>
             </a:r>
-            <a:br>
-              <a:rPr lang="en-US" sz="1600" dirty="0">
-                <a:latin typeface="Arial" panose="020B0604020202020204" pitchFamily="34" charset="0"/>
-                <a:ea typeface="Verdana" panose="020B0604030504040204" pitchFamily="34" charset="0"/>
-                <a:cs typeface="Arial" panose="020B0604020202020204" pitchFamily="34" charset="0"/>
-              </a:rPr>
-            </a:br>
-            <a:r>
-              <a:rPr lang="en-US" sz="1600" dirty="0">
-                <a:latin typeface="Arial" panose="020B0604020202020204" pitchFamily="34" charset="0"/>
-                <a:ea typeface="Verdana" panose="020B0604030504040204" pitchFamily="34" charset="0"/>
-                <a:cs typeface="Arial" panose="020B0604020202020204" pitchFamily="34" charset="0"/>
-              </a:rPr>
-              <a:t>Phase</a:t>
-            </a:r>
           </a:p>
         </p:txBody>
       </p:sp>
@@ -4932,8 +4979,8 @@
         </p:nvSpPr>
         <p:spPr>
           <a:xfrm>
-            <a:off x="4749442" y="5555969"/>
-            <a:ext cx="1785827" cy="584775"/>
+            <a:off x="5652759" y="5716682"/>
+            <a:ext cx="1785827" cy="338554"/>
           </a:xfrm>
           <a:prstGeom prst="rect">
             <a:avLst/>
@@ -4955,21 +5002,6 @@
               </a:rPr>
               <a:t>API Design</a:t>
             </a:r>
-            <a:br>
-              <a:rPr lang="en-US" sz="1600" dirty="0">
-                <a:latin typeface="Arial" panose="020B0604020202020204" pitchFamily="34" charset="0"/>
-                <a:ea typeface="Verdana" panose="020B0604030504040204" pitchFamily="34" charset="0"/>
-                <a:cs typeface="Arial" panose="020B0604020202020204" pitchFamily="34" charset="0"/>
-              </a:rPr>
-            </a:br>
-            <a:r>
-              <a:rPr lang="en-US" sz="1600" dirty="0">
-                <a:latin typeface="Arial" panose="020B0604020202020204" pitchFamily="34" charset="0"/>
-                <a:ea typeface="Verdana" panose="020B0604030504040204" pitchFamily="34" charset="0"/>
-                <a:cs typeface="Arial" panose="020B0604020202020204" pitchFamily="34" charset="0"/>
-              </a:rPr>
-              <a:t>Phase</a:t>
-            </a:r>
           </a:p>
         </p:txBody>
       </p:sp>
@@ -4987,8 +5019,8 @@
         </p:nvSpPr>
         <p:spPr>
           <a:xfrm>
-            <a:off x="6979971" y="5561643"/>
-            <a:ext cx="1785827" cy="584775"/>
+            <a:off x="7883288" y="5722356"/>
+            <a:ext cx="1785827" cy="338554"/>
           </a:xfrm>
           <a:prstGeom prst="rect">
             <a:avLst/>
@@ -5008,7 +5040,7 @@
                 <a:ea typeface="Verdana" panose="020B0604030504040204" pitchFamily="34" charset="0"/>
                 <a:cs typeface="Arial" panose="020B0604020202020204" pitchFamily="34" charset="0"/>
               </a:rPr>
-              <a:t>Implementation Phase</a:t>
+              <a:t>Implementation</a:t>
             </a:r>
           </a:p>
         </p:txBody>
@@ -5027,7 +5059,7 @@
         </p:nvSpPr>
         <p:spPr>
           <a:xfrm>
-            <a:off x="6749650" y="4394768"/>
+            <a:off x="7652967" y="4555481"/>
             <a:ext cx="838692" cy="189828"/>
           </a:xfrm>
           <a:prstGeom prst="rightArrow">
@@ -5076,7 +5108,7 @@
         </p:nvSpPr>
         <p:spPr>
           <a:xfrm>
-            <a:off x="3873500" y="4394768"/>
+            <a:off x="4776817" y="4555481"/>
             <a:ext cx="858762" cy="178124"/>
           </a:xfrm>
           <a:prstGeom prst="rightArrow">
@@ -5125,7 +5157,7 @@
         </p:nvSpPr>
         <p:spPr>
           <a:xfrm>
-            <a:off x="8209856" y="4390497"/>
+            <a:off x="9113173" y="4551210"/>
             <a:ext cx="724631" cy="182395"/>
           </a:xfrm>
           <a:prstGeom prst="rightArrow">
@@ -5174,7 +5206,7 @@
         </p:nvSpPr>
         <p:spPr>
           <a:xfrm>
-            <a:off x="4830178" y="1097297"/>
+            <a:off x="5733495" y="1258010"/>
             <a:ext cx="1332084" cy="505402"/>
           </a:xfrm>
           <a:prstGeom prst="wedgeRoundRectCallout">
@@ -5224,7 +5256,7 @@
                 <a:latin typeface="Verdana" panose="020B0604030504040204" pitchFamily="34" charset="0"/>
                 <a:ea typeface="Verdana" panose="020B0604030504040204" pitchFamily="34" charset="0"/>
               </a:rPr>
-              <a:t>Which API endpoints can I remove?</a:t>
+              <a:t>Which API endpoints do we need, which can be removed?</a:t>
             </a:r>
           </a:p>
         </p:txBody>
@@ -5243,7 +5275,7 @@
         </p:nvSpPr>
         <p:spPr>
           <a:xfrm>
-            <a:off x="7206842" y="1064107"/>
+            <a:off x="8110159" y="1224820"/>
             <a:ext cx="1332084" cy="505402"/>
           </a:xfrm>
           <a:prstGeom prst="wedgeRoundRectCallout">
@@ -5331,7 +5363,7 @@
         </p:nvSpPr>
         <p:spPr>
           <a:xfrm>
-            <a:off x="2565946" y="3705059"/>
+            <a:off x="3469263" y="3865772"/>
             <a:ext cx="45719" cy="61402"/>
           </a:xfrm>
           <a:prstGeom prst="rect">
@@ -5381,7 +5413,7 @@
         </p:nvSpPr>
         <p:spPr>
           <a:xfrm>
-            <a:off x="2455215" y="3825967"/>
+            <a:off x="3358532" y="3986680"/>
             <a:ext cx="109060" cy="45719"/>
           </a:xfrm>
           <a:prstGeom prst="rect">
@@ -5435,7 +5467,7 @@
         </p:nvCxnSpPr>
         <p:spPr>
           <a:xfrm flipH="1">
-            <a:off x="2496271" y="3735760"/>
+            <a:off x="3399588" y="3896473"/>
             <a:ext cx="69675" cy="307"/>
           </a:xfrm>
           <a:prstGeom prst="line">
@@ -5476,7 +5508,7 @@
         </p:nvCxnSpPr>
         <p:spPr>
           <a:xfrm flipH="1" flipV="1">
-            <a:off x="2473412" y="3766768"/>
+            <a:off x="3376729" y="3927481"/>
             <a:ext cx="36333" cy="59199"/>
           </a:xfrm>
           <a:prstGeom prst="line">

</xml_diff>

<commit_message>
Replaced the  main logo
</commit_message>
<xml_diff>
--- a/src/main/webapp/images/images.pptx
+++ b/src/main/webapp/images/images.pptx
@@ -5,11 +5,12 @@
     <p:sldMasterId id="2147483648" r:id="rId1"/>
   </p:sldMasterIdLst>
   <p:notesMasterIdLst>
-    <p:notesMasterId r:id="rId4"/>
+    <p:notesMasterId r:id="rId5"/>
   </p:notesMasterIdLst>
   <p:sldIdLst>
     <p:sldId id="257" r:id="rId2"/>
     <p:sldId id="258" r:id="rId3"/>
+    <p:sldId id="260" r:id="rId4"/>
   </p:sldIdLst>
   <p:sldSz cx="12192000" cy="6858000"/>
   <p:notesSz cx="6858000" cy="9144000"/>
@@ -329,7 +330,7 @@
           <a:p>
             <a:fld id="{2C805E82-58EB-422E-864A-536C3BC092C4}" type="datetimeFigureOut">
               <a:rPr lang="en-US" smtClean="0"/>
-              <a:t>8/28/2025</a:t>
+              <a:t>8/29/2025</a:t>
             </a:fld>
             <a:endParaRPr lang="en-US"/>
           </a:p>
@@ -3277,7 +3278,7 @@
         </p:nvSpPr>
         <p:spPr>
           <a:xfrm>
-            <a:off x="4088547" y="3439333"/>
+            <a:off x="4088547" y="3500295"/>
             <a:ext cx="222250" cy="222250"/>
           </a:xfrm>
           <a:prstGeom prst="ellipse">
@@ -3644,115 +3645,94 @@
           </p:style>
         </p:cxnSp>
       </p:grpSp>
-      <p:grpSp>
-        <p:nvGrpSpPr>
-          <p:cNvPr id="59" name="Group 58">
-            <a:extLst>
-              <a:ext uri="{FF2B5EF4-FFF2-40B4-BE49-F238E27FC236}">
-                <a16:creationId xmlns:a16="http://schemas.microsoft.com/office/drawing/2014/main" id="{07456F6A-EEBB-9541-B518-A7A626BEEEF6}"/>
-              </a:ext>
-            </a:extLst>
-          </p:cNvPr>
-          <p:cNvGrpSpPr/>
-          <p:nvPr/>
-        </p:nvGrpSpPr>
-        <p:grpSpPr>
-          <a:xfrm>
-            <a:off x="6079420" y="1756739"/>
-            <a:ext cx="776665" cy="1341299"/>
-            <a:chOff x="5569803" y="1926226"/>
-            <a:chExt cx="776665" cy="1341299"/>
-          </a:xfrm>
-        </p:grpSpPr>
-        <p:pic>
-          <p:nvPicPr>
-            <p:cNvPr id="56" name="Picture 55" descr="A person sitting in a chair with a computer&#10;&#10;AI-generated content may be incorrect.">
-              <a:extLst>
-                <a:ext uri="{FF2B5EF4-FFF2-40B4-BE49-F238E27FC236}">
-                  <a16:creationId xmlns:a16="http://schemas.microsoft.com/office/drawing/2014/main" id="{0C8BBDA0-D799-B613-B57C-024A25416C5D}"/>
-                </a:ext>
-              </a:extLst>
-            </p:cNvPr>
-            <p:cNvPicPr>
-              <a:picLocks noChangeAspect="1"/>
-            </p:cNvPicPr>
-            <p:nvPr/>
-          </p:nvPicPr>
-          <p:blipFill>
-            <a:blip r:embed="rId6">
-              <a:extLst>
-                <a:ext uri="{28A0092B-C50C-407E-A947-70E740481C1C}">
-                  <a14:useLocalDpi xmlns:a14="http://schemas.microsoft.com/office/drawing/2010/main" val="0"/>
-                </a:ext>
-              </a:extLst>
-            </a:blip>
-            <a:stretch>
-              <a:fillRect/>
-            </a:stretch>
-          </p:blipFill>
-          <p:spPr>
-            <a:xfrm>
-              <a:off x="5569803" y="1926226"/>
-              <a:ext cx="743250" cy="952885"/>
-            </a:xfrm>
-            <a:prstGeom prst="rect">
-              <a:avLst/>
-            </a:prstGeom>
-          </p:spPr>
-        </p:pic>
-        <p:sp>
-          <p:nvSpPr>
-            <p:cNvPr id="58" name="TextBox 57">
-              <a:extLst>
-                <a:ext uri="{FF2B5EF4-FFF2-40B4-BE49-F238E27FC236}">
-                  <a16:creationId xmlns:a16="http://schemas.microsoft.com/office/drawing/2014/main" id="{642FEC64-DBF3-6005-8DA0-699CB5FB7111}"/>
-                </a:ext>
-              </a:extLst>
-            </p:cNvPr>
-            <p:cNvSpPr txBox="1"/>
-            <p:nvPr/>
-          </p:nvSpPr>
-          <p:spPr>
-            <a:xfrm>
-              <a:off x="5587927" y="2867415"/>
-              <a:ext cx="758541" cy="400110"/>
-            </a:xfrm>
-            <a:prstGeom prst="rect">
-              <a:avLst/>
-            </a:prstGeom>
-            <a:noFill/>
-          </p:spPr>
-          <p:txBody>
-            <a:bodyPr wrap="none" rtlCol="0">
-              <a:spAutoFit/>
-            </a:bodyPr>
-            <a:lstStyle/>
-            <a:p>
-              <a:pPr algn="ctr"/>
-              <a:r>
-                <a:rPr lang="en-US" sz="1000" dirty="0">
-                  <a:latin typeface="Verdana" panose="020B0604030504040204" pitchFamily="34" charset="0"/>
-                  <a:ea typeface="Verdana" panose="020B0604030504040204" pitchFamily="34" charset="0"/>
-                </a:rPr>
-                <a:t>Software</a:t>
-              </a:r>
-              <a:br>
-                <a:rPr lang="en-US" sz="1000" dirty="0">
-                  <a:latin typeface="Verdana" panose="020B0604030504040204" pitchFamily="34" charset="0"/>
-                  <a:ea typeface="Verdana" panose="020B0604030504040204" pitchFamily="34" charset="0"/>
-                </a:rPr>
-              </a:br>
-              <a:r>
-                <a:rPr lang="en-US" sz="1000" dirty="0">
-                  <a:latin typeface="Verdana" panose="020B0604030504040204" pitchFamily="34" charset="0"/>
-                  <a:ea typeface="Verdana" panose="020B0604030504040204" pitchFamily="34" charset="0"/>
-                </a:rPr>
-                <a:t>Architect</a:t>
-              </a:r>
-            </a:p>
-          </p:txBody>
-        </p:sp>
-      </p:grpSp>
+      <p:pic>
+        <p:nvPicPr>
+          <p:cNvPr id="56" name="Picture 55" descr="A person sitting in a chair with a computer&#10;&#10;AI-generated content may be incorrect.">
+            <a:extLst>
+              <a:ext uri="{FF2B5EF4-FFF2-40B4-BE49-F238E27FC236}">
+                <a16:creationId xmlns:a16="http://schemas.microsoft.com/office/drawing/2014/main" id="{0C8BBDA0-D799-B613-B57C-024A25416C5D}"/>
+              </a:ext>
+            </a:extLst>
+          </p:cNvPr>
+          <p:cNvPicPr>
+            <a:picLocks noChangeAspect="1"/>
+          </p:cNvPicPr>
+          <p:nvPr/>
+        </p:nvPicPr>
+        <p:blipFill>
+          <a:blip r:embed="rId6">
+            <a:extLst>
+              <a:ext uri="{28A0092B-C50C-407E-A947-70E740481C1C}">
+                <a14:useLocalDpi xmlns:a14="http://schemas.microsoft.com/office/drawing/2010/main" val="0"/>
+              </a:ext>
+            </a:extLst>
+          </a:blip>
+          <a:stretch>
+            <a:fillRect/>
+          </a:stretch>
+        </p:blipFill>
+        <p:spPr>
+          <a:xfrm>
+            <a:off x="6079419" y="1756739"/>
+            <a:ext cx="829445" cy="1063392"/>
+          </a:xfrm>
+          <a:prstGeom prst="rect">
+            <a:avLst/>
+          </a:prstGeom>
+        </p:spPr>
+      </p:pic>
+      <p:sp>
+        <p:nvSpPr>
+          <p:cNvPr id="58" name="TextBox 57">
+            <a:extLst>
+              <a:ext uri="{FF2B5EF4-FFF2-40B4-BE49-F238E27FC236}">
+                <a16:creationId xmlns:a16="http://schemas.microsoft.com/office/drawing/2014/main" id="{642FEC64-DBF3-6005-8DA0-699CB5FB7111}"/>
+              </a:ext>
+            </a:extLst>
+          </p:cNvPr>
+          <p:cNvSpPr txBox="1"/>
+          <p:nvPr/>
+        </p:nvSpPr>
+        <p:spPr>
+          <a:xfrm>
+            <a:off x="6097544" y="2786600"/>
+            <a:ext cx="758541" cy="400110"/>
+          </a:xfrm>
+          <a:prstGeom prst="rect">
+            <a:avLst/>
+          </a:prstGeom>
+          <a:noFill/>
+        </p:spPr>
+        <p:txBody>
+          <a:bodyPr wrap="none" rtlCol="0">
+            <a:spAutoFit/>
+          </a:bodyPr>
+          <a:lstStyle/>
+          <a:p>
+            <a:pPr algn="ctr"/>
+            <a:r>
+              <a:rPr lang="en-US" sz="1000" dirty="0">
+                <a:latin typeface="Verdana" panose="020B0604030504040204" pitchFamily="34" charset="0"/>
+                <a:ea typeface="Verdana" panose="020B0604030504040204" pitchFamily="34" charset="0"/>
+              </a:rPr>
+              <a:t>Software</a:t>
+            </a:r>
+            <a:br>
+              <a:rPr lang="en-US" sz="1000" dirty="0">
+                <a:latin typeface="Verdana" panose="020B0604030504040204" pitchFamily="34" charset="0"/>
+                <a:ea typeface="Verdana" panose="020B0604030504040204" pitchFamily="34" charset="0"/>
+              </a:rPr>
+            </a:br>
+            <a:r>
+              <a:rPr lang="en-US" sz="1000" dirty="0">
+                <a:latin typeface="Verdana" panose="020B0604030504040204" pitchFamily="34" charset="0"/>
+                <a:ea typeface="Verdana" panose="020B0604030504040204" pitchFamily="34" charset="0"/>
+              </a:rPr>
+              <a:t>Architect</a:t>
+            </a:r>
+          </a:p>
+        </p:txBody>
+      </p:sp>
       <p:sp>
         <p:nvSpPr>
           <p:cNvPr id="64" name="Rectangle: Rounded Corners 63">
@@ -3879,8 +3859,8 @@
         </p:nvGrpSpPr>
         <p:grpSpPr>
           <a:xfrm>
-            <a:off x="5843617" y="3159555"/>
-            <a:ext cx="1282700" cy="1063392"/>
+            <a:off x="5843617" y="3263995"/>
+            <a:ext cx="1282700" cy="958951"/>
             <a:chOff x="5334000" y="2998842"/>
             <a:chExt cx="1282700" cy="1128658"/>
           </a:xfrm>
@@ -3988,7 +3968,7 @@
         </p:nvSpPr>
         <p:spPr>
           <a:xfrm>
-            <a:off x="6053167" y="3439333"/>
+            <a:off x="6053167" y="3500295"/>
             <a:ext cx="222250" cy="222250"/>
           </a:xfrm>
           <a:prstGeom prst="ellipse">
@@ -4050,7 +4030,7 @@
         </p:nvSpPr>
         <p:spPr>
           <a:xfrm>
-            <a:off x="6704042" y="3439333"/>
+            <a:off x="6704042" y="3500295"/>
             <a:ext cx="222250" cy="222250"/>
           </a:xfrm>
           <a:prstGeom prst="ellipse">
@@ -4648,8 +4628,8 @@
         </p:blipFill>
         <p:spPr>
           <a:xfrm>
-            <a:off x="8541015" y="1870111"/>
-            <a:ext cx="543145" cy="733722"/>
+            <a:off x="8497273" y="1870110"/>
+            <a:ext cx="630629" cy="851902"/>
           </a:xfrm>
           <a:prstGeom prst="rect">
             <a:avLst/>
@@ -4670,7 +4650,7 @@
         </p:nvSpPr>
         <p:spPr>
           <a:xfrm>
-            <a:off x="8393241" y="2698970"/>
+            <a:off x="8393241" y="2786600"/>
             <a:ext cx="838692" cy="400110"/>
           </a:xfrm>
           <a:prstGeom prst="rect">
@@ -4789,8 +4769,8 @@
         </p:nvCxnSpPr>
         <p:spPr>
           <a:xfrm>
-            <a:off x="8810767" y="3159554"/>
-            <a:ext cx="0" cy="828649"/>
+            <a:off x="8812587" y="3263995"/>
+            <a:ext cx="0" cy="724208"/>
           </a:xfrm>
           <a:prstGeom prst="straightConnector1">
             <a:avLst/>
@@ -4830,7 +4810,7 @@
         </p:nvSpPr>
         <p:spPr>
           <a:xfrm>
-            <a:off x="8699642" y="3439333"/>
+            <a:off x="8701462" y="3500295"/>
             <a:ext cx="222250" cy="222250"/>
           </a:xfrm>
           <a:prstGeom prst="ellipse">
@@ -4939,7 +4919,7 @@
         </p:nvSpPr>
         <p:spPr>
           <a:xfrm>
-            <a:off x="2258340" y="5706717"/>
+            <a:off x="2258340" y="5711699"/>
             <a:ext cx="1785827" cy="338554"/>
           </a:xfrm>
           <a:prstGeom prst="rect">
@@ -4979,7 +4959,7 @@
         </p:nvSpPr>
         <p:spPr>
           <a:xfrm>
-            <a:off x="5652759" y="5716682"/>
+            <a:off x="5652759" y="5711699"/>
             <a:ext cx="1785827" cy="338554"/>
           </a:xfrm>
           <a:prstGeom prst="rect">
@@ -5019,8 +4999,8 @@
         </p:nvSpPr>
         <p:spPr>
           <a:xfrm>
-            <a:off x="7883288" y="5722356"/>
-            <a:ext cx="1785827" cy="338554"/>
+            <a:off x="7824864" y="5711699"/>
+            <a:ext cx="1971805" cy="338554"/>
           </a:xfrm>
           <a:prstGeom prst="rect">
             <a:avLst/>
@@ -5040,7 +5020,7 @@
                 <a:ea typeface="Verdana" panose="020B0604030504040204" pitchFamily="34" charset="0"/>
                 <a:cs typeface="Arial" panose="020B0604020202020204" pitchFamily="34" charset="0"/>
               </a:rPr>
-              <a:t>Implementation</a:t>
+              <a:t>API Implementation</a:t>
             </a:r>
           </a:p>
         </p:txBody>
@@ -5275,7 +5255,7 @@
         </p:nvSpPr>
         <p:spPr>
           <a:xfrm>
-            <a:off x="8110159" y="1224820"/>
+            <a:off x="8110159" y="1258010"/>
             <a:ext cx="1332084" cy="505402"/>
           </a:xfrm>
           <a:prstGeom prst="wedgeRoundRectCallout">
@@ -5535,6 +5515,244 @@
     <p:extLst>
       <p:ext uri="{BB962C8B-B14F-4D97-AF65-F5344CB8AC3E}">
         <p14:creationId xmlns:p14="http://schemas.microsoft.com/office/powerpoint/2010/main" val="84280624"/>
+      </p:ext>
+    </p:extLst>
+  </p:cSld>
+  <p:clrMapOvr>
+    <a:masterClrMapping/>
+  </p:clrMapOvr>
+</p:sld>
+</file>
+
+<file path=ppt/slides/slide3.xml><?xml version="1.0" encoding="utf-8"?>
+<p:sld xmlns:a="http://schemas.openxmlformats.org/drawingml/2006/main" xmlns:r="http://schemas.openxmlformats.org/officeDocument/2006/relationships" xmlns:p="http://schemas.openxmlformats.org/presentationml/2006/main">
+  <p:cSld>
+    <p:spTree>
+      <p:nvGrpSpPr>
+        <p:cNvPr id="1" name=""/>
+        <p:cNvGrpSpPr/>
+        <p:nvPr/>
+      </p:nvGrpSpPr>
+      <p:grpSpPr>
+        <a:xfrm>
+          <a:off x="0" y="0"/>
+          <a:ext cx="0" cy="0"/>
+          <a:chOff x="0" y="0"/>
+          <a:chExt cx="0" cy="0"/>
+        </a:xfrm>
+      </p:grpSpPr>
+      <p:pic>
+        <p:nvPicPr>
+          <p:cNvPr id="5" name="Picture 4" descr="A diagram of a software development process&#10;&#10;AI-generated content may be incorrect.">
+            <a:extLst>
+              <a:ext uri="{FF2B5EF4-FFF2-40B4-BE49-F238E27FC236}">
+                <a16:creationId xmlns:a16="http://schemas.microsoft.com/office/drawing/2014/main" id="{11D4EEE4-FE9E-4B02-417E-66B1EF99DC99}"/>
+              </a:ext>
+            </a:extLst>
+          </p:cNvPr>
+          <p:cNvPicPr>
+            <a:picLocks noChangeAspect="1"/>
+          </p:cNvPicPr>
+          <p:nvPr/>
+        </p:nvPicPr>
+        <p:blipFill>
+          <a:blip r:embed="rId2"/>
+          <a:stretch>
+            <a:fillRect/>
+          </a:stretch>
+        </p:blipFill>
+        <p:spPr>
+          <a:xfrm>
+            <a:off x="952500" y="0"/>
+            <a:ext cx="10287000" cy="6858000"/>
+          </a:xfrm>
+          <a:prstGeom prst="rect">
+            <a:avLst/>
+          </a:prstGeom>
+        </p:spPr>
+      </p:pic>
+      <p:pic>
+        <p:nvPicPr>
+          <p:cNvPr id="7" name="Picture 6">
+            <a:extLst>
+              <a:ext uri="{FF2B5EF4-FFF2-40B4-BE49-F238E27FC236}">
+                <a16:creationId xmlns:a16="http://schemas.microsoft.com/office/drawing/2014/main" id="{060CA15A-6CFD-20CA-69A4-1B6B6B13F1D8}"/>
+              </a:ext>
+            </a:extLst>
+          </p:cNvPr>
+          <p:cNvPicPr>
+            <a:picLocks noChangeAspect="1"/>
+          </p:cNvPicPr>
+          <p:nvPr/>
+        </p:nvPicPr>
+        <p:blipFill>
+          <a:blip r:embed="rId3"/>
+          <a:stretch>
+            <a:fillRect/>
+          </a:stretch>
+        </p:blipFill>
+        <p:spPr>
+          <a:xfrm>
+            <a:off x="3461874" y="2246141"/>
+            <a:ext cx="1373362" cy="1238277"/>
+          </a:xfrm>
+          <a:prstGeom prst="rect">
+            <a:avLst/>
+          </a:prstGeom>
+        </p:spPr>
+      </p:pic>
+      <p:pic>
+        <p:nvPicPr>
+          <p:cNvPr id="10" name="Picture 9">
+            <a:extLst>
+              <a:ext uri="{FF2B5EF4-FFF2-40B4-BE49-F238E27FC236}">
+                <a16:creationId xmlns:a16="http://schemas.microsoft.com/office/drawing/2014/main" id="{00F078B5-1BBD-3331-0CEC-933B508795EC}"/>
+              </a:ext>
+            </a:extLst>
+          </p:cNvPr>
+          <p:cNvPicPr>
+            <a:picLocks noChangeAspect="1"/>
+          </p:cNvPicPr>
+          <p:nvPr/>
+        </p:nvPicPr>
+        <p:blipFill>
+          <a:blip r:embed="rId4"/>
+          <a:stretch>
+            <a:fillRect/>
+          </a:stretch>
+        </p:blipFill>
+        <p:spPr>
+          <a:xfrm>
+            <a:off x="5521149" y="3798686"/>
+            <a:ext cx="1210660" cy="914721"/>
+          </a:xfrm>
+          <a:prstGeom prst="rect">
+            <a:avLst/>
+          </a:prstGeom>
+        </p:spPr>
+      </p:pic>
+      <p:sp>
+        <p:nvSpPr>
+          <p:cNvPr id="11" name="Rectangle 10">
+            <a:extLst>
+              <a:ext uri="{FF2B5EF4-FFF2-40B4-BE49-F238E27FC236}">
+                <a16:creationId xmlns:a16="http://schemas.microsoft.com/office/drawing/2014/main" id="{B5625418-0DB9-7A7F-9735-E6018549AF23}"/>
+              </a:ext>
+            </a:extLst>
+          </p:cNvPr>
+          <p:cNvSpPr/>
+          <p:nvPr/>
+        </p:nvSpPr>
+        <p:spPr>
+          <a:xfrm>
+            <a:off x="5447607" y="3661064"/>
+            <a:ext cx="1357745" cy="318654"/>
+          </a:xfrm>
+          <a:prstGeom prst="rect">
+            <a:avLst/>
+          </a:prstGeom>
+          <a:solidFill>
+            <a:schemeClr val="bg1"/>
+          </a:solidFill>
+          <a:ln>
+            <a:noFill/>
+          </a:ln>
+        </p:spPr>
+        <p:style>
+          <a:lnRef idx="2">
+            <a:schemeClr val="accent1">
+              <a:shade val="15000"/>
+            </a:schemeClr>
+          </a:lnRef>
+          <a:fillRef idx="1">
+            <a:schemeClr val="accent1"/>
+          </a:fillRef>
+          <a:effectRef idx="0">
+            <a:schemeClr val="accent1"/>
+          </a:effectRef>
+          <a:fontRef idx="minor">
+            <a:schemeClr val="lt1"/>
+          </a:fontRef>
+        </p:style>
+        <p:txBody>
+          <a:bodyPr rtlCol="0" anchor="ctr"/>
+          <a:lstStyle/>
+          <a:p>
+            <a:pPr algn="ctr"/>
+            <a:endParaRPr lang="en-US"/>
+          </a:p>
+        </p:txBody>
+      </p:sp>
+      <p:sp>
+        <p:nvSpPr>
+          <p:cNvPr id="8" name="TextBox 7">
+            <a:extLst>
+              <a:ext uri="{FF2B5EF4-FFF2-40B4-BE49-F238E27FC236}">
+                <a16:creationId xmlns:a16="http://schemas.microsoft.com/office/drawing/2014/main" id="{F025979B-9C32-F41F-E1FD-EAA3D30AD3BB}"/>
+              </a:ext>
+            </a:extLst>
+          </p:cNvPr>
+          <p:cNvSpPr txBox="1"/>
+          <p:nvPr/>
+        </p:nvSpPr>
+        <p:spPr>
+          <a:xfrm>
+            <a:off x="5776631" y="3639588"/>
+            <a:ext cx="651140" cy="461665"/>
+          </a:xfrm>
+          <a:prstGeom prst="rect">
+            <a:avLst/>
+          </a:prstGeom>
+          <a:noFill/>
+        </p:spPr>
+        <p:txBody>
+          <a:bodyPr wrap="none" rtlCol="0">
+            <a:spAutoFit/>
+          </a:bodyPr>
+          <a:lstStyle/>
+          <a:p>
+            <a:r>
+              <a:rPr lang="en-US" sz="2400" b="1" dirty="0"/>
+              <a:t>API</a:t>
+            </a:r>
+            <a:endParaRPr lang="en-US" b="1" dirty="0"/>
+          </a:p>
+        </p:txBody>
+      </p:sp>
+      <p:pic>
+        <p:nvPicPr>
+          <p:cNvPr id="15" name="Picture 14">
+            <a:extLst>
+              <a:ext uri="{FF2B5EF4-FFF2-40B4-BE49-F238E27FC236}">
+                <a16:creationId xmlns:a16="http://schemas.microsoft.com/office/drawing/2014/main" id="{A3981107-DBD3-BCF9-8226-C54E9300FBF4}"/>
+              </a:ext>
+            </a:extLst>
+          </p:cNvPr>
+          <p:cNvPicPr>
+            <a:picLocks noChangeAspect="1"/>
+          </p:cNvPicPr>
+          <p:nvPr/>
+        </p:nvPicPr>
+        <p:blipFill>
+          <a:blip r:embed="rId5"/>
+          <a:stretch>
+            <a:fillRect/>
+          </a:stretch>
+        </p:blipFill>
+        <p:spPr>
+          <a:xfrm>
+            <a:off x="7461217" y="2169899"/>
+            <a:ext cx="1293461" cy="1392451"/>
+          </a:xfrm>
+          <a:prstGeom prst="rect">
+            <a:avLst/>
+          </a:prstGeom>
+        </p:spPr>
+      </p:pic>
+    </p:spTree>
+    <p:extLst>
+      <p:ext uri="{BB962C8B-B14F-4D97-AF65-F5344CB8AC3E}">
+        <p14:creationId xmlns:p14="http://schemas.microsoft.com/office/powerpoint/2010/main" val="4014834662"/>
       </p:ext>
     </p:extLst>
   </p:cSld>

</xml_diff>

<commit_message>
Finished API Overview write-up
</commit_message>
<xml_diff>
--- a/src/main/webapp/images/images.pptx
+++ b/src/main/webapp/images/images.pptx
@@ -330,7 +330,7 @@
           <a:p>
             <a:fld id="{2C805E82-58EB-422E-864A-536C3BC092C4}" type="datetimeFigureOut">
               <a:rPr lang="en-US" smtClean="0"/>
-              <a:t>8/29/2025</a:t>
+              <a:t>9/19/2025</a:t>
             </a:fld>
             <a:endParaRPr lang="en-US"/>
           </a:p>
@@ -2435,7 +2435,7 @@
                 <a:latin typeface="Verdana" panose="020B0604030504040204" pitchFamily="34" charset="0"/>
                 <a:ea typeface="Verdana" panose="020B0604030504040204" pitchFamily="34" charset="0"/>
               </a:rPr>
-              <a:t>What business data resources does</a:t>
+              <a:t>What business data resources should</a:t>
             </a:r>
             <a:br>
               <a:rPr lang="en-US" sz="900" dirty="0">
@@ -5324,7 +5324,7 @@
                 <a:latin typeface="Verdana" panose="020B0604030504040204" pitchFamily="34" charset="0"/>
                 <a:ea typeface="Verdana" panose="020B0604030504040204" pitchFamily="34" charset="0"/>
               </a:rPr>
-              <a:t>the endpoint stubs</a:t>
+              <a:t>the generated code</a:t>
             </a:r>
           </a:p>
         </p:txBody>

</xml_diff>

<commit_message>
Added benefits image to ppt
</commit_message>
<xml_diff>
--- a/src/main/webapp/images/images.pptx
+++ b/src/main/webapp/images/images.pptx
@@ -120,7 +120,7 @@
 <file path=ppt/revisionInfo.xml><?xml version="1.0" encoding="utf-8"?>
 <p1510:revInfo xmlns:a="http://schemas.openxmlformats.org/drawingml/2006/main" xmlns:r="http://schemas.openxmlformats.org/officeDocument/2006/relationships" xmlns:p1510="http://schemas.microsoft.com/office/powerpoint/2015/10/main">
   <p1510:revLst>
-    <p1510:client id="{93ED8897-6547-4AC5-9BAC-12404DB43CCE}" v="8" dt="2025-08-14T16:07:29.219"/>
+    <p1510:client id="{E3A915FD-CF9F-4A8A-A713-2D67325D6ED3}" v="1" dt="2025-10-14T10:08:55.056"/>
   </p1510:revLst>
 </p1510:revInfo>
 </file>
@@ -140,86 +140,6 @@
           <pc:docMk/>
           <pc:sldMk cId="3631816164" sldId="256"/>
         </pc:sldMkLst>
-        <pc:spChg chg="del">
-          <ac:chgData name="Steve Nies" userId="259007dac755d857" providerId="LiveId" clId="{93ED8897-6547-4AC5-9BAC-12404DB43CCE}" dt="2025-08-14T15:49:49.611" v="2" actId="478"/>
-          <ac:spMkLst>
-            <pc:docMk/>
-            <pc:sldMk cId="3631816164" sldId="256"/>
-            <ac:spMk id="2" creationId="{A7B9E5BA-7BAC-DD6A-6C79-7402426454FB}"/>
-          </ac:spMkLst>
-        </pc:spChg>
-        <pc:spChg chg="del">
-          <ac:chgData name="Steve Nies" userId="259007dac755d857" providerId="LiveId" clId="{93ED8897-6547-4AC5-9BAC-12404DB43CCE}" dt="2025-08-14T15:49:52.270" v="3" actId="478"/>
-          <ac:spMkLst>
-            <pc:docMk/>
-            <pc:sldMk cId="3631816164" sldId="256"/>
-            <ac:spMk id="3" creationId="{79059C54-2B87-7FE9-9748-4DF1E970B131}"/>
-          </ac:spMkLst>
-        </pc:spChg>
-        <pc:spChg chg="add mod topLvl">
-          <ac:chgData name="Steve Nies" userId="259007dac755d857" providerId="LiveId" clId="{93ED8897-6547-4AC5-9BAC-12404DB43CCE}" dt="2025-08-14T16:07:29.219" v="110" actId="165"/>
-          <ac:spMkLst>
-            <pc:docMk/>
-            <pc:sldMk cId="3631816164" sldId="256"/>
-            <ac:spMk id="4" creationId="{52132A69-4E90-6CE8-9B66-780F4DA40058}"/>
-          </ac:spMkLst>
-        </pc:spChg>
-        <pc:spChg chg="add del mod topLvl">
-          <ac:chgData name="Steve Nies" userId="259007dac755d857" providerId="LiveId" clId="{93ED8897-6547-4AC5-9BAC-12404DB43CCE}" dt="2025-08-14T16:16:46.180" v="119" actId="207"/>
-          <ac:spMkLst>
-            <pc:docMk/>
-            <pc:sldMk cId="3631816164" sldId="256"/>
-            <ac:spMk id="5" creationId="{51AE15FC-CDEC-B166-C98D-95F450AF75E2}"/>
-          </ac:spMkLst>
-        </pc:spChg>
-        <pc:spChg chg="add del mod topLvl">
-          <ac:chgData name="Steve Nies" userId="259007dac755d857" providerId="LiveId" clId="{93ED8897-6547-4AC5-9BAC-12404DB43CCE}" dt="2025-08-14T16:08:30.079" v="114" actId="207"/>
-          <ac:spMkLst>
-            <pc:docMk/>
-            <pc:sldMk cId="3631816164" sldId="256"/>
-            <ac:spMk id="6" creationId="{F606D89E-D933-A53A-6C99-9FE6E7541E77}"/>
-          </ac:spMkLst>
-        </pc:spChg>
-        <pc:spChg chg="mod">
-          <ac:chgData name="Steve Nies" userId="259007dac755d857" providerId="LiveId" clId="{93ED8897-6547-4AC5-9BAC-12404DB43CCE}" dt="2025-08-14T15:51:45.932" v="15"/>
-          <ac:spMkLst>
-            <pc:docMk/>
-            <pc:sldMk cId="3631816164" sldId="256"/>
-            <ac:spMk id="7" creationId="{AD06C1C2-5893-7032-7BB1-E1F2C9BD6D9B}"/>
-          </ac:spMkLst>
-        </pc:spChg>
-        <pc:spChg chg="add mod topLvl">
-          <ac:chgData name="Steve Nies" userId="259007dac755d857" providerId="LiveId" clId="{93ED8897-6547-4AC5-9BAC-12404DB43CCE}" dt="2025-08-14T16:21:47.053" v="130" actId="20577"/>
-          <ac:spMkLst>
-            <pc:docMk/>
-            <pc:sldMk cId="3631816164" sldId="256"/>
-            <ac:spMk id="9" creationId="{428F31FD-C1DB-29F3-66CC-5F3BA99B34FA}"/>
-          </ac:spMkLst>
-        </pc:spChg>
-        <pc:spChg chg="add mod">
-          <ac:chgData name="Steve Nies" userId="259007dac755d857" providerId="LiveId" clId="{93ED8897-6547-4AC5-9BAC-12404DB43CCE}" dt="2025-08-14T15:59:17.492" v="109" actId="14100"/>
-          <ac:spMkLst>
-            <pc:docMk/>
-            <pc:sldMk cId="3631816164" sldId="256"/>
-            <ac:spMk id="11" creationId="{66830A03-7B44-B3C4-7F1B-849A4099CEC5}"/>
-          </ac:spMkLst>
-        </pc:spChg>
-        <pc:grpChg chg="add del mod">
-          <ac:chgData name="Steve Nies" userId="259007dac755d857" providerId="LiveId" clId="{93ED8897-6547-4AC5-9BAC-12404DB43CCE}" dt="2025-08-14T15:53:37.888" v="36" actId="165"/>
-          <ac:grpSpMkLst>
-            <pc:docMk/>
-            <pc:sldMk cId="3631816164" sldId="256"/>
-            <ac:grpSpMk id="8" creationId="{3F7938E4-5CC9-C915-CAA9-E7A3570CC6B8}"/>
-          </ac:grpSpMkLst>
-        </pc:grpChg>
-        <pc:grpChg chg="add del mod">
-          <ac:chgData name="Steve Nies" userId="259007dac755d857" providerId="LiveId" clId="{93ED8897-6547-4AC5-9BAC-12404DB43CCE}" dt="2025-08-14T16:07:29.219" v="110" actId="165"/>
-          <ac:grpSpMkLst>
-            <pc:docMk/>
-            <pc:sldMk cId="3631816164" sldId="256"/>
-            <ac:grpSpMk id="10" creationId="{0734970C-407F-1DE3-F964-364C691DE02C}"/>
-          </ac:grpSpMkLst>
-        </pc:grpChg>
       </pc:sldChg>
       <pc:sldChg chg="new del">
         <pc:chgData name="Steve Nies" userId="259007dac755d857" providerId="LiveId" clId="{93ED8897-6547-4AC5-9BAC-12404DB43CCE}" dt="2025-08-14T15:49:54.857" v="4" actId="47"/>
@@ -243,6 +163,78 @@
           </pc:sldLayoutMkLst>
         </pc:sldLayoutChg>
       </pc:sldMasterChg>
+    </pc:docChg>
+  </pc:docChgLst>
+  <pc:docChgLst>
+    <pc:chgData name="Steve Nies" userId="259007dac755d857" providerId="LiveId" clId="{F971AF1D-A3EB-491A-A106-0CE6195C8123}"/>
+    <pc:docChg chg="modSld">
+      <pc:chgData name="Steve Nies" userId="259007dac755d857" providerId="LiveId" clId="{F971AF1D-A3EB-491A-A106-0CE6195C8123}" dt="2025-10-14T10:09:01.232" v="1" actId="1076"/>
+      <pc:docMkLst>
+        <pc:docMk/>
+      </pc:docMkLst>
+      <pc:sldChg chg="addSp modSp mod">
+        <pc:chgData name="Steve Nies" userId="259007dac755d857" providerId="LiveId" clId="{F971AF1D-A3EB-491A-A106-0CE6195C8123}" dt="2025-10-14T10:09:01.232" v="1" actId="1076"/>
+        <pc:sldMkLst>
+          <pc:docMk/>
+          <pc:sldMk cId="3991939631" sldId="257"/>
+        </pc:sldMkLst>
+        <pc:spChg chg="mod">
+          <ac:chgData name="Steve Nies" userId="259007dac755d857" providerId="LiveId" clId="{F971AF1D-A3EB-491A-A106-0CE6195C8123}" dt="2025-10-14T10:08:55.056" v="0"/>
+          <ac:spMkLst>
+            <pc:docMk/>
+            <pc:sldMk cId="3991939631" sldId="257"/>
+            <ac:spMk id="4" creationId="{B9697C2F-5F0F-5A9A-E8F5-45566EB9D2B7}"/>
+          </ac:spMkLst>
+        </pc:spChg>
+        <pc:spChg chg="mod">
+          <ac:chgData name="Steve Nies" userId="259007dac755d857" providerId="LiveId" clId="{F971AF1D-A3EB-491A-A106-0CE6195C8123}" dt="2025-10-14T10:08:55.056" v="0"/>
+          <ac:spMkLst>
+            <pc:docMk/>
+            <pc:sldMk cId="3991939631" sldId="257"/>
+            <ac:spMk id="8" creationId="{AE717F37-D7F9-8CAA-D758-95A9363C18D7}"/>
+          </ac:spMkLst>
+        </pc:spChg>
+        <pc:spChg chg="mod">
+          <ac:chgData name="Steve Nies" userId="259007dac755d857" providerId="LiveId" clId="{F971AF1D-A3EB-491A-A106-0CE6195C8123}" dt="2025-10-14T10:08:55.056" v="0"/>
+          <ac:spMkLst>
+            <pc:docMk/>
+            <pc:sldMk cId="3991939631" sldId="257"/>
+            <ac:spMk id="12" creationId="{4371EDB9-66C5-9E90-CF35-D792A8FB262C}"/>
+          </ac:spMkLst>
+        </pc:spChg>
+        <pc:spChg chg="mod">
+          <ac:chgData name="Steve Nies" userId="259007dac755d857" providerId="LiveId" clId="{F971AF1D-A3EB-491A-A106-0CE6195C8123}" dt="2025-10-14T10:08:55.056" v="0"/>
+          <ac:spMkLst>
+            <pc:docMk/>
+            <pc:sldMk cId="3991939631" sldId="257"/>
+            <ac:spMk id="28" creationId="{4EA254CA-1891-7143-2D82-816C89C816E8}"/>
+          </ac:spMkLst>
+        </pc:spChg>
+        <pc:spChg chg="mod">
+          <ac:chgData name="Steve Nies" userId="259007dac755d857" providerId="LiveId" clId="{F971AF1D-A3EB-491A-A106-0CE6195C8123}" dt="2025-10-14T10:08:55.056" v="0"/>
+          <ac:spMkLst>
+            <pc:docMk/>
+            <pc:sldMk cId="3991939631" sldId="257"/>
+            <ac:spMk id="30" creationId="{D48A8207-BE7E-5C23-55D2-161C4684F109}"/>
+          </ac:spMkLst>
+        </pc:spChg>
+        <pc:spChg chg="mod">
+          <ac:chgData name="Steve Nies" userId="259007dac755d857" providerId="LiveId" clId="{F971AF1D-A3EB-491A-A106-0CE6195C8123}" dt="2025-10-14T10:08:55.056" v="0"/>
+          <ac:spMkLst>
+            <pc:docMk/>
+            <pc:sldMk cId="3991939631" sldId="257"/>
+            <ac:spMk id="31" creationId="{4343AC8C-661C-66A4-F8CB-884F188A1359}"/>
+          </ac:spMkLst>
+        </pc:spChg>
+        <pc:grpChg chg="add mod">
+          <ac:chgData name="Steve Nies" userId="259007dac755d857" providerId="LiveId" clId="{F971AF1D-A3EB-491A-A106-0CE6195C8123}" dt="2025-10-14T10:09:01.232" v="1" actId="1076"/>
+          <ac:grpSpMkLst>
+            <pc:docMk/>
+            <pc:sldMk cId="3991939631" sldId="257"/>
+            <ac:grpSpMk id="2" creationId="{E375042D-3F9C-AB05-9300-6B1F10A6436D}"/>
+          </ac:grpSpMkLst>
+        </pc:grpChg>
+      </pc:sldChg>
     </pc:docChg>
   </pc:docChgLst>
 </pc:chgInfo>
@@ -330,7 +322,7 @@
           <a:p>
             <a:fld id="{2C805E82-58EB-422E-864A-536C3BC092C4}" type="datetimeFigureOut">
               <a:rPr lang="en-US" smtClean="0"/>
-              <a:t>9/19/2025</a:t>
+              <a:t>10/14/2025</a:t>
             </a:fld>
             <a:endParaRPr lang="en-US"/>
           </a:p>
@@ -1979,6 +1971,324 @@
           </a:p>
         </p:txBody>
       </p:sp>
+      <p:grpSp>
+        <p:nvGrpSpPr>
+          <p:cNvPr id="2" name="Group 1">
+            <a:extLst>
+              <a:ext uri="{FF2B5EF4-FFF2-40B4-BE49-F238E27FC236}">
+                <a16:creationId xmlns:a16="http://schemas.microsoft.com/office/drawing/2014/main" id="{E375042D-3F9C-AB05-9300-6B1F10A6436D}"/>
+              </a:ext>
+            </a:extLst>
+          </p:cNvPr>
+          <p:cNvGrpSpPr/>
+          <p:nvPr/>
+        </p:nvGrpSpPr>
+        <p:grpSpPr>
+          <a:xfrm>
+            <a:off x="4907959" y="3634203"/>
+            <a:ext cx="2650642" cy="1853486"/>
+            <a:chOff x="900921" y="1936638"/>
+            <a:chExt cx="2650642" cy="1853486"/>
+          </a:xfrm>
+        </p:grpSpPr>
+        <p:sp>
+          <p:nvSpPr>
+            <p:cNvPr id="4" name="Arrow: Down 3">
+              <a:extLst>
+                <a:ext uri="{FF2B5EF4-FFF2-40B4-BE49-F238E27FC236}">
+                  <a16:creationId xmlns:a16="http://schemas.microsoft.com/office/drawing/2014/main" id="{B9697C2F-5F0F-5A9A-E8F5-45566EB9D2B7}"/>
+                </a:ext>
+              </a:extLst>
+            </p:cNvPr>
+            <p:cNvSpPr/>
+            <p:nvPr/>
+          </p:nvSpPr>
+          <p:spPr>
+            <a:xfrm flipV="1">
+              <a:off x="1173967" y="2325757"/>
+              <a:ext cx="445911" cy="1464366"/>
+            </a:xfrm>
+            <a:prstGeom prst="downArrow">
+              <a:avLst/>
+            </a:prstGeom>
+            <a:gradFill>
+              <a:gsLst>
+                <a:gs pos="0">
+                  <a:schemeClr val="accent1">
+                    <a:lumMod val="5000"/>
+                    <a:lumOff val="95000"/>
+                  </a:schemeClr>
+                </a:gs>
+                <a:gs pos="74000">
+                  <a:schemeClr val="accent1">
+                    <a:lumMod val="45000"/>
+                    <a:lumOff val="55000"/>
+                  </a:schemeClr>
+                </a:gs>
+                <a:gs pos="83000">
+                  <a:schemeClr val="accent1">
+                    <a:lumMod val="45000"/>
+                    <a:lumOff val="55000"/>
+                  </a:schemeClr>
+                </a:gs>
+                <a:gs pos="100000">
+                  <a:schemeClr val="accent1">
+                    <a:lumMod val="30000"/>
+                    <a:lumOff val="70000"/>
+                  </a:schemeClr>
+                </a:gs>
+              </a:gsLst>
+              <a:lin ang="5400000" scaled="1"/>
+            </a:gradFill>
+          </p:spPr>
+          <p:style>
+            <a:lnRef idx="2">
+              <a:schemeClr val="accent1">
+                <a:shade val="15000"/>
+              </a:schemeClr>
+            </a:lnRef>
+            <a:fillRef idx="1">
+              <a:schemeClr val="accent1"/>
+            </a:fillRef>
+            <a:effectRef idx="0">
+              <a:schemeClr val="accent1"/>
+            </a:effectRef>
+            <a:fontRef idx="minor">
+              <a:schemeClr val="lt1"/>
+            </a:fontRef>
+          </p:style>
+          <p:txBody>
+            <a:bodyPr rtlCol="0" anchor="ctr"/>
+            <a:lstStyle/>
+            <a:p>
+              <a:pPr algn="ctr"/>
+              <a:endParaRPr lang="en-US"/>
+            </a:p>
+          </p:txBody>
+        </p:sp>
+        <p:sp>
+          <p:nvSpPr>
+            <p:cNvPr id="8" name="TextBox 7">
+              <a:extLst>
+                <a:ext uri="{FF2B5EF4-FFF2-40B4-BE49-F238E27FC236}">
+                  <a16:creationId xmlns:a16="http://schemas.microsoft.com/office/drawing/2014/main" id="{AE717F37-D7F9-8CAA-D758-95A9363C18D7}"/>
+                </a:ext>
+              </a:extLst>
+            </p:cNvPr>
+            <p:cNvSpPr txBox="1"/>
+            <p:nvPr/>
+          </p:nvSpPr>
+          <p:spPr>
+            <a:xfrm>
+              <a:off x="900921" y="1936638"/>
+              <a:ext cx="992003" cy="281966"/>
+            </a:xfrm>
+            <a:prstGeom prst="rect">
+              <a:avLst/>
+            </a:prstGeom>
+            <a:noFill/>
+          </p:spPr>
+          <p:txBody>
+            <a:bodyPr wrap="none" rtlCol="0">
+              <a:spAutoFit/>
+            </a:bodyPr>
+            <a:lstStyle/>
+            <a:p>
+              <a:r>
+                <a:rPr lang="en-US" sz="1600" b="1" dirty="0"/>
+                <a:t>QUALITY</a:t>
+              </a:r>
+            </a:p>
+          </p:txBody>
+        </p:sp>
+        <p:sp>
+          <p:nvSpPr>
+            <p:cNvPr id="12" name="Arrow: Down 11">
+              <a:extLst>
+                <a:ext uri="{FF2B5EF4-FFF2-40B4-BE49-F238E27FC236}">
+                  <a16:creationId xmlns:a16="http://schemas.microsoft.com/office/drawing/2014/main" id="{4371EDB9-66C5-9E90-CF35-D792A8FB262C}"/>
+                </a:ext>
+              </a:extLst>
+            </p:cNvPr>
+            <p:cNvSpPr/>
+            <p:nvPr/>
+          </p:nvSpPr>
+          <p:spPr>
+            <a:xfrm flipV="1">
+              <a:off x="2095277" y="2325757"/>
+              <a:ext cx="445911" cy="1464367"/>
+            </a:xfrm>
+            <a:prstGeom prst="downArrow">
+              <a:avLst/>
+            </a:prstGeom>
+            <a:gradFill>
+              <a:gsLst>
+                <a:gs pos="0">
+                  <a:schemeClr val="bg1"/>
+                </a:gs>
+                <a:gs pos="100000">
+                  <a:schemeClr val="accent3">
+                    <a:lumMod val="60000"/>
+                    <a:lumOff val="40000"/>
+                  </a:schemeClr>
+                </a:gs>
+              </a:gsLst>
+              <a:lin ang="5400000" scaled="1"/>
+            </a:gradFill>
+          </p:spPr>
+          <p:style>
+            <a:lnRef idx="2">
+              <a:schemeClr val="accent1">
+                <a:shade val="15000"/>
+              </a:schemeClr>
+            </a:lnRef>
+            <a:fillRef idx="1">
+              <a:schemeClr val="accent1"/>
+            </a:fillRef>
+            <a:effectRef idx="0">
+              <a:schemeClr val="accent1"/>
+            </a:effectRef>
+            <a:fontRef idx="minor">
+              <a:schemeClr val="lt1"/>
+            </a:fontRef>
+          </p:style>
+          <p:txBody>
+            <a:bodyPr rtlCol="0" anchor="ctr"/>
+            <a:lstStyle/>
+            <a:p>
+              <a:pPr algn="ctr"/>
+              <a:endParaRPr lang="en-US"/>
+            </a:p>
+          </p:txBody>
+        </p:sp>
+        <p:sp>
+          <p:nvSpPr>
+            <p:cNvPr id="28" name="TextBox 27">
+              <a:extLst>
+                <a:ext uri="{FF2B5EF4-FFF2-40B4-BE49-F238E27FC236}">
+                  <a16:creationId xmlns:a16="http://schemas.microsoft.com/office/drawing/2014/main" id="{4EA254CA-1891-7143-2D82-816C89C816E8}"/>
+                </a:ext>
+              </a:extLst>
+            </p:cNvPr>
+            <p:cNvSpPr txBox="1"/>
+            <p:nvPr/>
+          </p:nvSpPr>
+          <p:spPr>
+            <a:xfrm>
+              <a:off x="1911711" y="1936638"/>
+              <a:ext cx="813043" cy="290827"/>
+            </a:xfrm>
+            <a:prstGeom prst="rect">
+              <a:avLst/>
+            </a:prstGeom>
+            <a:noFill/>
+          </p:spPr>
+          <p:txBody>
+            <a:bodyPr wrap="none" rtlCol="0">
+              <a:spAutoFit/>
+            </a:bodyPr>
+            <a:lstStyle/>
+            <a:p>
+              <a:r>
+                <a:rPr lang="en-US" sz="1600" b="1" dirty="0"/>
+                <a:t>SPEED</a:t>
+              </a:r>
+            </a:p>
+          </p:txBody>
+        </p:sp>
+        <p:sp>
+          <p:nvSpPr>
+            <p:cNvPr id="30" name="Arrow: Down 29">
+              <a:extLst>
+                <a:ext uri="{FF2B5EF4-FFF2-40B4-BE49-F238E27FC236}">
+                  <a16:creationId xmlns:a16="http://schemas.microsoft.com/office/drawing/2014/main" id="{D48A8207-BE7E-5C23-55D2-161C4684F109}"/>
+                </a:ext>
+              </a:extLst>
+            </p:cNvPr>
+            <p:cNvSpPr/>
+            <p:nvPr/>
+          </p:nvSpPr>
+          <p:spPr>
+            <a:xfrm>
+              <a:off x="2977197" y="2334826"/>
+              <a:ext cx="445911" cy="1455297"/>
+            </a:xfrm>
+            <a:prstGeom prst="downArrow">
+              <a:avLst/>
+            </a:prstGeom>
+            <a:gradFill>
+              <a:gsLst>
+                <a:gs pos="0">
+                  <a:srgbClr val="FFFF00"/>
+                </a:gs>
+                <a:gs pos="100000">
+                  <a:schemeClr val="bg1"/>
+                </a:gs>
+              </a:gsLst>
+              <a:lin ang="5400000" scaled="1"/>
+            </a:gradFill>
+          </p:spPr>
+          <p:style>
+            <a:lnRef idx="2">
+              <a:schemeClr val="accent1">
+                <a:shade val="15000"/>
+              </a:schemeClr>
+            </a:lnRef>
+            <a:fillRef idx="1">
+              <a:schemeClr val="accent1"/>
+            </a:fillRef>
+            <a:effectRef idx="0">
+              <a:schemeClr val="accent1"/>
+            </a:effectRef>
+            <a:fontRef idx="minor">
+              <a:schemeClr val="lt1"/>
+            </a:fontRef>
+          </p:style>
+          <p:txBody>
+            <a:bodyPr rtlCol="0" anchor="ctr"/>
+            <a:lstStyle/>
+            <a:p>
+              <a:pPr algn="ctr"/>
+              <a:endParaRPr lang="en-US"/>
+            </a:p>
+          </p:txBody>
+        </p:sp>
+        <p:sp>
+          <p:nvSpPr>
+            <p:cNvPr id="31" name="TextBox 30">
+              <a:extLst>
+                <a:ext uri="{FF2B5EF4-FFF2-40B4-BE49-F238E27FC236}">
+                  <a16:creationId xmlns:a16="http://schemas.microsoft.com/office/drawing/2014/main" id="{4343AC8C-661C-66A4-F8CB-884F188A1359}"/>
+                </a:ext>
+              </a:extLst>
+            </p:cNvPr>
+            <p:cNvSpPr txBox="1"/>
+            <p:nvPr/>
+          </p:nvSpPr>
+          <p:spPr>
+            <a:xfrm>
+              <a:off x="2848742" y="1936638"/>
+              <a:ext cx="702821" cy="338554"/>
+            </a:xfrm>
+            <a:prstGeom prst="rect">
+              <a:avLst/>
+            </a:prstGeom>
+            <a:noFill/>
+          </p:spPr>
+          <p:txBody>
+            <a:bodyPr wrap="none" rtlCol="0">
+              <a:spAutoFit/>
+            </a:bodyPr>
+            <a:lstStyle/>
+            <a:p>
+              <a:r>
+                <a:rPr lang="en-US" sz="1600" b="1" dirty="0"/>
+                <a:t>COST</a:t>
+              </a:r>
+            </a:p>
+          </p:txBody>
+        </p:sp>
+      </p:grpSp>
     </p:spTree>
     <p:extLst>
       <p:ext uri="{BB962C8B-B14F-4D97-AF65-F5344CB8AC3E}">

</xml_diff>